<commit_message>
E2E deck: show TC-23-001 and TC-23-003 steps as written in the suite, one shared step file
</commit_message>
<xml_diff>
--- a/presentations/RoadSide_E2E_Journeys.pptx
+++ b/presentations/RoadSide_E2E_Journeys.pptx
@@ -118,7 +118,7 @@
   <p:extLst>
     <p:ext uri="{521415D9-36F7-43E2-AB2F-B90AF26B5E84}">
       <p14:sectionLst xmlns:p14="http://schemas.microsoft.com/office/powerpoint/2010/main">
-        <p14:section name="Where we are" id="{11fa2b05-46bf-91c5-04a1-29a3851c37de}">
+        <p14:section name="Where we are" id="{3c5279c5-f5ae-2834-9dbc-2479c2361fbf}">
           <p14:sldIdLst>
             <p14:sldId id="256"/>
             <p14:sldId id="257"/>
@@ -126,7 +126,7 @@
             <p14:sldId id="259"/>
           </p14:sldIdLst>
         </p14:section>
-        <p14:section name="The two journeys" id="{c97bffc5-7962-e982-0a8b-2c409d03ab28}">
+        <p14:section name="The two journeys" id="{da909712-6e92-d557-dbf0-3df4c52c987d}">
           <p14:sldIdLst>
             <p14:sldId id="260"/>
             <p14:sldId id="261"/>
@@ -136,7 +136,7 @@
             <p14:sldId id="265"/>
           </p14:sldIdLst>
         </p14:section>
-        <p14:section name="Demo and next" id="{0229cb46-f735-ced1-987f-8dedba8e326e}">
+        <p14:section name="Demo and next" id="{97f6995c-a9bd-1f5e-5b56-274b58c80fb5}">
           <p14:sldIdLst>
             <p14:sldId id="266"/>
             <p14:sldId id="267"/>
@@ -634,7 +634,7 @@
           <a:p>
             <a:r>
               <a:rPr lang="en-US" dirty="0"/>
-              <a:t>Same idea as E2E-01: when this journey passes, these 12 cases are proven in one run.</a:t>
+              <a:t>Same format as TC-23-001: the test case as written in the suite, step by step.</a:t>
             </a:r>
             <a:endParaRPr lang="en-US" dirty="0"/>
           </a:p>
@@ -1338,7 +1338,7 @@
           <a:p>
             <a:r>
               <a:rPr lang="en-US" dirty="0"/>
-              <a:t>This is the traceability: when E2E-01 passes, these 25 cases across both suites are proven by a single run.</a:t>
+              <a:t>This is the test case exactly as it is in the suite. Each row is one step of the automated run, and each step is a caption in the video.</a:t>
             </a:r>
             <a:endParaRPr lang="en-US" dirty="0"/>
           </a:p>
@@ -2417,7 +2417,7 @@
                   <a:schemeClr val="tx1"/>
                 </a:solidFill>
               </a:rPr>
-              <a:t>E2E-02: each step is mapped to the cases it proves</a:t>
+              <a:t>TC-23-003 in the RoadSide web suite: steps and expected results</a:t>
             </a:r>
             <a:endParaRPr lang="en-US" sz="2600" dirty="0"/>
           </a:p>
@@ -2446,12 +2446,10 @@
             <a:tbl>
               <a:tblPr/>
               <a:tblGrid>
-                <a:gridCol w="411480"/>
-                <a:gridCol w="685800"/>
-                <a:gridCol w="3108960"/>
-                <a:gridCol w="2743200"/>
-                <a:gridCol w="2468880"/>
-                <a:gridCol w="1673352"/>
+                <a:gridCol w="502920"/>
+                <a:gridCol w="731520"/>
+                <a:gridCol w="5669280"/>
+                <a:gridCol w="4187952"/>
               </a:tblGrid>
               <a:tr h="0">
                 <a:tc>
@@ -2463,14 +2461,14 @@
                         <a:buNone/>
                       </a:pPr>
                       <a:r>
-                        <a:rPr lang="en-US" sz="1150" b="1" dirty="0">
+                        <a:rPr lang="en-US" sz="1200" b="1" dirty="0">
                           <a:solidFill>
                             <a:schemeClr val="bg1"/>
                           </a:solidFill>
                         </a:rPr>
-                        <a:t>#</a:t>
+                        <a:t>Step</a:t>
                       </a:r>
-                      <a:endParaRPr lang="en-US" sz="1150" dirty="0"/>
+                      <a:endParaRPr lang="en-US" sz="1200" dirty="0"/>
                     </a:p>
                   </a:txBody>
                   <a:tcPr marL="45720" marR="45720" marT="45720" marB="45720">
@@ -2524,14 +2522,14 @@
                         <a:buNone/>
                       </a:pPr>
                       <a:r>
-                        <a:rPr lang="en-US" sz="1150" b="1" dirty="0">
+                        <a:rPr lang="en-US" sz="1200" b="1" dirty="0">
                           <a:solidFill>
                             <a:schemeClr val="bg1"/>
                           </a:solidFill>
                         </a:rPr>
                         <a:t>Side</a:t>
                       </a:r>
-                      <a:endParaRPr lang="en-US" sz="1150" dirty="0"/>
+                      <a:endParaRPr lang="en-US" sz="1200" dirty="0"/>
                     </a:p>
                   </a:txBody>
                   <a:tcPr marL="45720" marR="45720" marT="45720" marB="45720">
@@ -2585,14 +2583,14 @@
                         <a:buNone/>
                       </a:pPr>
                       <a:r>
-                        <a:rPr lang="en-US" sz="1150" b="1" dirty="0">
+                        <a:rPr lang="en-US" sz="1200" b="1" dirty="0">
                           <a:solidFill>
                             <a:schemeClr val="bg1"/>
                           </a:solidFill>
                         </a:rPr>
-                        <a:t>Step</a:t>
+                        <a:t>Action</a:t>
                       </a:r>
-                      <a:endParaRPr lang="en-US" sz="1150" dirty="0"/>
+                      <a:endParaRPr lang="en-US" sz="1200" dirty="0"/>
                     </a:p>
                   </a:txBody>
                   <a:tcPr marL="45720" marR="45720" marT="45720" marB="45720">
@@ -2646,14 +2644,14 @@
                         <a:buNone/>
                       </a:pPr>
                       <a:r>
-                        <a:rPr lang="en-US" sz="1150" b="1" dirty="0">
+                        <a:rPr lang="en-US" sz="1200" b="1" dirty="0">
                           <a:solidFill>
                             <a:schemeClr val="bg1"/>
                           </a:solidFill>
                         </a:rPr>
-                        <a:t>Checked</a:t>
+                        <a:t>Expected result</a:t>
                       </a:r>
-                      <a:endParaRPr lang="en-US" sz="1150" dirty="0"/>
+                      <a:endParaRPr lang="en-US" sz="1200" dirty="0"/>
                     </a:p>
                   </a:txBody>
                   <a:tcPr marL="45720" marR="45720" marT="45720" marB="45720">
@@ -2695,128 +2693,6 @@
                     </a:lnB>
                     <a:solidFill>
                       <a:schemeClr val="tx2"/>
-                    </a:solidFill>
-                  </a:tcPr>
-                </a:tc>
-                <a:tc>
-                  <a:txBody>
-                    <a:bodyPr/>
-                    <a:lstStyle/>
-                    <a:p>
-                      <a:pPr indent="0" marL="0">
-                        <a:buNone/>
-                      </a:pPr>
-                      <a:r>
-                        <a:rPr lang="en-US" sz="1150" b="1" dirty="0">
-                          <a:solidFill>
-                            <a:schemeClr val="bg1"/>
-                          </a:solidFill>
-                        </a:rPr>
-                        <a:t>Web suite cases</a:t>
-                      </a:r>
-                      <a:endParaRPr lang="en-US" sz="1150" dirty="0"/>
-                    </a:p>
-                  </a:txBody>
-                  <a:tcPr marL="45720" marR="45720" marT="45720" marB="45720">
-                    <a:lnL w="6350" cap="flat" cmpd="sng" algn="ctr">
-                      <a:solidFill>
-                        <a:srgbClr val="D9D9DE"/>
-                      </a:solidFill>
-                      <a:prstDash val="solid"/>
-                      <a:round/>
-                      <a:headEnd type="none" w="med" len="med"/>
-                      <a:tailEnd type="none" w="med" len="med"/>
-                    </a:lnL>
-                    <a:lnR w="6350" cap="flat" cmpd="sng" algn="ctr">
-                      <a:solidFill>
-                        <a:srgbClr val="D9D9DE"/>
-                      </a:solidFill>
-                      <a:prstDash val="solid"/>
-                      <a:round/>
-                      <a:headEnd type="none" w="med" len="med"/>
-                      <a:tailEnd type="none" w="med" len="med"/>
-                    </a:lnR>
-                    <a:lnT w="6350" cap="flat" cmpd="sng" algn="ctr">
-                      <a:solidFill>
-                        <a:srgbClr val="D9D9DE"/>
-                      </a:solidFill>
-                      <a:prstDash val="solid"/>
-                      <a:round/>
-                      <a:headEnd type="none" w="med" len="med"/>
-                      <a:tailEnd type="none" w="med" len="med"/>
-                    </a:lnT>
-                    <a:lnB w="6350" cap="flat" cmpd="sng" algn="ctr">
-                      <a:solidFill>
-                        <a:srgbClr val="D9D9DE"/>
-                      </a:solidFill>
-                      <a:prstDash val="solid"/>
-                      <a:round/>
-                      <a:headEnd type="none" w="med" len="med"/>
-                      <a:tailEnd type="none" w="med" len="med"/>
-                    </a:lnB>
-                    <a:solidFill>
-                      <a:schemeClr val="accent1"/>
-                    </a:solidFill>
-                  </a:tcPr>
-                </a:tc>
-                <a:tc>
-                  <a:txBody>
-                    <a:bodyPr/>
-                    <a:lstStyle/>
-                    <a:p>
-                      <a:pPr indent="0" marL="0">
-                        <a:buNone/>
-                      </a:pPr>
-                      <a:r>
-                        <a:rPr lang="en-US" sz="1150" b="1" dirty="0">
-                          <a:solidFill>
-                            <a:schemeClr val="bg1"/>
-                          </a:solidFill>
-                        </a:rPr>
-                        <a:t>App suite cases</a:t>
-                      </a:r>
-                      <a:endParaRPr lang="en-US" sz="1150" dirty="0"/>
-                    </a:p>
-                  </a:txBody>
-                  <a:tcPr marL="45720" marR="45720" marT="45720" marB="45720">
-                    <a:lnL w="6350" cap="flat" cmpd="sng" algn="ctr">
-                      <a:solidFill>
-                        <a:srgbClr val="D9D9DE"/>
-                      </a:solidFill>
-                      <a:prstDash val="solid"/>
-                      <a:round/>
-                      <a:headEnd type="none" w="med" len="med"/>
-                      <a:tailEnd type="none" w="med" len="med"/>
-                    </a:lnL>
-                    <a:lnR w="6350" cap="flat" cmpd="sng" algn="ctr">
-                      <a:solidFill>
-                        <a:srgbClr val="D9D9DE"/>
-                      </a:solidFill>
-                      <a:prstDash val="solid"/>
-                      <a:round/>
-                      <a:headEnd type="none" w="med" len="med"/>
-                      <a:tailEnd type="none" w="med" len="med"/>
-                    </a:lnR>
-                    <a:lnT w="6350" cap="flat" cmpd="sng" algn="ctr">
-                      <a:solidFill>
-                        <a:srgbClr val="D9D9DE"/>
-                      </a:solidFill>
-                      <a:prstDash val="solid"/>
-                      <a:round/>
-                      <a:headEnd type="none" w="med" len="med"/>
-                      <a:tailEnd type="none" w="med" len="med"/>
-                    </a:lnT>
-                    <a:lnB w="6350" cap="flat" cmpd="sng" algn="ctr">
-                      <a:solidFill>
-                        <a:srgbClr val="D9D9DE"/>
-                      </a:solidFill>
-                      <a:prstDash val="solid"/>
-                      <a:round/>
-                      <a:headEnd type="none" w="med" len="med"/>
-                      <a:tailEnd type="none" w="med" len="med"/>
-                    </a:lnB>
-                    <a:solidFill>
-                      <a:schemeClr val="accent2"/>
                     </a:solidFill>
                   </a:tcPr>
                 </a:tc>
@@ -2831,14 +2707,14 @@
                         <a:buNone/>
                       </a:pPr>
                       <a:r>
-                        <a:rPr lang="en-US" sz="1100" b="1" dirty="0">
+                        <a:rPr lang="en-US" sz="1150" b="1" dirty="0">
                           <a:solidFill>
                             <a:schemeClr val="tx1"/>
                           </a:solidFill>
                         </a:rPr>
                         <a:t>1</a:t>
                       </a:r>
-                      <a:endParaRPr lang="en-US" sz="1100" dirty="0"/>
+                      <a:endParaRPr lang="en-US" sz="1150" dirty="0"/>
                     </a:p>
                   </a:txBody>
                   <a:tcPr marL="45720" marR="45720" marT="45720" marB="45720">
@@ -2892,14 +2768,14 @@
                         <a:buNone/>
                       </a:pPr>
                       <a:r>
-                        <a:rPr lang="en-US" sz="1100" b="1" dirty="0">
+                        <a:rPr lang="en-US" sz="1150" b="1" dirty="0">
                           <a:solidFill>
                             <a:schemeClr val="accent2"/>
                           </a:solidFill>
                         </a:rPr>
                         <a:t>App</a:t>
                       </a:r>
-                      <a:endParaRPr lang="en-US" sz="1100" dirty="0"/>
+                      <a:endParaRPr lang="en-US" sz="1150" dirty="0"/>
                     </a:p>
                   </a:txBody>
                   <a:tcPr marL="45720" marR="45720" marT="45720" marB="45720">
@@ -2953,14 +2829,14 @@
                         <a:buNone/>
                       </a:pPr>
                       <a:r>
-                        <a:rPr lang="en-US" sz="1100" dirty="0">
+                        <a:rPr lang="en-US" sz="1150" dirty="0">
                           <a:solidFill>
                             <a:schemeClr val="tx1"/>
                           </a:solidFill>
                         </a:rPr>
-                        <a:t>Driver signed in, on the dashboard</a:t>
+                        <a:t>Driver is signed in, on the dashboard</a:t>
                       </a:r>
-                      <a:endParaRPr lang="en-US" sz="1100" dirty="0"/>
+                      <a:endParaRPr lang="en-US" sz="1150" dirty="0"/>
                     </a:p>
                   </a:txBody>
                   <a:tcPr marL="45720" marR="45720" marT="45720" marB="45720">
@@ -3014,128 +2890,14 @@
                         <a:buNone/>
                       </a:pPr>
                       <a:r>
-                        <a:rPr lang="en-US" sz="1100" dirty="0">
+                        <a:rPr lang="en-US" sz="1150" dirty="0">
                           <a:solidFill>
                             <a:schemeClr val="tx1"/>
                           </a:solidFill>
                         </a:rPr>
-                        <a:t>Dashboard shown</a:t>
+                        <a:t>Dashboard is shown</a:t>
                       </a:r>
-                      <a:endParaRPr lang="en-US" sz="1100" dirty="0"/>
-                    </a:p>
-                  </a:txBody>
-                  <a:tcPr marL="45720" marR="45720" marT="45720" marB="45720">
-                    <a:lnL w="6350" cap="flat" cmpd="sng" algn="ctr">
-                      <a:solidFill>
-                        <a:srgbClr val="D9D9DE"/>
-                      </a:solidFill>
-                      <a:prstDash val="solid"/>
-                      <a:round/>
-                      <a:headEnd type="none" w="med" len="med"/>
-                      <a:tailEnd type="none" w="med" len="med"/>
-                    </a:lnL>
-                    <a:lnR w="6350" cap="flat" cmpd="sng" algn="ctr">
-                      <a:solidFill>
-                        <a:srgbClr val="D9D9DE"/>
-                      </a:solidFill>
-                      <a:prstDash val="solid"/>
-                      <a:round/>
-                      <a:headEnd type="none" w="med" len="med"/>
-                      <a:tailEnd type="none" w="med" len="med"/>
-                    </a:lnR>
-                    <a:lnT w="6350" cap="flat" cmpd="sng" algn="ctr">
-                      <a:solidFill>
-                        <a:srgbClr val="D9D9DE"/>
-                      </a:solidFill>
-                      <a:prstDash val="solid"/>
-                      <a:round/>
-                      <a:headEnd type="none" w="med" len="med"/>
-                      <a:tailEnd type="none" w="med" len="med"/>
-                    </a:lnT>
-                    <a:lnB w="6350" cap="flat" cmpd="sng" algn="ctr">
-                      <a:solidFill>
-                        <a:srgbClr val="D9D9DE"/>
-                      </a:solidFill>
-                      <a:prstDash val="solid"/>
-                      <a:round/>
-                      <a:headEnd type="none" w="med" len="med"/>
-                      <a:tailEnd type="none" w="med" len="med"/>
-                    </a:lnB>
-                    <a:solidFill>
-                      <a:schemeClr val="bg2"/>
-                    </a:solidFill>
-                  </a:tcPr>
-                </a:tc>
-                <a:tc>
-                  <a:txBody>
-                    <a:bodyPr/>
-                    <a:lstStyle/>
-                    <a:p>
-                      <a:pPr indent="0" marL="0">
-                        <a:buNone/>
-                      </a:pPr>
-                      <a:endParaRPr lang="en-US" sz="1100" dirty="0"/>
-                    </a:p>
-                  </a:txBody>
-                  <a:tcPr marL="45720" marR="45720" marT="45720" marB="45720">
-                    <a:lnL w="6350" cap="flat" cmpd="sng" algn="ctr">
-                      <a:solidFill>
-                        <a:srgbClr val="D9D9DE"/>
-                      </a:solidFill>
-                      <a:prstDash val="solid"/>
-                      <a:round/>
-                      <a:headEnd type="none" w="med" len="med"/>
-                      <a:tailEnd type="none" w="med" len="med"/>
-                    </a:lnL>
-                    <a:lnR w="6350" cap="flat" cmpd="sng" algn="ctr">
-                      <a:solidFill>
-                        <a:srgbClr val="D9D9DE"/>
-                      </a:solidFill>
-                      <a:prstDash val="solid"/>
-                      <a:round/>
-                      <a:headEnd type="none" w="med" len="med"/>
-                      <a:tailEnd type="none" w="med" len="med"/>
-                    </a:lnR>
-                    <a:lnT w="6350" cap="flat" cmpd="sng" algn="ctr">
-                      <a:solidFill>
-                        <a:srgbClr val="D9D9DE"/>
-                      </a:solidFill>
-                      <a:prstDash val="solid"/>
-                      <a:round/>
-                      <a:headEnd type="none" w="med" len="med"/>
-                      <a:tailEnd type="none" w="med" len="med"/>
-                    </a:lnT>
-                    <a:lnB w="6350" cap="flat" cmpd="sng" algn="ctr">
-                      <a:solidFill>
-                        <a:srgbClr val="D9D9DE"/>
-                      </a:solidFill>
-                      <a:prstDash val="solid"/>
-                      <a:round/>
-                      <a:headEnd type="none" w="med" len="med"/>
-                      <a:tailEnd type="none" w="med" len="med"/>
-                    </a:lnB>
-                    <a:solidFill>
-                      <a:schemeClr val="bg2"/>
-                    </a:solidFill>
-                  </a:tcPr>
-                </a:tc>
-                <a:tc>
-                  <a:txBody>
-                    <a:bodyPr/>
-                    <a:lstStyle/>
-                    <a:p>
-                      <a:pPr indent="0" marL="0">
-                        <a:buNone/>
-                      </a:pPr>
-                      <a:r>
-                        <a:rPr lang="en-US" sz="1100" dirty="0">
-                          <a:solidFill>
-                            <a:schemeClr val="tx1"/>
-                          </a:solidFill>
-                        </a:rPr>
-                        <a:t>M01-002, M03-001</a:t>
-                      </a:r>
-                      <a:endParaRPr lang="en-US" sz="1100" dirty="0"/>
+                      <a:endParaRPr lang="en-US" sz="1150" dirty="0"/>
                     </a:p>
                   </a:txBody>
                   <a:tcPr marL="45720" marR="45720" marT="45720" marB="45720">
@@ -3191,14 +2953,14 @@
                         <a:buNone/>
                       </a:pPr>
                       <a:r>
-                        <a:rPr lang="en-US" sz="1100" b="1" dirty="0">
+                        <a:rPr lang="en-US" sz="1150" b="1" dirty="0">
                           <a:solidFill>
                             <a:schemeClr val="tx1"/>
                           </a:solidFill>
                         </a:rPr>
                         <a:t>2</a:t>
                       </a:r>
-                      <a:endParaRPr lang="en-US" sz="1100" dirty="0"/>
+                      <a:endParaRPr lang="en-US" sz="1150" dirty="0"/>
                     </a:p>
                   </a:txBody>
                   <a:tcPr marL="45720" marR="45720" marT="45720" marB="45720">
@@ -3252,14 +3014,14 @@
                         <a:buNone/>
                       </a:pPr>
                       <a:r>
-                        <a:rPr lang="en-US" sz="1100" b="1" dirty="0">
+                        <a:rPr lang="en-US" sz="1150" b="1" dirty="0">
                           <a:solidFill>
                             <a:schemeClr val="accent1"/>
                           </a:solidFill>
                         </a:rPr>
                         <a:t>Web</a:t>
                       </a:r>
-                      <a:endParaRPr lang="en-US" sz="1100" dirty="0"/>
+                      <a:endParaRPr lang="en-US" sz="1150" dirty="0"/>
                     </a:p>
                   </a:txBody>
                   <a:tcPr marL="45720" marR="45720" marT="45720" marB="45720">
@@ -3313,14 +3075,14 @@
                         <a:buNone/>
                       </a:pPr>
                       <a:r>
-                        <a:rPr lang="en-US" sz="1100" dirty="0">
+                        <a:rPr lang="en-US" sz="1150" dirty="0">
                           <a:solidFill>
                             <a:schemeClr val="tx1"/>
                           </a:solidFill>
                         </a:rPr>
-                        <a:t>Create High announcement, Submit &amp; Publish</a:t>
+                        <a:t>Sign in as administrator; Announcements &gt; Create New: title, priority High, content, effective today, expiry tomorrow, Active; click Submit &amp; Publish</a:t>
                       </a:r>
-                      <a:endParaRPr lang="en-US" sz="1100" dirty="0"/>
+                      <a:endParaRPr lang="en-US" sz="1150" dirty="0"/>
                     </a:p>
                   </a:txBody>
                   <a:tcPr marL="45720" marR="45720" marT="45720" marB="45720">
@@ -3374,128 +3136,14 @@
                         <a:buNone/>
                       </a:pPr>
                       <a:r>
-                        <a:rPr lang="en-US" sz="1100" dirty="0">
+                        <a:rPr lang="en-US" sz="1150" dirty="0">
                           <a:solidFill>
                             <a:schemeClr val="tx1"/>
                           </a:solidFill>
                         </a:rPr>
-                        <a:t>Saved; approved at once</a:t>
+                        <a:t>Announcement is saved and approved at once</a:t>
                       </a:r>
-                      <a:endParaRPr lang="en-US" sz="1100" dirty="0"/>
-                    </a:p>
-                  </a:txBody>
-                  <a:tcPr marL="45720" marR="45720" marT="45720" marB="45720">
-                    <a:lnL w="6350" cap="flat" cmpd="sng" algn="ctr">
-                      <a:solidFill>
-                        <a:srgbClr val="D9D9DE"/>
-                      </a:solidFill>
-                      <a:prstDash val="solid"/>
-                      <a:round/>
-                      <a:headEnd type="none" w="med" len="med"/>
-                      <a:tailEnd type="none" w="med" len="med"/>
-                    </a:lnL>
-                    <a:lnR w="6350" cap="flat" cmpd="sng" algn="ctr">
-                      <a:solidFill>
-                        <a:srgbClr val="D9D9DE"/>
-                      </a:solidFill>
-                      <a:prstDash val="solid"/>
-                      <a:round/>
-                      <a:headEnd type="none" w="med" len="med"/>
-                      <a:tailEnd type="none" w="med" len="med"/>
-                    </a:lnR>
-                    <a:lnT w="6350" cap="flat" cmpd="sng" algn="ctr">
-                      <a:solidFill>
-                        <a:srgbClr val="D9D9DE"/>
-                      </a:solidFill>
-                      <a:prstDash val="solid"/>
-                      <a:round/>
-                      <a:headEnd type="none" w="med" len="med"/>
-                      <a:tailEnd type="none" w="med" len="med"/>
-                    </a:lnT>
-                    <a:lnB w="6350" cap="flat" cmpd="sng" algn="ctr">
-                      <a:solidFill>
-                        <a:srgbClr val="D9D9DE"/>
-                      </a:solidFill>
-                      <a:prstDash val="solid"/>
-                      <a:round/>
-                      <a:headEnd type="none" w="med" len="med"/>
-                      <a:tailEnd type="none" w="med" len="med"/>
-                    </a:lnB>
-                    <a:solidFill>
-                      <a:schemeClr val="bg1"/>
-                    </a:solidFill>
-                  </a:tcPr>
-                </a:tc>
-                <a:tc>
-                  <a:txBody>
-                    <a:bodyPr/>
-                    <a:lstStyle/>
-                    <a:p>
-                      <a:pPr indent="0" marL="0">
-                        <a:buNone/>
-                      </a:pPr>
-                      <a:r>
-                        <a:rPr lang="en-US" sz="1100" dirty="0">
-                          <a:solidFill>
-                            <a:schemeClr val="tx1"/>
-                          </a:solidFill>
-                        </a:rPr>
-                        <a:t>TC-14-004/005/006/007</a:t>
-                      </a:r>
-                      <a:endParaRPr lang="en-US" sz="1100" dirty="0"/>
-                    </a:p>
-                  </a:txBody>
-                  <a:tcPr marL="45720" marR="45720" marT="45720" marB="45720">
-                    <a:lnL w="6350" cap="flat" cmpd="sng" algn="ctr">
-                      <a:solidFill>
-                        <a:srgbClr val="D9D9DE"/>
-                      </a:solidFill>
-                      <a:prstDash val="solid"/>
-                      <a:round/>
-                      <a:headEnd type="none" w="med" len="med"/>
-                      <a:tailEnd type="none" w="med" len="med"/>
-                    </a:lnL>
-                    <a:lnR w="6350" cap="flat" cmpd="sng" algn="ctr">
-                      <a:solidFill>
-                        <a:srgbClr val="D9D9DE"/>
-                      </a:solidFill>
-                      <a:prstDash val="solid"/>
-                      <a:round/>
-                      <a:headEnd type="none" w="med" len="med"/>
-                      <a:tailEnd type="none" w="med" len="med"/>
-                    </a:lnR>
-                    <a:lnT w="6350" cap="flat" cmpd="sng" algn="ctr">
-                      <a:solidFill>
-                        <a:srgbClr val="D9D9DE"/>
-                      </a:solidFill>
-                      <a:prstDash val="solid"/>
-                      <a:round/>
-                      <a:headEnd type="none" w="med" len="med"/>
-                      <a:tailEnd type="none" w="med" len="med"/>
-                    </a:lnT>
-                    <a:lnB w="6350" cap="flat" cmpd="sng" algn="ctr">
-                      <a:solidFill>
-                        <a:srgbClr val="D9D9DE"/>
-                      </a:solidFill>
-                      <a:prstDash val="solid"/>
-                      <a:round/>
-                      <a:headEnd type="none" w="med" len="med"/>
-                      <a:tailEnd type="none" w="med" len="med"/>
-                    </a:lnB>
-                    <a:solidFill>
-                      <a:schemeClr val="bg1"/>
-                    </a:solidFill>
-                  </a:tcPr>
-                </a:tc>
-                <a:tc>
-                  <a:txBody>
-                    <a:bodyPr/>
-                    <a:lstStyle/>
-                    <a:p>
-                      <a:pPr indent="0" marL="0">
-                        <a:buNone/>
-                      </a:pPr>
-                      <a:endParaRPr lang="en-US" sz="1100" dirty="0"/>
+                      <a:endParaRPr lang="en-US" sz="1150" dirty="0"/>
                     </a:p>
                   </a:txBody>
                   <a:tcPr marL="45720" marR="45720" marT="45720" marB="45720">
@@ -3551,14 +3199,14 @@
                         <a:buNone/>
                       </a:pPr>
                       <a:r>
-                        <a:rPr lang="en-US" sz="1100" b="1" dirty="0">
+                        <a:rPr lang="en-US" sz="1150" b="1" dirty="0">
                           <a:solidFill>
                             <a:schemeClr val="tx1"/>
                           </a:solidFill>
                         </a:rPr>
                         <a:t>3</a:t>
                       </a:r>
-                      <a:endParaRPr lang="en-US" sz="1100" dirty="0"/>
+                      <a:endParaRPr lang="en-US" sz="1150" dirty="0"/>
                     </a:p>
                   </a:txBody>
                   <a:tcPr marL="45720" marR="45720" marT="45720" marB="45720">
@@ -3612,14 +3260,14 @@
                         <a:buNone/>
                       </a:pPr>
                       <a:r>
-                        <a:rPr lang="en-US" sz="1100" b="1" dirty="0">
+                        <a:rPr lang="en-US" sz="1150" b="1" dirty="0">
                           <a:solidFill>
                             <a:schemeClr val="accent1"/>
                           </a:solidFill>
                         </a:rPr>
                         <a:t>Web</a:t>
                       </a:r>
-                      <a:endParaRPr lang="en-US" sz="1100" dirty="0"/>
+                      <a:endParaRPr lang="en-US" sz="1150" dirty="0"/>
                     </a:p>
                   </a:txBody>
                   <a:tcPr marL="45720" marR="45720" marT="45720" marB="45720">
@@ -3673,14 +3321,14 @@
                         <a:buNone/>
                       </a:pPr>
                       <a:r>
-                        <a:rPr lang="en-US" sz="1100" dirty="0">
+                        <a:rPr lang="en-US" sz="1150" dirty="0">
                           <a:solidFill>
                             <a:schemeClr val="tx1"/>
                           </a:solidFill>
                         </a:rPr>
-                        <a:t>Announcement list</a:t>
+                        <a:t>Open the announcement list</a:t>
                       </a:r>
-                      <a:endParaRPr lang="en-US" sz="1100" dirty="0"/>
+                      <a:endParaRPr lang="en-US" sz="1150" dirty="0"/>
                     </a:p>
                   </a:txBody>
                   <a:tcPr marL="45720" marR="45720" marT="45720" marB="45720">
@@ -3734,128 +3382,14 @@
                         <a:buNone/>
                       </a:pPr>
                       <a:r>
-                        <a:rPr lang="en-US" sz="1100" dirty="0">
+                        <a:rPr lang="en-US" sz="1150" dirty="0">
                           <a:solidFill>
                             <a:schemeClr val="tx1"/>
                           </a:solidFill>
                         </a:rPr>
-                        <a:t>Approved, Active, High</a:t>
+                        <a:t>Row shows priority High, Active, status Approved</a:t>
                       </a:r>
-                      <a:endParaRPr lang="en-US" sz="1100" dirty="0"/>
-                    </a:p>
-                  </a:txBody>
-                  <a:tcPr marL="45720" marR="45720" marT="45720" marB="45720">
-                    <a:lnL w="6350" cap="flat" cmpd="sng" algn="ctr">
-                      <a:solidFill>
-                        <a:srgbClr val="D9D9DE"/>
-                      </a:solidFill>
-                      <a:prstDash val="solid"/>
-                      <a:round/>
-                      <a:headEnd type="none" w="med" len="med"/>
-                      <a:tailEnd type="none" w="med" len="med"/>
-                    </a:lnL>
-                    <a:lnR w="6350" cap="flat" cmpd="sng" algn="ctr">
-                      <a:solidFill>
-                        <a:srgbClr val="D9D9DE"/>
-                      </a:solidFill>
-                      <a:prstDash val="solid"/>
-                      <a:round/>
-                      <a:headEnd type="none" w="med" len="med"/>
-                      <a:tailEnd type="none" w="med" len="med"/>
-                    </a:lnR>
-                    <a:lnT w="6350" cap="flat" cmpd="sng" algn="ctr">
-                      <a:solidFill>
-                        <a:srgbClr val="D9D9DE"/>
-                      </a:solidFill>
-                      <a:prstDash val="solid"/>
-                      <a:round/>
-                      <a:headEnd type="none" w="med" len="med"/>
-                      <a:tailEnd type="none" w="med" len="med"/>
-                    </a:lnT>
-                    <a:lnB w="6350" cap="flat" cmpd="sng" algn="ctr">
-                      <a:solidFill>
-                        <a:srgbClr val="D9D9DE"/>
-                      </a:solidFill>
-                      <a:prstDash val="solid"/>
-                      <a:round/>
-                      <a:headEnd type="none" w="med" len="med"/>
-                      <a:tailEnd type="none" w="med" len="med"/>
-                    </a:lnB>
-                    <a:solidFill>
-                      <a:schemeClr val="bg2"/>
-                    </a:solidFill>
-                  </a:tcPr>
-                </a:tc>
-                <a:tc>
-                  <a:txBody>
-                    <a:bodyPr/>
-                    <a:lstStyle/>
-                    <a:p>
-                      <a:pPr indent="0" marL="0">
-                        <a:buNone/>
-                      </a:pPr>
-                      <a:r>
-                        <a:rPr lang="en-US" sz="1100" dirty="0">
-                          <a:solidFill>
-                            <a:schemeClr val="tx1"/>
-                          </a:solidFill>
-                        </a:rPr>
-                        <a:t>TC-14-001</a:t>
-                      </a:r>
-                      <a:endParaRPr lang="en-US" sz="1100" dirty="0"/>
-                    </a:p>
-                  </a:txBody>
-                  <a:tcPr marL="45720" marR="45720" marT="45720" marB="45720">
-                    <a:lnL w="6350" cap="flat" cmpd="sng" algn="ctr">
-                      <a:solidFill>
-                        <a:srgbClr val="D9D9DE"/>
-                      </a:solidFill>
-                      <a:prstDash val="solid"/>
-                      <a:round/>
-                      <a:headEnd type="none" w="med" len="med"/>
-                      <a:tailEnd type="none" w="med" len="med"/>
-                    </a:lnL>
-                    <a:lnR w="6350" cap="flat" cmpd="sng" algn="ctr">
-                      <a:solidFill>
-                        <a:srgbClr val="D9D9DE"/>
-                      </a:solidFill>
-                      <a:prstDash val="solid"/>
-                      <a:round/>
-                      <a:headEnd type="none" w="med" len="med"/>
-                      <a:tailEnd type="none" w="med" len="med"/>
-                    </a:lnR>
-                    <a:lnT w="6350" cap="flat" cmpd="sng" algn="ctr">
-                      <a:solidFill>
-                        <a:srgbClr val="D9D9DE"/>
-                      </a:solidFill>
-                      <a:prstDash val="solid"/>
-                      <a:round/>
-                      <a:headEnd type="none" w="med" len="med"/>
-                      <a:tailEnd type="none" w="med" len="med"/>
-                    </a:lnT>
-                    <a:lnB w="6350" cap="flat" cmpd="sng" algn="ctr">
-                      <a:solidFill>
-                        <a:srgbClr val="D9D9DE"/>
-                      </a:solidFill>
-                      <a:prstDash val="solid"/>
-                      <a:round/>
-                      <a:headEnd type="none" w="med" len="med"/>
-                      <a:tailEnd type="none" w="med" len="med"/>
-                    </a:lnB>
-                    <a:solidFill>
-                      <a:schemeClr val="bg2"/>
-                    </a:solidFill>
-                  </a:tcPr>
-                </a:tc>
-                <a:tc>
-                  <a:txBody>
-                    <a:bodyPr/>
-                    <a:lstStyle/>
-                    <a:p>
-                      <a:pPr indent="0" marL="0">
-                        <a:buNone/>
-                      </a:pPr>
-                      <a:endParaRPr lang="en-US" sz="1100" dirty="0"/>
+                      <a:endParaRPr lang="en-US" sz="1150" dirty="0"/>
                     </a:p>
                   </a:txBody>
                   <a:tcPr marL="45720" marR="45720" marT="45720" marB="45720">
@@ -3911,14 +3445,14 @@
                         <a:buNone/>
                       </a:pPr>
                       <a:r>
-                        <a:rPr lang="en-US" sz="1100" b="1" dirty="0">
+                        <a:rPr lang="en-US" sz="1150" b="1" dirty="0">
                           <a:solidFill>
                             <a:schemeClr val="tx1"/>
                           </a:solidFill>
                         </a:rPr>
                         <a:t>4</a:t>
                       </a:r>
-                      <a:endParaRPr lang="en-US" sz="1100" dirty="0"/>
+                      <a:endParaRPr lang="en-US" sz="1150" dirty="0"/>
                     </a:p>
                   </a:txBody>
                   <a:tcPr marL="45720" marR="45720" marT="45720" marB="45720">
@@ -3972,14 +3506,14 @@
                         <a:buNone/>
                       </a:pPr>
                       <a:r>
-                        <a:rPr lang="en-US" sz="1100" b="1" dirty="0">
+                        <a:rPr lang="en-US" sz="1150" b="1" dirty="0">
                           <a:solidFill>
                             <a:schemeClr val="accent4"/>
                           </a:solidFill>
                         </a:rPr>
                         <a:t>Server</a:t>
                       </a:r>
-                      <a:endParaRPr lang="en-US" sz="1100" dirty="0"/>
+                      <a:endParaRPr lang="en-US" sz="1150" dirty="0"/>
                     </a:p>
                   </a:txBody>
                   <a:tcPr marL="45720" marR="45720" marT="45720" marB="45720">
@@ -4033,14 +3567,14 @@
                         <a:buNone/>
                       </a:pPr>
                       <a:r>
-                        <a:rPr lang="en-US" sz="1100" dirty="0">
+                        <a:rPr lang="en-US" sz="1150" dirty="0">
                           <a:solidFill>
                             <a:schemeClr val="tx1"/>
                           </a:solidFill>
                         </a:rPr>
-                        <a:t>GET api/pmws/announcements</a:t>
+                        <a:t>Read the feed the app uses: GET api/pmws/announcements</a:t>
                       </a:r>
-                      <a:endParaRPr lang="en-US" sz="1100" dirty="0"/>
+                      <a:endParaRPr lang="en-US" sz="1150" dirty="0"/>
                     </a:p>
                   </a:txBody>
                   <a:tcPr marL="45720" marR="45720" marT="45720" marB="45720">
@@ -4094,128 +3628,14 @@
                         <a:buNone/>
                       </a:pPr>
                       <a:r>
-                        <a:rPr lang="en-US" sz="1100" dirty="0">
+                        <a:rPr lang="en-US" sz="1150" dirty="0">
                           <a:solidFill>
                             <a:schemeClr val="tx1"/>
                           </a:solidFill>
                         </a:rPr>
-                        <a:t>Contains the new one</a:t>
+                        <a:t>Feed contains the new announcement</a:t>
                       </a:r>
-                      <a:endParaRPr lang="en-US" sz="1100" dirty="0"/>
-                    </a:p>
-                  </a:txBody>
-                  <a:tcPr marL="45720" marR="45720" marT="45720" marB="45720">
-                    <a:lnL w="6350" cap="flat" cmpd="sng" algn="ctr">
-                      <a:solidFill>
-                        <a:srgbClr val="D9D9DE"/>
-                      </a:solidFill>
-                      <a:prstDash val="solid"/>
-                      <a:round/>
-                      <a:headEnd type="none" w="med" len="med"/>
-                      <a:tailEnd type="none" w="med" len="med"/>
-                    </a:lnL>
-                    <a:lnR w="6350" cap="flat" cmpd="sng" algn="ctr">
-                      <a:solidFill>
-                        <a:srgbClr val="D9D9DE"/>
-                      </a:solidFill>
-                      <a:prstDash val="solid"/>
-                      <a:round/>
-                      <a:headEnd type="none" w="med" len="med"/>
-                      <a:tailEnd type="none" w="med" len="med"/>
-                    </a:lnR>
-                    <a:lnT w="6350" cap="flat" cmpd="sng" algn="ctr">
-                      <a:solidFill>
-                        <a:srgbClr val="D9D9DE"/>
-                      </a:solidFill>
-                      <a:prstDash val="solid"/>
-                      <a:round/>
-                      <a:headEnd type="none" w="med" len="med"/>
-                      <a:tailEnd type="none" w="med" len="med"/>
-                    </a:lnT>
-                    <a:lnB w="6350" cap="flat" cmpd="sng" algn="ctr">
-                      <a:solidFill>
-                        <a:srgbClr val="D9D9DE"/>
-                      </a:solidFill>
-                      <a:prstDash val="solid"/>
-                      <a:round/>
-                      <a:headEnd type="none" w="med" len="med"/>
-                      <a:tailEnd type="none" w="med" len="med"/>
-                    </a:lnB>
-                    <a:solidFill>
-                      <a:schemeClr val="bg1"/>
-                    </a:solidFill>
-                  </a:tcPr>
-                </a:tc>
-                <a:tc>
-                  <a:txBody>
-                    <a:bodyPr/>
-                    <a:lstStyle/>
-                    <a:p>
-                      <a:pPr indent="0" marL="0">
-                        <a:buNone/>
-                      </a:pPr>
-                      <a:r>
-                        <a:rPr lang="en-US" sz="1100" dirty="0">
-                          <a:solidFill>
-                            <a:schemeClr val="tx1"/>
-                          </a:solidFill>
-                        </a:rPr>
-                        <a:t>TC-14-019</a:t>
-                      </a:r>
-                      <a:endParaRPr lang="en-US" sz="1100" dirty="0"/>
-                    </a:p>
-                  </a:txBody>
-                  <a:tcPr marL="45720" marR="45720" marT="45720" marB="45720">
-                    <a:lnL w="6350" cap="flat" cmpd="sng" algn="ctr">
-                      <a:solidFill>
-                        <a:srgbClr val="D9D9DE"/>
-                      </a:solidFill>
-                      <a:prstDash val="solid"/>
-                      <a:round/>
-                      <a:headEnd type="none" w="med" len="med"/>
-                      <a:tailEnd type="none" w="med" len="med"/>
-                    </a:lnL>
-                    <a:lnR w="6350" cap="flat" cmpd="sng" algn="ctr">
-                      <a:solidFill>
-                        <a:srgbClr val="D9D9DE"/>
-                      </a:solidFill>
-                      <a:prstDash val="solid"/>
-                      <a:round/>
-                      <a:headEnd type="none" w="med" len="med"/>
-                      <a:tailEnd type="none" w="med" len="med"/>
-                    </a:lnR>
-                    <a:lnT w="6350" cap="flat" cmpd="sng" algn="ctr">
-                      <a:solidFill>
-                        <a:srgbClr val="D9D9DE"/>
-                      </a:solidFill>
-                      <a:prstDash val="solid"/>
-                      <a:round/>
-                      <a:headEnd type="none" w="med" len="med"/>
-                      <a:tailEnd type="none" w="med" len="med"/>
-                    </a:lnT>
-                    <a:lnB w="6350" cap="flat" cmpd="sng" algn="ctr">
-                      <a:solidFill>
-                        <a:srgbClr val="D9D9DE"/>
-                      </a:solidFill>
-                      <a:prstDash val="solid"/>
-                      <a:round/>
-                      <a:headEnd type="none" w="med" len="med"/>
-                      <a:tailEnd type="none" w="med" len="med"/>
-                    </a:lnB>
-                    <a:solidFill>
-                      <a:schemeClr val="bg1"/>
-                    </a:solidFill>
-                  </a:tcPr>
-                </a:tc>
-                <a:tc>
-                  <a:txBody>
-                    <a:bodyPr/>
-                    <a:lstStyle/>
-                    <a:p>
-                      <a:pPr indent="0" marL="0">
-                        <a:buNone/>
-                      </a:pPr>
-                      <a:endParaRPr lang="en-US" sz="1100" dirty="0"/>
+                      <a:endParaRPr lang="en-US" sz="1150" dirty="0"/>
                     </a:p>
                   </a:txBody>
                   <a:tcPr marL="45720" marR="45720" marT="45720" marB="45720">
@@ -4271,14 +3691,14 @@
                         <a:buNone/>
                       </a:pPr>
                       <a:r>
-                        <a:rPr lang="en-US" sz="1100" b="1" dirty="0">
+                        <a:rPr lang="en-US" sz="1150" b="1" dirty="0">
                           <a:solidFill>
                             <a:schemeClr val="tx1"/>
                           </a:solidFill>
                         </a:rPr>
                         <a:t>5</a:t>
                       </a:r>
-                      <a:endParaRPr lang="en-US" sz="1100" dirty="0"/>
+                      <a:endParaRPr lang="en-US" sz="1150" dirty="0"/>
                     </a:p>
                   </a:txBody>
                   <a:tcPr marL="45720" marR="45720" marT="45720" marB="45720">
@@ -4332,14 +3752,14 @@
                         <a:buNone/>
                       </a:pPr>
                       <a:r>
-                        <a:rPr lang="en-US" sz="1100" b="1" dirty="0">
+                        <a:rPr lang="en-US" sz="1150" b="1" dirty="0">
                           <a:solidFill>
                             <a:schemeClr val="accent2"/>
                           </a:solidFill>
                         </a:rPr>
                         <a:t>App</a:t>
                       </a:r>
-                      <a:endParaRPr lang="en-US" sz="1100" dirty="0"/>
+                      <a:endParaRPr lang="en-US" sz="1150" dirty="0"/>
                     </a:p>
                   </a:txBody>
                   <a:tcPr marL="45720" marR="45720" marT="45720" marB="45720">
@@ -4393,14 +3813,14 @@
                         <a:buNone/>
                       </a:pPr>
                       <a:r>
-                        <a:rPr lang="en-US" sz="1100" dirty="0">
+                        <a:rPr lang="en-US" sz="1150" dirty="0">
                           <a:solidFill>
                             <a:schemeClr val="tx1"/>
                           </a:solidFill>
                         </a:rPr>
-                        <a:t>News tab, tap the card</a:t>
+                        <a:t>Open the News tab and tap the card</a:t>
                       </a:r>
-                      <a:endParaRPr lang="en-US" sz="1100" dirty="0"/>
+                      <a:endParaRPr lang="en-US" sz="1150" dirty="0"/>
                     </a:p>
                   </a:txBody>
                   <a:tcPr marL="45720" marR="45720" marT="45720" marB="45720">
@@ -4454,128 +3874,14 @@
                         <a:buNone/>
                       </a:pPr>
                       <a:r>
-                        <a:rPr lang="en-US" sz="1100" dirty="0">
+                        <a:rPr lang="en-US" sz="1150" dirty="0">
                           <a:solidFill>
                             <a:schemeClr val="tx1"/>
                           </a:solidFill>
                         </a:rPr>
-                        <a:t>Title + content</a:t>
+                        <a:t>Card shows the title; the content expands</a:t>
                       </a:r>
-                      <a:endParaRPr lang="en-US" sz="1100" dirty="0"/>
-                    </a:p>
-                  </a:txBody>
-                  <a:tcPr marL="45720" marR="45720" marT="45720" marB="45720">
-                    <a:lnL w="6350" cap="flat" cmpd="sng" algn="ctr">
-                      <a:solidFill>
-                        <a:srgbClr val="D9D9DE"/>
-                      </a:solidFill>
-                      <a:prstDash val="solid"/>
-                      <a:round/>
-                      <a:headEnd type="none" w="med" len="med"/>
-                      <a:tailEnd type="none" w="med" len="med"/>
-                    </a:lnL>
-                    <a:lnR w="6350" cap="flat" cmpd="sng" algn="ctr">
-                      <a:solidFill>
-                        <a:srgbClr val="D9D9DE"/>
-                      </a:solidFill>
-                      <a:prstDash val="solid"/>
-                      <a:round/>
-                      <a:headEnd type="none" w="med" len="med"/>
-                      <a:tailEnd type="none" w="med" len="med"/>
-                    </a:lnR>
-                    <a:lnT w="6350" cap="flat" cmpd="sng" algn="ctr">
-                      <a:solidFill>
-                        <a:srgbClr val="D9D9DE"/>
-                      </a:solidFill>
-                      <a:prstDash val="solid"/>
-                      <a:round/>
-                      <a:headEnd type="none" w="med" len="med"/>
-                      <a:tailEnd type="none" w="med" len="med"/>
-                    </a:lnT>
-                    <a:lnB w="6350" cap="flat" cmpd="sng" algn="ctr">
-                      <a:solidFill>
-                        <a:srgbClr val="D9D9DE"/>
-                      </a:solidFill>
-                      <a:prstDash val="solid"/>
-                      <a:round/>
-                      <a:headEnd type="none" w="med" len="med"/>
-                      <a:tailEnd type="none" w="med" len="med"/>
-                    </a:lnB>
-                    <a:solidFill>
-                      <a:schemeClr val="bg2"/>
-                    </a:solidFill>
-                  </a:tcPr>
-                </a:tc>
-                <a:tc>
-                  <a:txBody>
-                    <a:bodyPr/>
-                    <a:lstStyle/>
-                    <a:p>
-                      <a:pPr indent="0" marL="0">
-                        <a:buNone/>
-                      </a:pPr>
-                      <a:endParaRPr lang="en-US" sz="1100" dirty="0"/>
-                    </a:p>
-                  </a:txBody>
-                  <a:tcPr marL="45720" marR="45720" marT="45720" marB="45720">
-                    <a:lnL w="6350" cap="flat" cmpd="sng" algn="ctr">
-                      <a:solidFill>
-                        <a:srgbClr val="D9D9DE"/>
-                      </a:solidFill>
-                      <a:prstDash val="solid"/>
-                      <a:round/>
-                      <a:headEnd type="none" w="med" len="med"/>
-                      <a:tailEnd type="none" w="med" len="med"/>
-                    </a:lnL>
-                    <a:lnR w="6350" cap="flat" cmpd="sng" algn="ctr">
-                      <a:solidFill>
-                        <a:srgbClr val="D9D9DE"/>
-                      </a:solidFill>
-                      <a:prstDash val="solid"/>
-                      <a:round/>
-                      <a:headEnd type="none" w="med" len="med"/>
-                      <a:tailEnd type="none" w="med" len="med"/>
-                    </a:lnR>
-                    <a:lnT w="6350" cap="flat" cmpd="sng" algn="ctr">
-                      <a:solidFill>
-                        <a:srgbClr val="D9D9DE"/>
-                      </a:solidFill>
-                      <a:prstDash val="solid"/>
-                      <a:round/>
-                      <a:headEnd type="none" w="med" len="med"/>
-                      <a:tailEnd type="none" w="med" len="med"/>
-                    </a:lnT>
-                    <a:lnB w="6350" cap="flat" cmpd="sng" algn="ctr">
-                      <a:solidFill>
-                        <a:srgbClr val="D9D9DE"/>
-                      </a:solidFill>
-                      <a:prstDash val="solid"/>
-                      <a:round/>
-                      <a:headEnd type="none" w="med" len="med"/>
-                      <a:tailEnd type="none" w="med" len="med"/>
-                    </a:lnB>
-                    <a:solidFill>
-                      <a:schemeClr val="bg2"/>
-                    </a:solidFill>
-                  </a:tcPr>
-                </a:tc>
-                <a:tc>
-                  <a:txBody>
-                    <a:bodyPr/>
-                    <a:lstStyle/>
-                    <a:p>
-                      <a:pPr indent="0" marL="0">
-                        <a:buNone/>
-                      </a:pPr>
-                      <a:r>
-                        <a:rPr lang="en-US" sz="1100" dirty="0">
-                          <a:solidFill>
-                            <a:schemeClr val="tx1"/>
-                          </a:solidFill>
-                        </a:rPr>
-                        <a:t>M09-001</a:t>
-                      </a:r>
-                      <a:endParaRPr lang="en-US" sz="1100" dirty="0"/>
+                      <a:endParaRPr lang="en-US" sz="1150" dirty="0"/>
                     </a:p>
                   </a:txBody>
                   <a:tcPr marL="45720" marR="45720" marT="45720" marB="45720">
@@ -4631,14 +3937,14 @@
                         <a:buNone/>
                       </a:pPr>
                       <a:r>
-                        <a:rPr lang="en-US" sz="1100" b="1" dirty="0">
+                        <a:rPr lang="en-US" sz="1150" b="1" dirty="0">
                           <a:solidFill>
                             <a:schemeClr val="tx1"/>
                           </a:solidFill>
                         </a:rPr>
                         <a:t>6</a:t>
                       </a:r>
-                      <a:endParaRPr lang="en-US" sz="1100" dirty="0"/>
+                      <a:endParaRPr lang="en-US" sz="1150" dirty="0"/>
                     </a:p>
                   </a:txBody>
                   <a:tcPr marL="45720" marR="45720" marT="45720" marB="45720">
@@ -4692,14 +3998,14 @@
                         <a:buNone/>
                       </a:pPr>
                       <a:r>
-                        <a:rPr lang="en-US" sz="1100" b="1" dirty="0">
+                        <a:rPr lang="en-US" sz="1150" b="1" dirty="0">
                           <a:solidFill>
                             <a:schemeClr val="accent2"/>
                           </a:solidFill>
                         </a:rPr>
                         <a:t>App</a:t>
                       </a:r>
-                      <a:endParaRPr lang="en-US" sz="1100" dirty="0"/>
+                      <a:endParaRPr lang="en-US" sz="1150" dirty="0"/>
                     </a:p>
                   </a:txBody>
                   <a:tcPr marL="45720" marR="45720" marT="45720" marB="45720">
@@ -4753,14 +4059,14 @@
                         <a:buNone/>
                       </a:pPr>
                       <a:r>
-                        <a:rPr lang="en-US" sz="1100" dirty="0">
+                        <a:rPr lang="en-US" sz="1150" dirty="0">
                           <a:solidFill>
                             <a:schemeClr val="tx1"/>
                           </a:solidFill>
                         </a:rPr>
-                        <a:t>Home</a:t>
+                        <a:t>Open Home</a:t>
                       </a:r>
-                      <a:endParaRPr lang="en-US" sz="1100" dirty="0"/>
+                      <a:endParaRPr lang="en-US" sz="1150" dirty="0"/>
                     </a:p>
                   </a:txBody>
                   <a:tcPr marL="45720" marR="45720" marT="45720" marB="45720">
@@ -4814,128 +4120,14 @@
                         <a:buNone/>
                       </a:pPr>
                       <a:r>
-                        <a:rPr lang="en-US" sz="1100" dirty="0">
+                        <a:rPr lang="en-US" sz="1150" dirty="0">
                           <a:solidFill>
                             <a:schemeClr val="tx1"/>
                           </a:solidFill>
                         </a:rPr>
-                        <a:t>High-priority banner</a:t>
+                        <a:t>High-priority banner shows the title</a:t>
                       </a:r>
-                      <a:endParaRPr lang="en-US" sz="1100" dirty="0"/>
-                    </a:p>
-                  </a:txBody>
-                  <a:tcPr marL="45720" marR="45720" marT="45720" marB="45720">
-                    <a:lnL w="6350" cap="flat" cmpd="sng" algn="ctr">
-                      <a:solidFill>
-                        <a:srgbClr val="D9D9DE"/>
-                      </a:solidFill>
-                      <a:prstDash val="solid"/>
-                      <a:round/>
-                      <a:headEnd type="none" w="med" len="med"/>
-                      <a:tailEnd type="none" w="med" len="med"/>
-                    </a:lnL>
-                    <a:lnR w="6350" cap="flat" cmpd="sng" algn="ctr">
-                      <a:solidFill>
-                        <a:srgbClr val="D9D9DE"/>
-                      </a:solidFill>
-                      <a:prstDash val="solid"/>
-                      <a:round/>
-                      <a:headEnd type="none" w="med" len="med"/>
-                      <a:tailEnd type="none" w="med" len="med"/>
-                    </a:lnR>
-                    <a:lnT w="6350" cap="flat" cmpd="sng" algn="ctr">
-                      <a:solidFill>
-                        <a:srgbClr val="D9D9DE"/>
-                      </a:solidFill>
-                      <a:prstDash val="solid"/>
-                      <a:round/>
-                      <a:headEnd type="none" w="med" len="med"/>
-                      <a:tailEnd type="none" w="med" len="med"/>
-                    </a:lnT>
-                    <a:lnB w="6350" cap="flat" cmpd="sng" algn="ctr">
-                      <a:solidFill>
-                        <a:srgbClr val="D9D9DE"/>
-                      </a:solidFill>
-                      <a:prstDash val="solid"/>
-                      <a:round/>
-                      <a:headEnd type="none" w="med" len="med"/>
-                      <a:tailEnd type="none" w="med" len="med"/>
-                    </a:lnB>
-                    <a:solidFill>
-                      <a:schemeClr val="bg1"/>
-                    </a:solidFill>
-                  </a:tcPr>
-                </a:tc>
-                <a:tc>
-                  <a:txBody>
-                    <a:bodyPr/>
-                    <a:lstStyle/>
-                    <a:p>
-                      <a:pPr indent="0" marL="0">
-                        <a:buNone/>
-                      </a:pPr>
-                      <a:endParaRPr lang="en-US" sz="1100" dirty="0"/>
-                    </a:p>
-                  </a:txBody>
-                  <a:tcPr marL="45720" marR="45720" marT="45720" marB="45720">
-                    <a:lnL w="6350" cap="flat" cmpd="sng" algn="ctr">
-                      <a:solidFill>
-                        <a:srgbClr val="D9D9DE"/>
-                      </a:solidFill>
-                      <a:prstDash val="solid"/>
-                      <a:round/>
-                      <a:headEnd type="none" w="med" len="med"/>
-                      <a:tailEnd type="none" w="med" len="med"/>
-                    </a:lnL>
-                    <a:lnR w="6350" cap="flat" cmpd="sng" algn="ctr">
-                      <a:solidFill>
-                        <a:srgbClr val="D9D9DE"/>
-                      </a:solidFill>
-                      <a:prstDash val="solid"/>
-                      <a:round/>
-                      <a:headEnd type="none" w="med" len="med"/>
-                      <a:tailEnd type="none" w="med" len="med"/>
-                    </a:lnR>
-                    <a:lnT w="6350" cap="flat" cmpd="sng" algn="ctr">
-                      <a:solidFill>
-                        <a:srgbClr val="D9D9DE"/>
-                      </a:solidFill>
-                      <a:prstDash val="solid"/>
-                      <a:round/>
-                      <a:headEnd type="none" w="med" len="med"/>
-                      <a:tailEnd type="none" w="med" len="med"/>
-                    </a:lnT>
-                    <a:lnB w="6350" cap="flat" cmpd="sng" algn="ctr">
-                      <a:solidFill>
-                        <a:srgbClr val="D9D9DE"/>
-                      </a:solidFill>
-                      <a:prstDash val="solid"/>
-                      <a:round/>
-                      <a:headEnd type="none" w="med" len="med"/>
-                      <a:tailEnd type="none" w="med" len="med"/>
-                    </a:lnB>
-                    <a:solidFill>
-                      <a:schemeClr val="bg1"/>
-                    </a:solidFill>
-                  </a:tcPr>
-                </a:tc>
-                <a:tc>
-                  <a:txBody>
-                    <a:bodyPr/>
-                    <a:lstStyle/>
-                    <a:p>
-                      <a:pPr indent="0" marL="0">
-                        <a:buNone/>
-                      </a:pPr>
-                      <a:r>
-                        <a:rPr lang="en-US" sz="1100" dirty="0">
-                          <a:solidFill>
-                            <a:schemeClr val="tx1"/>
-                          </a:solidFill>
-                        </a:rPr>
-                        <a:t>M03-008</a:t>
-                      </a:r>
-                      <a:endParaRPr lang="en-US" sz="1100" dirty="0"/>
+                      <a:endParaRPr lang="en-US" sz="1150" dirty="0"/>
                     </a:p>
                   </a:txBody>
                   <a:tcPr marL="45720" marR="45720" marT="45720" marB="45720">
@@ -4991,14 +4183,14 @@
                         <a:buNone/>
                       </a:pPr>
                       <a:r>
-                        <a:rPr lang="en-US" sz="1100" b="1" dirty="0">
+                        <a:rPr lang="en-US" sz="1150" b="1" dirty="0">
                           <a:solidFill>
                             <a:schemeClr val="tx1"/>
                           </a:solidFill>
                         </a:rPr>
                         <a:t>7</a:t>
                       </a:r>
-                      <a:endParaRPr lang="en-US" sz="1100" dirty="0"/>
+                      <a:endParaRPr lang="en-US" sz="1150" dirty="0"/>
                     </a:p>
                   </a:txBody>
                   <a:tcPr marL="45720" marR="45720" marT="45720" marB="45720">
@@ -5052,14 +4244,14 @@
                         <a:buNone/>
                       </a:pPr>
                       <a:r>
-                        <a:rPr lang="en-US" sz="1100" b="1" dirty="0">
+                        <a:rPr lang="en-US" sz="1150" b="1" dirty="0">
                           <a:solidFill>
                             <a:schemeClr val="accent1"/>
                           </a:solidFill>
                         </a:rPr>
                         <a:t>Web</a:t>
                       </a:r>
-                      <a:endParaRPr lang="en-US" sz="1100" dirty="0"/>
+                      <a:endParaRPr lang="en-US" sz="1150" dirty="0"/>
                     </a:p>
                   </a:txBody>
                   <a:tcPr marL="45720" marR="45720" marT="45720" marB="45720">
@@ -5113,14 +4305,14 @@
                         <a:buNone/>
                       </a:pPr>
                       <a:r>
-                        <a:rPr lang="en-US" sz="1100" dirty="0">
+                        <a:rPr lang="en-US" sz="1150" dirty="0">
                           <a:solidFill>
                             <a:schemeClr val="tx1"/>
                           </a:solidFill>
                         </a:rPr>
-                        <a:t>Edit, untick Active</a:t>
+                        <a:t>Edit the announcement, untick Active, Update</a:t>
                       </a:r>
-                      <a:endParaRPr lang="en-US" sz="1100" dirty="0"/>
+                      <a:endParaRPr lang="en-US" sz="1150" dirty="0"/>
                     </a:p>
                   </a:txBody>
                   <a:tcPr marL="45720" marR="45720" marT="45720" marB="45720">
@@ -5174,128 +4366,14 @@
                         <a:buNone/>
                       </a:pPr>
                       <a:r>
-                        <a:rPr lang="en-US" sz="1100" dirty="0">
+                        <a:rPr lang="en-US" sz="1150" dirty="0">
                           <a:solidFill>
                             <a:schemeClr val="tx1"/>
                           </a:solidFill>
                         </a:rPr>
-                        <a:t>Feed no longer has it</a:t>
+                        <a:t>Feed no longer contains it</a:t>
                       </a:r>
-                      <a:endParaRPr lang="en-US" sz="1100" dirty="0"/>
-                    </a:p>
-                  </a:txBody>
-                  <a:tcPr marL="45720" marR="45720" marT="45720" marB="45720">
-                    <a:lnL w="6350" cap="flat" cmpd="sng" algn="ctr">
-                      <a:solidFill>
-                        <a:srgbClr val="D9D9DE"/>
-                      </a:solidFill>
-                      <a:prstDash val="solid"/>
-                      <a:round/>
-                      <a:headEnd type="none" w="med" len="med"/>
-                      <a:tailEnd type="none" w="med" len="med"/>
-                    </a:lnL>
-                    <a:lnR w="6350" cap="flat" cmpd="sng" algn="ctr">
-                      <a:solidFill>
-                        <a:srgbClr val="D9D9DE"/>
-                      </a:solidFill>
-                      <a:prstDash val="solid"/>
-                      <a:round/>
-                      <a:headEnd type="none" w="med" len="med"/>
-                      <a:tailEnd type="none" w="med" len="med"/>
-                    </a:lnR>
-                    <a:lnT w="6350" cap="flat" cmpd="sng" algn="ctr">
-                      <a:solidFill>
-                        <a:srgbClr val="D9D9DE"/>
-                      </a:solidFill>
-                      <a:prstDash val="solid"/>
-                      <a:round/>
-                      <a:headEnd type="none" w="med" len="med"/>
-                      <a:tailEnd type="none" w="med" len="med"/>
-                    </a:lnT>
-                    <a:lnB w="6350" cap="flat" cmpd="sng" algn="ctr">
-                      <a:solidFill>
-                        <a:srgbClr val="D9D9DE"/>
-                      </a:solidFill>
-                      <a:prstDash val="solid"/>
-                      <a:round/>
-                      <a:headEnd type="none" w="med" len="med"/>
-                      <a:tailEnd type="none" w="med" len="med"/>
-                    </a:lnB>
-                    <a:solidFill>
-                      <a:schemeClr val="bg2"/>
-                    </a:solidFill>
-                  </a:tcPr>
-                </a:tc>
-                <a:tc>
-                  <a:txBody>
-                    <a:bodyPr/>
-                    <a:lstStyle/>
-                    <a:p>
-                      <a:pPr indent="0" marL="0">
-                        <a:buNone/>
-                      </a:pPr>
-                      <a:r>
-                        <a:rPr lang="en-US" sz="1100" dirty="0">
-                          <a:solidFill>
-                            <a:schemeClr val="tx1"/>
-                          </a:solidFill>
-                        </a:rPr>
-                        <a:t>TC-14-010, 14-022</a:t>
-                      </a:r>
-                      <a:endParaRPr lang="en-US" sz="1100" dirty="0"/>
-                    </a:p>
-                  </a:txBody>
-                  <a:tcPr marL="45720" marR="45720" marT="45720" marB="45720">
-                    <a:lnL w="6350" cap="flat" cmpd="sng" algn="ctr">
-                      <a:solidFill>
-                        <a:srgbClr val="D9D9DE"/>
-                      </a:solidFill>
-                      <a:prstDash val="solid"/>
-                      <a:round/>
-                      <a:headEnd type="none" w="med" len="med"/>
-                      <a:tailEnd type="none" w="med" len="med"/>
-                    </a:lnL>
-                    <a:lnR w="6350" cap="flat" cmpd="sng" algn="ctr">
-                      <a:solidFill>
-                        <a:srgbClr val="D9D9DE"/>
-                      </a:solidFill>
-                      <a:prstDash val="solid"/>
-                      <a:round/>
-                      <a:headEnd type="none" w="med" len="med"/>
-                      <a:tailEnd type="none" w="med" len="med"/>
-                    </a:lnR>
-                    <a:lnT w="6350" cap="flat" cmpd="sng" algn="ctr">
-                      <a:solidFill>
-                        <a:srgbClr val="D9D9DE"/>
-                      </a:solidFill>
-                      <a:prstDash val="solid"/>
-                      <a:round/>
-                      <a:headEnd type="none" w="med" len="med"/>
-                      <a:tailEnd type="none" w="med" len="med"/>
-                    </a:lnT>
-                    <a:lnB w="6350" cap="flat" cmpd="sng" algn="ctr">
-                      <a:solidFill>
-                        <a:srgbClr val="D9D9DE"/>
-                      </a:solidFill>
-                      <a:prstDash val="solid"/>
-                      <a:round/>
-                      <a:headEnd type="none" w="med" len="med"/>
-                      <a:tailEnd type="none" w="med" len="med"/>
-                    </a:lnB>
-                    <a:solidFill>
-                      <a:schemeClr val="bg2"/>
-                    </a:solidFill>
-                  </a:tcPr>
-                </a:tc>
-                <a:tc>
-                  <a:txBody>
-                    <a:bodyPr/>
-                    <a:lstStyle/>
-                    <a:p>
-                      <a:pPr indent="0" marL="0">
-                        <a:buNone/>
-                      </a:pPr>
-                      <a:endParaRPr lang="en-US" sz="1100" dirty="0"/>
+                      <a:endParaRPr lang="en-US" sz="1150" dirty="0"/>
                     </a:p>
                   </a:txBody>
                   <a:tcPr marL="45720" marR="45720" marT="45720" marB="45720">
@@ -5351,14 +4429,14 @@
                         <a:buNone/>
                       </a:pPr>
                       <a:r>
-                        <a:rPr lang="en-US" sz="1100" b="1" dirty="0">
+                        <a:rPr lang="en-US" sz="1150" b="1" dirty="0">
                           <a:solidFill>
                             <a:schemeClr val="tx1"/>
                           </a:solidFill>
                         </a:rPr>
                         <a:t>8</a:t>
                       </a:r>
-                      <a:endParaRPr lang="en-US" sz="1100" dirty="0"/>
+                      <a:endParaRPr lang="en-US" sz="1150" dirty="0"/>
                     </a:p>
                   </a:txBody>
                   <a:tcPr marL="45720" marR="45720" marT="45720" marB="45720">
@@ -5412,14 +4490,14 @@
                         <a:buNone/>
                       </a:pPr>
                       <a:r>
-                        <a:rPr lang="en-US" sz="1100" b="1" dirty="0">
+                        <a:rPr lang="en-US" sz="1150" b="1" dirty="0">
                           <a:solidFill>
                             <a:schemeClr val="accent2"/>
                           </a:solidFill>
                         </a:rPr>
                         <a:t>App</a:t>
                       </a:r>
-                      <a:endParaRPr lang="en-US" sz="1100" dirty="0"/>
+                      <a:endParaRPr lang="en-US" sz="1150" dirty="0"/>
                     </a:p>
                   </a:txBody>
                   <a:tcPr marL="45720" marR="45720" marT="45720" marB="45720">
@@ -5473,14 +4551,14 @@
                         <a:buNone/>
                       </a:pPr>
                       <a:r>
-                        <a:rPr lang="en-US" sz="1100" dirty="0">
+                        <a:rPr lang="en-US" sz="1150" dirty="0">
                           <a:solidFill>
                             <a:schemeClr val="tx1"/>
                           </a:solidFill>
                         </a:rPr>
-                        <a:t>Re-open News</a:t>
+                        <a:t>Re-open the News tab</a:t>
                       </a:r>
-                      <a:endParaRPr lang="en-US" sz="1100" dirty="0"/>
+                      <a:endParaRPr lang="en-US" sz="1150" dirty="0"/>
                     </a:p>
                   </a:txBody>
                   <a:tcPr marL="45720" marR="45720" marT="45720" marB="45720">
@@ -5534,128 +4612,14 @@
                         <a:buNone/>
                       </a:pPr>
                       <a:r>
-                        <a:rPr lang="en-US" sz="1100" dirty="0">
+                        <a:rPr lang="en-US" sz="1150" dirty="0">
                           <a:solidFill>
                             <a:schemeClr val="tx1"/>
                           </a:solidFill>
                         </a:rPr>
-                        <a:t>Announcement gone</a:t>
+                        <a:t>The announcement is gone</a:t>
                       </a:r>
-                      <a:endParaRPr lang="en-US" sz="1100" dirty="0"/>
-                    </a:p>
-                  </a:txBody>
-                  <a:tcPr marL="45720" marR="45720" marT="45720" marB="45720">
-                    <a:lnL w="6350" cap="flat" cmpd="sng" algn="ctr">
-                      <a:solidFill>
-                        <a:srgbClr val="D9D9DE"/>
-                      </a:solidFill>
-                      <a:prstDash val="solid"/>
-                      <a:round/>
-                      <a:headEnd type="none" w="med" len="med"/>
-                      <a:tailEnd type="none" w="med" len="med"/>
-                    </a:lnL>
-                    <a:lnR w="6350" cap="flat" cmpd="sng" algn="ctr">
-                      <a:solidFill>
-                        <a:srgbClr val="D9D9DE"/>
-                      </a:solidFill>
-                      <a:prstDash val="solid"/>
-                      <a:round/>
-                      <a:headEnd type="none" w="med" len="med"/>
-                      <a:tailEnd type="none" w="med" len="med"/>
-                    </a:lnR>
-                    <a:lnT w="6350" cap="flat" cmpd="sng" algn="ctr">
-                      <a:solidFill>
-                        <a:srgbClr val="D9D9DE"/>
-                      </a:solidFill>
-                      <a:prstDash val="solid"/>
-                      <a:round/>
-                      <a:headEnd type="none" w="med" len="med"/>
-                      <a:tailEnd type="none" w="med" len="med"/>
-                    </a:lnT>
-                    <a:lnB w="6350" cap="flat" cmpd="sng" algn="ctr">
-                      <a:solidFill>
-                        <a:srgbClr val="D9D9DE"/>
-                      </a:solidFill>
-                      <a:prstDash val="solid"/>
-                      <a:round/>
-                      <a:headEnd type="none" w="med" len="med"/>
-                      <a:tailEnd type="none" w="med" len="med"/>
-                    </a:lnB>
-                    <a:solidFill>
-                      <a:schemeClr val="bg1"/>
-                    </a:solidFill>
-                  </a:tcPr>
-                </a:tc>
-                <a:tc>
-                  <a:txBody>
-                    <a:bodyPr/>
-                    <a:lstStyle/>
-                    <a:p>
-                      <a:pPr indent="0" marL="0">
-                        <a:buNone/>
-                      </a:pPr>
-                      <a:endParaRPr lang="en-US" sz="1100" dirty="0"/>
-                    </a:p>
-                  </a:txBody>
-                  <a:tcPr marL="45720" marR="45720" marT="45720" marB="45720">
-                    <a:lnL w="6350" cap="flat" cmpd="sng" algn="ctr">
-                      <a:solidFill>
-                        <a:srgbClr val="D9D9DE"/>
-                      </a:solidFill>
-                      <a:prstDash val="solid"/>
-                      <a:round/>
-                      <a:headEnd type="none" w="med" len="med"/>
-                      <a:tailEnd type="none" w="med" len="med"/>
-                    </a:lnL>
-                    <a:lnR w="6350" cap="flat" cmpd="sng" algn="ctr">
-                      <a:solidFill>
-                        <a:srgbClr val="D9D9DE"/>
-                      </a:solidFill>
-                      <a:prstDash val="solid"/>
-                      <a:round/>
-                      <a:headEnd type="none" w="med" len="med"/>
-                      <a:tailEnd type="none" w="med" len="med"/>
-                    </a:lnR>
-                    <a:lnT w="6350" cap="flat" cmpd="sng" algn="ctr">
-                      <a:solidFill>
-                        <a:srgbClr val="D9D9DE"/>
-                      </a:solidFill>
-                      <a:prstDash val="solid"/>
-                      <a:round/>
-                      <a:headEnd type="none" w="med" len="med"/>
-                      <a:tailEnd type="none" w="med" len="med"/>
-                    </a:lnT>
-                    <a:lnB w="6350" cap="flat" cmpd="sng" algn="ctr">
-                      <a:solidFill>
-                        <a:srgbClr val="D9D9DE"/>
-                      </a:solidFill>
-                      <a:prstDash val="solid"/>
-                      <a:round/>
-                      <a:headEnd type="none" w="med" len="med"/>
-                      <a:tailEnd type="none" w="med" len="med"/>
-                    </a:lnB>
-                    <a:solidFill>
-                      <a:schemeClr val="bg1"/>
-                    </a:solidFill>
-                  </a:tcPr>
-                </a:tc>
-                <a:tc>
-                  <a:txBody>
-                    <a:bodyPr/>
-                    <a:lstStyle/>
-                    <a:p>
-                      <a:pPr indent="0" marL="0">
-                        <a:buNone/>
-                      </a:pPr>
-                      <a:r>
-                        <a:rPr lang="en-US" sz="1100" dirty="0">
-                          <a:solidFill>
-                            <a:schemeClr val="tx1"/>
-                          </a:solidFill>
-                        </a:rPr>
-                        <a:t>M09-001</a:t>
-                      </a:r>
-                      <a:endParaRPr lang="en-US" sz="1100" dirty="0"/>
+                      <a:endParaRPr lang="en-US" sz="1150" dirty="0"/>
                     </a:p>
                   </a:txBody>
                   <a:tcPr marL="45720" marR="45720" marT="45720" marB="45720">
@@ -5713,8 +4677,8 @@
         </p:nvSpPr>
         <p:spPr>
           <a:xfrm>
-            <a:off x="548640" y="5120640"/>
-            <a:ext cx="11094415" cy="457200"/>
+            <a:off x="548640" y="5760720"/>
+            <a:ext cx="11094415" cy="274320"/>
           </a:xfrm>
           <a:prstGeom prst="rect">
             <a:avLst/>
@@ -5735,7 +4699,7 @@
                   <a:schemeClr val="accent4"/>
                 </a:solidFill>
               </a:rPr>
-              <a:t>Same table in the workbooks: web suite sheet 26 "E2E Journeys", app suite sheet 13.</a:t>
+              <a:t>Workbook sheet "23-E2E Journeys" - the same 8 steps, one row each.</a:t>
             </a:r>
             <a:endParaRPr lang="en-US" sz="1100" dirty="0"/>
           </a:p>
@@ -7197,7 +6161,7 @@
                   <a:schemeClr val="accent4"/>
                 </a:solidFill>
               </a:rPr>
-              <a:t>The two journeys test exactly that hand-off, step by step, and each step is mapped to the cases it proves in both suites.</a:t>
+              <a:t>The two journeys test exactly that hand-off. Both are test cases in the RoadSide web suite (sheet 23-E2E Journeys), written step by step.</a:t>
             </a:r>
             <a:endParaRPr lang="en-US" sz="1500" dirty="0"/>
           </a:p>
@@ -11983,7 +10947,7 @@
                   <a:schemeClr val="tx1"/>
                 </a:solidFill>
               </a:rPr>
-              <a:t>E2E-01: each step is mapped to the cases it proves</a:t>
+              <a:t>TC-23-001 in the RoadSide web suite: steps and expected results</a:t>
             </a:r>
             <a:endParaRPr lang="en-US" sz="2600" dirty="0"/>
           </a:p>
@@ -12004,7 +10968,7 @@
           </p:nvPr>
         </p:nvGraphicFramePr>
         <p:xfrm>
-          <a:off x="548640" y="1325880"/>
+          <a:off x="548640" y="1280160"/>
           <a:ext cx="11094415" cy="914400"/>
         </p:xfrm>
         <a:graphic>
@@ -12012,12 +10976,10 @@
             <a:tbl>
               <a:tblPr/>
               <a:tblGrid>
-                <a:gridCol w="411480"/>
-                <a:gridCol w="685800"/>
-                <a:gridCol w="3108960"/>
-                <a:gridCol w="2743200"/>
-                <a:gridCol w="2468880"/>
-                <a:gridCol w="1673352"/>
+                <a:gridCol w="502920"/>
+                <a:gridCol w="731520"/>
+                <a:gridCol w="5669280"/>
+                <a:gridCol w="4187952"/>
               </a:tblGrid>
               <a:tr h="0">
                 <a:tc>
@@ -12034,7 +10996,7 @@
                             <a:schemeClr val="bg1"/>
                           </a:solidFill>
                         </a:rPr>
-                        <a:t>#</a:t>
+                        <a:t>Step</a:t>
                       </a:r>
                       <a:endParaRPr lang="en-US" sz="1050" dirty="0"/>
                     </a:p>
@@ -12156,7 +11118,7 @@
                             <a:schemeClr val="bg1"/>
                           </a:solidFill>
                         </a:rPr>
-                        <a:t>Step</a:t>
+                        <a:t>Action</a:t>
                       </a:r>
                       <a:endParaRPr lang="en-US" sz="1050" dirty="0"/>
                     </a:p>
@@ -12217,7 +11179,7 @@
                             <a:schemeClr val="bg1"/>
                           </a:solidFill>
                         </a:rPr>
-                        <a:t>Checked</a:t>
+                        <a:t>Expected result</a:t>
                       </a:r>
                       <a:endParaRPr lang="en-US" sz="1050" dirty="0"/>
                     </a:p>
@@ -12261,128 +11223,6 @@
                     </a:lnB>
                     <a:solidFill>
                       <a:schemeClr val="tx2"/>
-                    </a:solidFill>
-                  </a:tcPr>
-                </a:tc>
-                <a:tc>
-                  <a:txBody>
-                    <a:bodyPr/>
-                    <a:lstStyle/>
-                    <a:p>
-                      <a:pPr indent="0" marL="0">
-                        <a:buNone/>
-                      </a:pPr>
-                      <a:r>
-                        <a:rPr lang="en-US" sz="1050" b="1" dirty="0">
-                          <a:solidFill>
-                            <a:schemeClr val="bg1"/>
-                          </a:solidFill>
-                        </a:rPr>
-                        <a:t>Web suite cases</a:t>
-                      </a:r>
-                      <a:endParaRPr lang="en-US" sz="1050" dirty="0"/>
-                    </a:p>
-                  </a:txBody>
-                  <a:tcPr marL="45720" marR="45720" marT="45720" marB="45720">
-                    <a:lnL w="6350" cap="flat" cmpd="sng" algn="ctr">
-                      <a:solidFill>
-                        <a:srgbClr val="D9D9DE"/>
-                      </a:solidFill>
-                      <a:prstDash val="solid"/>
-                      <a:round/>
-                      <a:headEnd type="none" w="med" len="med"/>
-                      <a:tailEnd type="none" w="med" len="med"/>
-                    </a:lnL>
-                    <a:lnR w="6350" cap="flat" cmpd="sng" algn="ctr">
-                      <a:solidFill>
-                        <a:srgbClr val="D9D9DE"/>
-                      </a:solidFill>
-                      <a:prstDash val="solid"/>
-                      <a:round/>
-                      <a:headEnd type="none" w="med" len="med"/>
-                      <a:tailEnd type="none" w="med" len="med"/>
-                    </a:lnR>
-                    <a:lnT w="6350" cap="flat" cmpd="sng" algn="ctr">
-                      <a:solidFill>
-                        <a:srgbClr val="D9D9DE"/>
-                      </a:solidFill>
-                      <a:prstDash val="solid"/>
-                      <a:round/>
-                      <a:headEnd type="none" w="med" len="med"/>
-                      <a:tailEnd type="none" w="med" len="med"/>
-                    </a:lnT>
-                    <a:lnB w="6350" cap="flat" cmpd="sng" algn="ctr">
-                      <a:solidFill>
-                        <a:srgbClr val="D9D9DE"/>
-                      </a:solidFill>
-                      <a:prstDash val="solid"/>
-                      <a:round/>
-                      <a:headEnd type="none" w="med" len="med"/>
-                      <a:tailEnd type="none" w="med" len="med"/>
-                    </a:lnB>
-                    <a:solidFill>
-                      <a:schemeClr val="accent1"/>
-                    </a:solidFill>
-                  </a:tcPr>
-                </a:tc>
-                <a:tc>
-                  <a:txBody>
-                    <a:bodyPr/>
-                    <a:lstStyle/>
-                    <a:p>
-                      <a:pPr indent="0" marL="0">
-                        <a:buNone/>
-                      </a:pPr>
-                      <a:r>
-                        <a:rPr lang="en-US" sz="1050" b="1" dirty="0">
-                          <a:solidFill>
-                            <a:schemeClr val="bg1"/>
-                          </a:solidFill>
-                        </a:rPr>
-                        <a:t>App suite cases</a:t>
-                      </a:r>
-                      <a:endParaRPr lang="en-US" sz="1050" dirty="0"/>
-                    </a:p>
-                  </a:txBody>
-                  <a:tcPr marL="45720" marR="45720" marT="45720" marB="45720">
-                    <a:lnL w="6350" cap="flat" cmpd="sng" algn="ctr">
-                      <a:solidFill>
-                        <a:srgbClr val="D9D9DE"/>
-                      </a:solidFill>
-                      <a:prstDash val="solid"/>
-                      <a:round/>
-                      <a:headEnd type="none" w="med" len="med"/>
-                      <a:tailEnd type="none" w="med" len="med"/>
-                    </a:lnL>
-                    <a:lnR w="6350" cap="flat" cmpd="sng" algn="ctr">
-                      <a:solidFill>
-                        <a:srgbClr val="D9D9DE"/>
-                      </a:solidFill>
-                      <a:prstDash val="solid"/>
-                      <a:round/>
-                      <a:headEnd type="none" w="med" len="med"/>
-                      <a:tailEnd type="none" w="med" len="med"/>
-                    </a:lnR>
-                    <a:lnT w="6350" cap="flat" cmpd="sng" algn="ctr">
-                      <a:solidFill>
-                        <a:srgbClr val="D9D9DE"/>
-                      </a:solidFill>
-                      <a:prstDash val="solid"/>
-                      <a:round/>
-                      <a:headEnd type="none" w="med" len="med"/>
-                      <a:tailEnd type="none" w="med" len="med"/>
-                    </a:lnT>
-                    <a:lnB w="6350" cap="flat" cmpd="sng" algn="ctr">
-                      <a:solidFill>
-                        <a:srgbClr val="D9D9DE"/>
-                      </a:solidFill>
-                      <a:prstDash val="solid"/>
-                      <a:round/>
-                      <a:headEnd type="none" w="med" len="med"/>
-                      <a:tailEnd type="none" w="med" len="med"/>
-                    </a:lnB>
-                    <a:solidFill>
-                      <a:schemeClr val="accent2"/>
                     </a:solidFill>
                   </a:tcPr>
                 </a:tc>
@@ -12524,7 +11364,7 @@
                             <a:schemeClr val="tx1"/>
                           </a:solidFill>
                         </a:rPr>
-                        <a:t>Driver signs in, truck chosen, Ready on</a:t>
+                        <a:t>Sign in as the driver, choose truck v3036, switch Ready on</a:t>
                       </a:r>
                       <a:endParaRPr lang="en-US" sz="1000" dirty="0"/>
                     </a:p>
@@ -12585,121 +11425,7 @@
                             <a:schemeClr val="tx1"/>
                           </a:solidFill>
                         </a:rPr>
-                        <a:t>Dashboard, VIN, Ready On</a:t>
-                      </a:r>
-                      <a:endParaRPr lang="en-US" sz="1000" dirty="0"/>
-                    </a:p>
-                  </a:txBody>
-                  <a:tcPr marL="45720" marR="45720" marT="45720" marB="45720">
-                    <a:lnL w="6350" cap="flat" cmpd="sng" algn="ctr">
-                      <a:solidFill>
-                        <a:srgbClr val="D9D9DE"/>
-                      </a:solidFill>
-                      <a:prstDash val="solid"/>
-                      <a:round/>
-                      <a:headEnd type="none" w="med" len="med"/>
-                      <a:tailEnd type="none" w="med" len="med"/>
-                    </a:lnL>
-                    <a:lnR w="6350" cap="flat" cmpd="sng" algn="ctr">
-                      <a:solidFill>
-                        <a:srgbClr val="D9D9DE"/>
-                      </a:solidFill>
-                      <a:prstDash val="solid"/>
-                      <a:round/>
-                      <a:headEnd type="none" w="med" len="med"/>
-                      <a:tailEnd type="none" w="med" len="med"/>
-                    </a:lnR>
-                    <a:lnT w="6350" cap="flat" cmpd="sng" algn="ctr">
-                      <a:solidFill>
-                        <a:srgbClr val="D9D9DE"/>
-                      </a:solidFill>
-                      <a:prstDash val="solid"/>
-                      <a:round/>
-                      <a:headEnd type="none" w="med" len="med"/>
-                      <a:tailEnd type="none" w="med" len="med"/>
-                    </a:lnT>
-                    <a:lnB w="6350" cap="flat" cmpd="sng" algn="ctr">
-                      <a:solidFill>
-                        <a:srgbClr val="D9D9DE"/>
-                      </a:solidFill>
-                      <a:prstDash val="solid"/>
-                      <a:round/>
-                      <a:headEnd type="none" w="med" len="med"/>
-                      <a:tailEnd type="none" w="med" len="med"/>
-                    </a:lnB>
-                    <a:solidFill>
-                      <a:schemeClr val="bg2"/>
-                    </a:solidFill>
-                  </a:tcPr>
-                </a:tc>
-                <a:tc>
-                  <a:txBody>
-                    <a:bodyPr/>
-                    <a:lstStyle/>
-                    <a:p>
-                      <a:pPr indent="0" marL="0">
-                        <a:buNone/>
-                      </a:pPr>
-                      <a:endParaRPr lang="en-US" sz="1000" dirty="0"/>
-                    </a:p>
-                  </a:txBody>
-                  <a:tcPr marL="45720" marR="45720" marT="45720" marB="45720">
-                    <a:lnL w="6350" cap="flat" cmpd="sng" algn="ctr">
-                      <a:solidFill>
-                        <a:srgbClr val="D9D9DE"/>
-                      </a:solidFill>
-                      <a:prstDash val="solid"/>
-                      <a:round/>
-                      <a:headEnd type="none" w="med" len="med"/>
-                      <a:tailEnd type="none" w="med" len="med"/>
-                    </a:lnL>
-                    <a:lnR w="6350" cap="flat" cmpd="sng" algn="ctr">
-                      <a:solidFill>
-                        <a:srgbClr val="D9D9DE"/>
-                      </a:solidFill>
-                      <a:prstDash val="solid"/>
-                      <a:round/>
-                      <a:headEnd type="none" w="med" len="med"/>
-                      <a:tailEnd type="none" w="med" len="med"/>
-                    </a:lnR>
-                    <a:lnT w="6350" cap="flat" cmpd="sng" algn="ctr">
-                      <a:solidFill>
-                        <a:srgbClr val="D9D9DE"/>
-                      </a:solidFill>
-                      <a:prstDash val="solid"/>
-                      <a:round/>
-                      <a:headEnd type="none" w="med" len="med"/>
-                      <a:tailEnd type="none" w="med" len="med"/>
-                    </a:lnT>
-                    <a:lnB w="6350" cap="flat" cmpd="sng" algn="ctr">
-                      <a:solidFill>
-                        <a:srgbClr val="D9D9DE"/>
-                      </a:solidFill>
-                      <a:prstDash val="solid"/>
-                      <a:round/>
-                      <a:headEnd type="none" w="med" len="med"/>
-                      <a:tailEnd type="none" w="med" len="med"/>
-                    </a:lnB>
-                    <a:solidFill>
-                      <a:schemeClr val="bg2"/>
-                    </a:solidFill>
-                  </a:tcPr>
-                </a:tc>
-                <a:tc>
-                  <a:txBody>
-                    <a:bodyPr/>
-                    <a:lstStyle/>
-                    <a:p>
-                      <a:pPr indent="0" marL="0">
-                        <a:buNone/>
-                      </a:pPr>
-                      <a:r>
-                        <a:rPr lang="en-US" sz="1000" dirty="0">
-                          <a:solidFill>
-                            <a:schemeClr val="tx1"/>
-                          </a:solidFill>
-                        </a:rPr>
-                        <a:t>M01-002, M02-002, M03-001/002</a:t>
+                        <a:t>Dashboard shows VIN v3036 and Ready = On</a:t>
                       </a:r>
                       <a:endParaRPr lang="en-US" sz="1000" dirty="0"/>
                     </a:p>
@@ -12884,7 +11610,7 @@
                             <a:schemeClr val="tx1"/>
                           </a:solidFill>
                         </a:rPr>
-                        <a:t>Create Basic Repair job, Thai address</a:t>
+                        <a:t>Sign in as the agent and create a Basic Repair job: client Honda, program HOT UAT Program, customer [AUTO-TEST] Jaidee, Thai incident address (ถ.ราชดำริ หน้าสวนลุมพินี, ปทุมวัน, กทม.), licence 1กข 2345, location note and service condition; Save</a:t>
                       </a:r>
                       <a:endParaRPr lang="en-US" sz="1000" dirty="0"/>
                     </a:p>
@@ -12945,122 +11671,8 @@
                             <a:schemeClr val="tx1"/>
                           </a:solidFill>
                         </a:rPr>
-                        <a:t>Job number; values saved</a:t>
+                        <a:t>Job number is issued; the values are kept after reload</a:t>
                       </a:r>
-                      <a:endParaRPr lang="en-US" sz="1000" dirty="0"/>
-                    </a:p>
-                  </a:txBody>
-                  <a:tcPr marL="45720" marR="45720" marT="45720" marB="45720">
-                    <a:lnL w="6350" cap="flat" cmpd="sng" algn="ctr">
-                      <a:solidFill>
-                        <a:srgbClr val="D9D9DE"/>
-                      </a:solidFill>
-                      <a:prstDash val="solid"/>
-                      <a:round/>
-                      <a:headEnd type="none" w="med" len="med"/>
-                      <a:tailEnd type="none" w="med" len="med"/>
-                    </a:lnL>
-                    <a:lnR w="6350" cap="flat" cmpd="sng" algn="ctr">
-                      <a:solidFill>
-                        <a:srgbClr val="D9D9DE"/>
-                      </a:solidFill>
-                      <a:prstDash val="solid"/>
-                      <a:round/>
-                      <a:headEnd type="none" w="med" len="med"/>
-                      <a:tailEnd type="none" w="med" len="med"/>
-                    </a:lnR>
-                    <a:lnT w="6350" cap="flat" cmpd="sng" algn="ctr">
-                      <a:solidFill>
-                        <a:srgbClr val="D9D9DE"/>
-                      </a:solidFill>
-                      <a:prstDash val="solid"/>
-                      <a:round/>
-                      <a:headEnd type="none" w="med" len="med"/>
-                      <a:tailEnd type="none" w="med" len="med"/>
-                    </a:lnT>
-                    <a:lnB w="6350" cap="flat" cmpd="sng" algn="ctr">
-                      <a:solidFill>
-                        <a:srgbClr val="D9D9DE"/>
-                      </a:solidFill>
-                      <a:prstDash val="solid"/>
-                      <a:round/>
-                      <a:headEnd type="none" w="med" len="med"/>
-                      <a:tailEnd type="none" w="med" len="med"/>
-                    </a:lnB>
-                    <a:solidFill>
-                      <a:schemeClr val="bg1"/>
-                    </a:solidFill>
-                  </a:tcPr>
-                </a:tc>
-                <a:tc>
-                  <a:txBody>
-                    <a:bodyPr/>
-                    <a:lstStyle/>
-                    <a:p>
-                      <a:pPr indent="0" marL="0">
-                        <a:buNone/>
-                      </a:pPr>
-                      <a:r>
-                        <a:rPr lang="en-US" sz="1000" dirty="0">
-                          <a:solidFill>
-                            <a:schemeClr val="tx1"/>
-                          </a:solidFill>
-                        </a:rPr>
-                        <a:t>TC-01-001, 03-004/010/012/013/026/029/030</a:t>
-                      </a:r>
-                      <a:endParaRPr lang="en-US" sz="1000" dirty="0"/>
-                    </a:p>
-                  </a:txBody>
-                  <a:tcPr marL="45720" marR="45720" marT="45720" marB="45720">
-                    <a:lnL w="6350" cap="flat" cmpd="sng" algn="ctr">
-                      <a:solidFill>
-                        <a:srgbClr val="D9D9DE"/>
-                      </a:solidFill>
-                      <a:prstDash val="solid"/>
-                      <a:round/>
-                      <a:headEnd type="none" w="med" len="med"/>
-                      <a:tailEnd type="none" w="med" len="med"/>
-                    </a:lnL>
-                    <a:lnR w="6350" cap="flat" cmpd="sng" algn="ctr">
-                      <a:solidFill>
-                        <a:srgbClr val="D9D9DE"/>
-                      </a:solidFill>
-                      <a:prstDash val="solid"/>
-                      <a:round/>
-                      <a:headEnd type="none" w="med" len="med"/>
-                      <a:tailEnd type="none" w="med" len="med"/>
-                    </a:lnR>
-                    <a:lnT w="6350" cap="flat" cmpd="sng" algn="ctr">
-                      <a:solidFill>
-                        <a:srgbClr val="D9D9DE"/>
-                      </a:solidFill>
-                      <a:prstDash val="solid"/>
-                      <a:round/>
-                      <a:headEnd type="none" w="med" len="med"/>
-                      <a:tailEnd type="none" w="med" len="med"/>
-                    </a:lnT>
-                    <a:lnB w="6350" cap="flat" cmpd="sng" algn="ctr">
-                      <a:solidFill>
-                        <a:srgbClr val="D9D9DE"/>
-                      </a:solidFill>
-                      <a:prstDash val="solid"/>
-                      <a:round/>
-                      <a:headEnd type="none" w="med" len="med"/>
-                      <a:tailEnd type="none" w="med" len="med"/>
-                    </a:lnB>
-                    <a:solidFill>
-                      <a:schemeClr val="bg1"/>
-                    </a:solidFill>
-                  </a:tcPr>
-                </a:tc>
-                <a:tc>
-                  <a:txBody>
-                    <a:bodyPr/>
-                    <a:lstStyle/>
-                    <a:p>
-                      <a:pPr indent="0" marL="0">
-                        <a:buNone/>
-                      </a:pPr>
                       <a:endParaRPr lang="en-US" sz="1000" dirty="0"/>
                     </a:p>
                   </a:txBody>
@@ -13244,7 +11856,7 @@
                             <a:schemeClr val="tx1"/>
                           </a:solidFill>
                         </a:rPr>
-                        <a:t>Set incident pin</a:t>
+                        <a:t>Set the incident pin on the map at 13.7334, 100.5408</a:t>
                       </a:r>
                       <a:endParaRPr lang="en-US" sz="1000" dirty="0"/>
                     </a:p>
@@ -13305,122 +11917,8 @@
                             <a:schemeClr val="tx1"/>
                           </a:solidFill>
                         </a:rPr>
-                        <a:t>Location saved</a:t>
+                        <a:t>Incident location is saved</a:t>
                       </a:r>
-                      <a:endParaRPr lang="en-US" sz="1000" dirty="0"/>
-                    </a:p>
-                  </a:txBody>
-                  <a:tcPr marL="45720" marR="45720" marT="45720" marB="45720">
-                    <a:lnL w="6350" cap="flat" cmpd="sng" algn="ctr">
-                      <a:solidFill>
-                        <a:srgbClr val="D9D9DE"/>
-                      </a:solidFill>
-                      <a:prstDash val="solid"/>
-                      <a:round/>
-                      <a:headEnd type="none" w="med" len="med"/>
-                      <a:tailEnd type="none" w="med" len="med"/>
-                    </a:lnL>
-                    <a:lnR w="6350" cap="flat" cmpd="sng" algn="ctr">
-                      <a:solidFill>
-                        <a:srgbClr val="D9D9DE"/>
-                      </a:solidFill>
-                      <a:prstDash val="solid"/>
-                      <a:round/>
-                      <a:headEnd type="none" w="med" len="med"/>
-                      <a:tailEnd type="none" w="med" len="med"/>
-                    </a:lnR>
-                    <a:lnT w="6350" cap="flat" cmpd="sng" algn="ctr">
-                      <a:solidFill>
-                        <a:srgbClr val="D9D9DE"/>
-                      </a:solidFill>
-                      <a:prstDash val="solid"/>
-                      <a:round/>
-                      <a:headEnd type="none" w="med" len="med"/>
-                      <a:tailEnd type="none" w="med" len="med"/>
-                    </a:lnT>
-                    <a:lnB w="6350" cap="flat" cmpd="sng" algn="ctr">
-                      <a:solidFill>
-                        <a:srgbClr val="D9D9DE"/>
-                      </a:solidFill>
-                      <a:prstDash val="solid"/>
-                      <a:round/>
-                      <a:headEnd type="none" w="med" len="med"/>
-                      <a:tailEnd type="none" w="med" len="med"/>
-                    </a:lnB>
-                    <a:solidFill>
-                      <a:schemeClr val="bg2"/>
-                    </a:solidFill>
-                  </a:tcPr>
-                </a:tc>
-                <a:tc>
-                  <a:txBody>
-                    <a:bodyPr/>
-                    <a:lstStyle/>
-                    <a:p>
-                      <a:pPr indent="0" marL="0">
-                        <a:buNone/>
-                      </a:pPr>
-                      <a:r>
-                        <a:rPr lang="en-US" sz="1000" dirty="0">
-                          <a:solidFill>
-                            <a:schemeClr val="tx1"/>
-                          </a:solidFill>
-                        </a:rPr>
-                        <a:t>TC-04-004</a:t>
-                      </a:r>
-                      <a:endParaRPr lang="en-US" sz="1000" dirty="0"/>
-                    </a:p>
-                  </a:txBody>
-                  <a:tcPr marL="45720" marR="45720" marT="45720" marB="45720">
-                    <a:lnL w="6350" cap="flat" cmpd="sng" algn="ctr">
-                      <a:solidFill>
-                        <a:srgbClr val="D9D9DE"/>
-                      </a:solidFill>
-                      <a:prstDash val="solid"/>
-                      <a:round/>
-                      <a:headEnd type="none" w="med" len="med"/>
-                      <a:tailEnd type="none" w="med" len="med"/>
-                    </a:lnL>
-                    <a:lnR w="6350" cap="flat" cmpd="sng" algn="ctr">
-                      <a:solidFill>
-                        <a:srgbClr val="D9D9DE"/>
-                      </a:solidFill>
-                      <a:prstDash val="solid"/>
-                      <a:round/>
-                      <a:headEnd type="none" w="med" len="med"/>
-                      <a:tailEnd type="none" w="med" len="med"/>
-                    </a:lnR>
-                    <a:lnT w="6350" cap="flat" cmpd="sng" algn="ctr">
-                      <a:solidFill>
-                        <a:srgbClr val="D9D9DE"/>
-                      </a:solidFill>
-                      <a:prstDash val="solid"/>
-                      <a:round/>
-                      <a:headEnd type="none" w="med" len="med"/>
-                      <a:tailEnd type="none" w="med" len="med"/>
-                    </a:lnT>
-                    <a:lnB w="6350" cap="flat" cmpd="sng" algn="ctr">
-                      <a:solidFill>
-                        <a:srgbClr val="D9D9DE"/>
-                      </a:solidFill>
-                      <a:prstDash val="solid"/>
-                      <a:round/>
-                      <a:headEnd type="none" w="med" len="med"/>
-                      <a:tailEnd type="none" w="med" len="med"/>
-                    </a:lnB>
-                    <a:solidFill>
-                      <a:schemeClr val="bg2"/>
-                    </a:solidFill>
-                  </a:tcPr>
-                </a:tc>
-                <a:tc>
-                  <a:txBody>
-                    <a:bodyPr/>
-                    <a:lstStyle/>
-                    <a:p>
-                      <a:pPr indent="0" marL="0">
-                        <a:buNone/>
-                      </a:pPr>
                       <a:endParaRPr lang="en-US" sz="1000" dirty="0"/>
                     </a:p>
                   </a:txBody>
@@ -13604,7 +12102,7 @@
                             <a:schemeClr val="tx1"/>
                           </a:solidFill>
                         </a:rPr>
-                        <a:t>Assign truck v3036, Dispatch</a:t>
+                        <a:t>Assign truck v3036 and click Dispatch</a:t>
                       </a:r>
                       <a:endParaRPr lang="en-US" sz="1000" dirty="0"/>
                     </a:p>
@@ -13665,122 +12163,8 @@
                             <a:schemeClr val="tx1"/>
                           </a:solidFill>
                         </a:rPr>
-                        <a:t>Dispatch time; status OPEN</a:t>
+                        <a:t>Truck and dispatch time are saved; status stays OPEN</a:t>
                       </a:r>
-                      <a:endParaRPr lang="en-US" sz="1000" dirty="0"/>
-                    </a:p>
-                  </a:txBody>
-                  <a:tcPr marL="45720" marR="45720" marT="45720" marB="45720">
-                    <a:lnL w="6350" cap="flat" cmpd="sng" algn="ctr">
-                      <a:solidFill>
-                        <a:srgbClr val="D9D9DE"/>
-                      </a:solidFill>
-                      <a:prstDash val="solid"/>
-                      <a:round/>
-                      <a:headEnd type="none" w="med" len="med"/>
-                      <a:tailEnd type="none" w="med" len="med"/>
-                    </a:lnL>
-                    <a:lnR w="6350" cap="flat" cmpd="sng" algn="ctr">
-                      <a:solidFill>
-                        <a:srgbClr val="D9D9DE"/>
-                      </a:solidFill>
-                      <a:prstDash val="solid"/>
-                      <a:round/>
-                      <a:headEnd type="none" w="med" len="med"/>
-                      <a:tailEnd type="none" w="med" len="med"/>
-                    </a:lnR>
-                    <a:lnT w="6350" cap="flat" cmpd="sng" algn="ctr">
-                      <a:solidFill>
-                        <a:srgbClr val="D9D9DE"/>
-                      </a:solidFill>
-                      <a:prstDash val="solid"/>
-                      <a:round/>
-                      <a:headEnd type="none" w="med" len="med"/>
-                      <a:tailEnd type="none" w="med" len="med"/>
-                    </a:lnT>
-                    <a:lnB w="6350" cap="flat" cmpd="sng" algn="ctr">
-                      <a:solidFill>
-                        <a:srgbClr val="D9D9DE"/>
-                      </a:solidFill>
-                      <a:prstDash val="solid"/>
-                      <a:round/>
-                      <a:headEnd type="none" w="med" len="med"/>
-                      <a:tailEnd type="none" w="med" len="med"/>
-                    </a:lnB>
-                    <a:solidFill>
-                      <a:schemeClr val="bg1"/>
-                    </a:solidFill>
-                  </a:tcPr>
-                </a:tc>
-                <a:tc>
-                  <a:txBody>
-                    <a:bodyPr/>
-                    <a:lstStyle/>
-                    <a:p>
-                      <a:pPr indent="0" marL="0">
-                        <a:buNone/>
-                      </a:pPr>
-                      <a:r>
-                        <a:rPr lang="en-US" sz="1000" dirty="0">
-                          <a:solidFill>
-                            <a:schemeClr val="tx1"/>
-                          </a:solidFill>
-                        </a:rPr>
-                        <a:t>TC-04-019, 04-022, 04-045</a:t>
-                      </a:r>
-                      <a:endParaRPr lang="en-US" sz="1000" dirty="0"/>
-                    </a:p>
-                  </a:txBody>
-                  <a:tcPr marL="45720" marR="45720" marT="45720" marB="45720">
-                    <a:lnL w="6350" cap="flat" cmpd="sng" algn="ctr">
-                      <a:solidFill>
-                        <a:srgbClr val="D9D9DE"/>
-                      </a:solidFill>
-                      <a:prstDash val="solid"/>
-                      <a:round/>
-                      <a:headEnd type="none" w="med" len="med"/>
-                      <a:tailEnd type="none" w="med" len="med"/>
-                    </a:lnL>
-                    <a:lnR w="6350" cap="flat" cmpd="sng" algn="ctr">
-                      <a:solidFill>
-                        <a:srgbClr val="D9D9DE"/>
-                      </a:solidFill>
-                      <a:prstDash val="solid"/>
-                      <a:round/>
-                      <a:headEnd type="none" w="med" len="med"/>
-                      <a:tailEnd type="none" w="med" len="med"/>
-                    </a:lnR>
-                    <a:lnT w="6350" cap="flat" cmpd="sng" algn="ctr">
-                      <a:solidFill>
-                        <a:srgbClr val="D9D9DE"/>
-                      </a:solidFill>
-                      <a:prstDash val="solid"/>
-                      <a:round/>
-                      <a:headEnd type="none" w="med" len="med"/>
-                      <a:tailEnd type="none" w="med" len="med"/>
-                    </a:lnT>
-                    <a:lnB w="6350" cap="flat" cmpd="sng" algn="ctr">
-                      <a:solidFill>
-                        <a:srgbClr val="D9D9DE"/>
-                      </a:solidFill>
-                      <a:prstDash val="solid"/>
-                      <a:round/>
-                      <a:headEnd type="none" w="med" len="med"/>
-                      <a:tailEnd type="none" w="med" len="med"/>
-                    </a:lnB>
-                    <a:solidFill>
-                      <a:schemeClr val="bg1"/>
-                    </a:solidFill>
-                  </a:tcPr>
-                </a:tc>
-                <a:tc>
-                  <a:txBody>
-                    <a:bodyPr/>
-                    <a:lstStyle/>
-                    <a:p>
-                      <a:pPr indent="0" marL="0">
-                        <a:buNone/>
-                      </a:pPr>
                       <a:endParaRPr lang="en-US" sz="1000" dirty="0"/>
                     </a:p>
                   </a:txBody>
@@ -13964,7 +12348,7 @@
                             <a:schemeClr val="tx1"/>
                           </a:solidFill>
                         </a:rPr>
-                        <a:t>Job card appears without refresh</a:t>
+                        <a:t>Wait on the dashboard without refreshing</a:t>
                       </a:r>
                       <a:endParaRPr lang="en-US" sz="1000" dirty="0"/>
                     </a:p>
@@ -14025,129 +12409,7 @@
                             <a:schemeClr val="tx1"/>
                           </a:solidFill>
                         </a:rPr>
-                        <a:t>Same job no.; &gt; 2 km</a:t>
-                      </a:r>
-                      <a:endParaRPr lang="en-US" sz="1000" dirty="0"/>
-                    </a:p>
-                  </a:txBody>
-                  <a:tcPr marL="45720" marR="45720" marT="45720" marB="45720">
-                    <a:lnL w="6350" cap="flat" cmpd="sng" algn="ctr">
-                      <a:solidFill>
-                        <a:srgbClr val="D9D9DE"/>
-                      </a:solidFill>
-                      <a:prstDash val="solid"/>
-                      <a:round/>
-                      <a:headEnd type="none" w="med" len="med"/>
-                      <a:tailEnd type="none" w="med" len="med"/>
-                    </a:lnL>
-                    <a:lnR w="6350" cap="flat" cmpd="sng" algn="ctr">
-                      <a:solidFill>
-                        <a:srgbClr val="D9D9DE"/>
-                      </a:solidFill>
-                      <a:prstDash val="solid"/>
-                      <a:round/>
-                      <a:headEnd type="none" w="med" len="med"/>
-                      <a:tailEnd type="none" w="med" len="med"/>
-                    </a:lnR>
-                    <a:lnT w="6350" cap="flat" cmpd="sng" algn="ctr">
-                      <a:solidFill>
-                        <a:srgbClr val="D9D9DE"/>
-                      </a:solidFill>
-                      <a:prstDash val="solid"/>
-                      <a:round/>
-                      <a:headEnd type="none" w="med" len="med"/>
-                      <a:tailEnd type="none" w="med" len="med"/>
-                    </a:lnT>
-                    <a:lnB w="6350" cap="flat" cmpd="sng" algn="ctr">
-                      <a:solidFill>
-                        <a:srgbClr val="D9D9DE"/>
-                      </a:solidFill>
-                      <a:prstDash val="solid"/>
-                      <a:round/>
-                      <a:headEnd type="none" w="med" len="med"/>
-                      <a:tailEnd type="none" w="med" len="med"/>
-                    </a:lnB>
-                    <a:solidFill>
-                      <a:schemeClr val="bg2"/>
-                    </a:solidFill>
-                  </a:tcPr>
-                </a:tc>
-                <a:tc>
-                  <a:txBody>
-                    <a:bodyPr/>
-                    <a:lstStyle/>
-                    <a:p>
-                      <a:pPr indent="0" marL="0">
-                        <a:buNone/>
-                      </a:pPr>
-                      <a:r>
-                        <a:rPr lang="en-US" sz="1000" dirty="0">
-                          <a:solidFill>
-                            <a:schemeClr val="tx1"/>
-                          </a:solidFill>
-                        </a:rPr>
-                        <a:t>TC-04-025, 04-046</a:t>
-                      </a:r>
-                      <a:endParaRPr lang="en-US" sz="1000" dirty="0"/>
-                    </a:p>
-                  </a:txBody>
-                  <a:tcPr marL="45720" marR="45720" marT="45720" marB="45720">
-                    <a:lnL w="6350" cap="flat" cmpd="sng" algn="ctr">
-                      <a:solidFill>
-                        <a:srgbClr val="D9D9DE"/>
-                      </a:solidFill>
-                      <a:prstDash val="solid"/>
-                      <a:round/>
-                      <a:headEnd type="none" w="med" len="med"/>
-                      <a:tailEnd type="none" w="med" len="med"/>
-                    </a:lnL>
-                    <a:lnR w="6350" cap="flat" cmpd="sng" algn="ctr">
-                      <a:solidFill>
-                        <a:srgbClr val="D9D9DE"/>
-                      </a:solidFill>
-                      <a:prstDash val="solid"/>
-                      <a:round/>
-                      <a:headEnd type="none" w="med" len="med"/>
-                      <a:tailEnd type="none" w="med" len="med"/>
-                    </a:lnR>
-                    <a:lnT w="6350" cap="flat" cmpd="sng" algn="ctr">
-                      <a:solidFill>
-                        <a:srgbClr val="D9D9DE"/>
-                      </a:solidFill>
-                      <a:prstDash val="solid"/>
-                      <a:round/>
-                      <a:headEnd type="none" w="med" len="med"/>
-                      <a:tailEnd type="none" w="med" len="med"/>
-                    </a:lnT>
-                    <a:lnB w="6350" cap="flat" cmpd="sng" algn="ctr">
-                      <a:solidFill>
-                        <a:srgbClr val="D9D9DE"/>
-                      </a:solidFill>
-                      <a:prstDash val="solid"/>
-                      <a:round/>
-                      <a:headEnd type="none" w="med" len="med"/>
-                      <a:tailEnd type="none" w="med" len="med"/>
-                    </a:lnB>
-                    <a:solidFill>
-                      <a:schemeClr val="bg2"/>
-                    </a:solidFill>
-                  </a:tcPr>
-                </a:tc>
-                <a:tc>
-                  <a:txBody>
-                    <a:bodyPr/>
-                    <a:lstStyle/>
-                    <a:p>
-                      <a:pPr indent="0" marL="0">
-                        <a:buNone/>
-                      </a:pPr>
-                      <a:r>
-                        <a:rPr lang="en-US" sz="1000" dirty="0">
-                          <a:solidFill>
-                            <a:schemeClr val="tx1"/>
-                          </a:solidFill>
-                        </a:rPr>
-                        <a:t>M04-001, M04-002</a:t>
+                        <a:t>A job card with the same job number appears, more than 2 km away (9.70 km on 20 Oct)</a:t>
                       </a:r>
                       <a:endParaRPr lang="en-US" sz="1000" dirty="0"/>
                     </a:p>
@@ -14332,7 +12594,7 @@
                             <a:schemeClr val="tx1"/>
                           </a:solidFill>
                         </a:rPr>
-                        <a:t>Take Job</a:t>
+                        <a:t>Open the job and tap Take Job</a:t>
                       </a:r>
                       <a:endParaRPr lang="en-US" sz="1000" dirty="0"/>
                     </a:p>
@@ -14393,129 +12655,7 @@
                             <a:schemeClr val="tx1"/>
                           </a:solidFill>
                         </a:rPr>
-                        <a:t>Portal accept time; ONPROCESS</a:t>
-                      </a:r>
-                      <a:endParaRPr lang="en-US" sz="1000" dirty="0"/>
-                    </a:p>
-                  </a:txBody>
-                  <a:tcPr marL="45720" marR="45720" marT="45720" marB="45720">
-                    <a:lnL w="6350" cap="flat" cmpd="sng" algn="ctr">
-                      <a:solidFill>
-                        <a:srgbClr val="D9D9DE"/>
-                      </a:solidFill>
-                      <a:prstDash val="solid"/>
-                      <a:round/>
-                      <a:headEnd type="none" w="med" len="med"/>
-                      <a:tailEnd type="none" w="med" len="med"/>
-                    </a:lnL>
-                    <a:lnR w="6350" cap="flat" cmpd="sng" algn="ctr">
-                      <a:solidFill>
-                        <a:srgbClr val="D9D9DE"/>
-                      </a:solidFill>
-                      <a:prstDash val="solid"/>
-                      <a:round/>
-                      <a:headEnd type="none" w="med" len="med"/>
-                      <a:tailEnd type="none" w="med" len="med"/>
-                    </a:lnR>
-                    <a:lnT w="6350" cap="flat" cmpd="sng" algn="ctr">
-                      <a:solidFill>
-                        <a:srgbClr val="D9D9DE"/>
-                      </a:solidFill>
-                      <a:prstDash val="solid"/>
-                      <a:round/>
-                      <a:headEnd type="none" w="med" len="med"/>
-                      <a:tailEnd type="none" w="med" len="med"/>
-                    </a:lnT>
-                    <a:lnB w="6350" cap="flat" cmpd="sng" algn="ctr">
-                      <a:solidFill>
-                        <a:srgbClr val="D9D9DE"/>
-                      </a:solidFill>
-                      <a:prstDash val="solid"/>
-                      <a:round/>
-                      <a:headEnd type="none" w="med" len="med"/>
-                      <a:tailEnd type="none" w="med" len="med"/>
-                    </a:lnB>
-                    <a:solidFill>
-                      <a:schemeClr val="bg1"/>
-                    </a:solidFill>
-                  </a:tcPr>
-                </a:tc>
-                <a:tc>
-                  <a:txBody>
-                    <a:bodyPr/>
-                    <a:lstStyle/>
-                    <a:p>
-                      <a:pPr indent="0" marL="0">
-                        <a:buNone/>
-                      </a:pPr>
-                      <a:r>
-                        <a:rPr lang="en-US" sz="1000" dirty="0">
-                          <a:solidFill>
-                            <a:schemeClr val="tx1"/>
-                          </a:solidFill>
-                        </a:rPr>
-                        <a:t>TC-05-019</a:t>
-                      </a:r>
-                      <a:endParaRPr lang="en-US" sz="1000" dirty="0"/>
-                    </a:p>
-                  </a:txBody>
-                  <a:tcPr marL="45720" marR="45720" marT="45720" marB="45720">
-                    <a:lnL w="6350" cap="flat" cmpd="sng" algn="ctr">
-                      <a:solidFill>
-                        <a:srgbClr val="D9D9DE"/>
-                      </a:solidFill>
-                      <a:prstDash val="solid"/>
-                      <a:round/>
-                      <a:headEnd type="none" w="med" len="med"/>
-                      <a:tailEnd type="none" w="med" len="med"/>
-                    </a:lnL>
-                    <a:lnR w="6350" cap="flat" cmpd="sng" algn="ctr">
-                      <a:solidFill>
-                        <a:srgbClr val="D9D9DE"/>
-                      </a:solidFill>
-                      <a:prstDash val="solid"/>
-                      <a:round/>
-                      <a:headEnd type="none" w="med" len="med"/>
-                      <a:tailEnd type="none" w="med" len="med"/>
-                    </a:lnR>
-                    <a:lnT w="6350" cap="flat" cmpd="sng" algn="ctr">
-                      <a:solidFill>
-                        <a:srgbClr val="D9D9DE"/>
-                      </a:solidFill>
-                      <a:prstDash val="solid"/>
-                      <a:round/>
-                      <a:headEnd type="none" w="med" len="med"/>
-                      <a:tailEnd type="none" w="med" len="med"/>
-                    </a:lnT>
-                    <a:lnB w="6350" cap="flat" cmpd="sng" algn="ctr">
-                      <a:solidFill>
-                        <a:srgbClr val="D9D9DE"/>
-                      </a:solidFill>
-                      <a:prstDash val="solid"/>
-                      <a:round/>
-                      <a:headEnd type="none" w="med" len="med"/>
-                      <a:tailEnd type="none" w="med" len="med"/>
-                    </a:lnB>
-                    <a:solidFill>
-                      <a:schemeClr val="bg1"/>
-                    </a:solidFill>
-                  </a:tcPr>
-                </a:tc>
-                <a:tc>
-                  <a:txBody>
-                    <a:bodyPr/>
-                    <a:lstStyle/>
-                    <a:p>
-                      <a:pPr indent="0" marL="0">
-                        <a:buNone/>
-                      </a:pPr>
-                      <a:r>
-                        <a:rPr lang="en-US" sz="1000" dirty="0">
-                          <a:solidFill>
-                            <a:schemeClr val="tx1"/>
-                          </a:solidFill>
-                        </a:rPr>
-                        <a:t>M04-003</a:t>
+                        <a:t>Job is accepted; the portal shows the accept time and status ONPROCESS</a:t>
                       </a:r>
                       <a:endParaRPr lang="en-US" sz="1000" dirty="0"/>
                     </a:p>
@@ -14700,7 +12840,7 @@
                             <a:schemeClr val="tx1"/>
                           </a:solidFill>
                         </a:rPr>
-                        <a:t>Drive ~5 km by road</a:t>
+                        <a:t>Drive ~5 km by road to the customer (GPS point every ~150 m: Victory Monument - Phaya Thai - Rama I - Ratchadamri)</a:t>
                       </a:r>
                       <a:endParaRPr lang="en-US" sz="1000" dirty="0"/>
                     </a:p>
@@ -14761,121 +12901,7 @@
                             <a:schemeClr val="tx1"/>
                           </a:solidFill>
                         </a:rPr>
-                        <a:t>Road distance &gt; 2 km</a:t>
-                      </a:r>
-                      <a:endParaRPr lang="en-US" sz="1000" dirty="0"/>
-                    </a:p>
-                  </a:txBody>
-                  <a:tcPr marL="45720" marR="45720" marT="45720" marB="45720">
-                    <a:lnL w="6350" cap="flat" cmpd="sng" algn="ctr">
-                      <a:solidFill>
-                        <a:srgbClr val="D9D9DE"/>
-                      </a:solidFill>
-                      <a:prstDash val="solid"/>
-                      <a:round/>
-                      <a:headEnd type="none" w="med" len="med"/>
-                      <a:tailEnd type="none" w="med" len="med"/>
-                    </a:lnL>
-                    <a:lnR w="6350" cap="flat" cmpd="sng" algn="ctr">
-                      <a:solidFill>
-                        <a:srgbClr val="D9D9DE"/>
-                      </a:solidFill>
-                      <a:prstDash val="solid"/>
-                      <a:round/>
-                      <a:headEnd type="none" w="med" len="med"/>
-                      <a:tailEnd type="none" w="med" len="med"/>
-                    </a:lnR>
-                    <a:lnT w="6350" cap="flat" cmpd="sng" algn="ctr">
-                      <a:solidFill>
-                        <a:srgbClr val="D9D9DE"/>
-                      </a:solidFill>
-                      <a:prstDash val="solid"/>
-                      <a:round/>
-                      <a:headEnd type="none" w="med" len="med"/>
-                      <a:tailEnd type="none" w="med" len="med"/>
-                    </a:lnT>
-                    <a:lnB w="6350" cap="flat" cmpd="sng" algn="ctr">
-                      <a:solidFill>
-                        <a:srgbClr val="D9D9DE"/>
-                      </a:solidFill>
-                      <a:prstDash val="solid"/>
-                      <a:round/>
-                      <a:headEnd type="none" w="med" len="med"/>
-                      <a:tailEnd type="none" w="med" len="med"/>
-                    </a:lnB>
-                    <a:solidFill>
-                      <a:schemeClr val="bg2"/>
-                    </a:solidFill>
-                  </a:tcPr>
-                </a:tc>
-                <a:tc>
-                  <a:txBody>
-                    <a:bodyPr/>
-                    <a:lstStyle/>
-                    <a:p>
-                      <a:pPr indent="0" marL="0">
-                        <a:buNone/>
-                      </a:pPr>
-                      <a:endParaRPr lang="en-US" sz="1000" dirty="0"/>
-                    </a:p>
-                  </a:txBody>
-                  <a:tcPr marL="45720" marR="45720" marT="45720" marB="45720">
-                    <a:lnL w="6350" cap="flat" cmpd="sng" algn="ctr">
-                      <a:solidFill>
-                        <a:srgbClr val="D9D9DE"/>
-                      </a:solidFill>
-                      <a:prstDash val="solid"/>
-                      <a:round/>
-                      <a:headEnd type="none" w="med" len="med"/>
-                      <a:tailEnd type="none" w="med" len="med"/>
-                    </a:lnL>
-                    <a:lnR w="6350" cap="flat" cmpd="sng" algn="ctr">
-                      <a:solidFill>
-                        <a:srgbClr val="D9D9DE"/>
-                      </a:solidFill>
-                      <a:prstDash val="solid"/>
-                      <a:round/>
-                      <a:headEnd type="none" w="med" len="med"/>
-                      <a:tailEnd type="none" w="med" len="med"/>
-                    </a:lnR>
-                    <a:lnT w="6350" cap="flat" cmpd="sng" algn="ctr">
-                      <a:solidFill>
-                        <a:srgbClr val="D9D9DE"/>
-                      </a:solidFill>
-                      <a:prstDash val="solid"/>
-                      <a:round/>
-                      <a:headEnd type="none" w="med" len="med"/>
-                      <a:tailEnd type="none" w="med" len="med"/>
-                    </a:lnT>
-                    <a:lnB w="6350" cap="flat" cmpd="sng" algn="ctr">
-                      <a:solidFill>
-                        <a:srgbClr val="D9D9DE"/>
-                      </a:solidFill>
-                      <a:prstDash val="solid"/>
-                      <a:round/>
-                      <a:headEnd type="none" w="med" len="med"/>
-                      <a:tailEnd type="none" w="med" len="med"/>
-                    </a:lnB>
-                    <a:solidFill>
-                      <a:schemeClr val="bg2"/>
-                    </a:solidFill>
-                  </a:tcPr>
-                </a:tc>
-                <a:tc>
-                  <a:txBody>
-                    <a:bodyPr/>
-                    <a:lstStyle/>
-                    <a:p>
-                      <a:pPr indent="0" marL="0">
-                        <a:buNone/>
-                      </a:pPr>
-                      <a:r>
-                        <a:rPr lang="en-US" sz="1000" dirty="0">
-                          <a:solidFill>
-                            <a:schemeClr val="tx1"/>
-                          </a:solidFill>
-                        </a:rPr>
-                        <a:t>M06-004</a:t>
+                        <a:t>App follows the route; the portal road distance is more than 2 km</a:t>
                       </a:r>
                       <a:endParaRPr lang="en-US" sz="1000" dirty="0"/>
                     </a:p>
@@ -15060,7 +13086,7 @@
                             <a:schemeClr val="tx1"/>
                           </a:solidFill>
                         </a:rPr>
-                        <a:t>Arrive, mileage 48215</a:t>
+                        <a:t>Tap Arrived, enter odometer 48215, Confirm</a:t>
                       </a:r>
                       <a:endParaRPr lang="en-US" sz="1000" dirty="0"/>
                     </a:p>
@@ -15121,129 +13147,7 @@
                             <a:schemeClr val="tx1"/>
                           </a:solidFill>
                         </a:rPr>
-                        <a:t>Reach time; mileage = 48215</a:t>
-                      </a:r>
-                      <a:endParaRPr lang="en-US" sz="1000" dirty="0"/>
-                    </a:p>
-                  </a:txBody>
-                  <a:tcPr marL="45720" marR="45720" marT="45720" marB="45720">
-                    <a:lnL w="6350" cap="flat" cmpd="sng" algn="ctr">
-                      <a:solidFill>
-                        <a:srgbClr val="D9D9DE"/>
-                      </a:solidFill>
-                      <a:prstDash val="solid"/>
-                      <a:round/>
-                      <a:headEnd type="none" w="med" len="med"/>
-                      <a:tailEnd type="none" w="med" len="med"/>
-                    </a:lnL>
-                    <a:lnR w="6350" cap="flat" cmpd="sng" algn="ctr">
-                      <a:solidFill>
-                        <a:srgbClr val="D9D9DE"/>
-                      </a:solidFill>
-                      <a:prstDash val="solid"/>
-                      <a:round/>
-                      <a:headEnd type="none" w="med" len="med"/>
-                      <a:tailEnd type="none" w="med" len="med"/>
-                    </a:lnR>
-                    <a:lnT w="6350" cap="flat" cmpd="sng" algn="ctr">
-                      <a:solidFill>
-                        <a:srgbClr val="D9D9DE"/>
-                      </a:solidFill>
-                      <a:prstDash val="solid"/>
-                      <a:round/>
-                      <a:headEnd type="none" w="med" len="med"/>
-                      <a:tailEnd type="none" w="med" len="med"/>
-                    </a:lnT>
-                    <a:lnB w="6350" cap="flat" cmpd="sng" algn="ctr">
-                      <a:solidFill>
-                        <a:srgbClr val="D9D9DE"/>
-                      </a:solidFill>
-                      <a:prstDash val="solid"/>
-                      <a:round/>
-                      <a:headEnd type="none" w="med" len="med"/>
-                      <a:tailEnd type="none" w="med" len="med"/>
-                    </a:lnB>
-                    <a:solidFill>
-                      <a:schemeClr val="bg1"/>
-                    </a:solidFill>
-                  </a:tcPr>
-                </a:tc>
-                <a:tc>
-                  <a:txBody>
-                    <a:bodyPr/>
-                    <a:lstStyle/>
-                    <a:p>
-                      <a:pPr indent="0" marL="0">
-                        <a:buNone/>
-                      </a:pPr>
-                      <a:r>
-                        <a:rPr lang="en-US" sz="1000" dirty="0">
-                          <a:solidFill>
-                            <a:schemeClr val="tx1"/>
-                          </a:solidFill>
-                        </a:rPr>
-                        <a:t>TC-05-019</a:t>
-                      </a:r>
-                      <a:endParaRPr lang="en-US" sz="1000" dirty="0"/>
-                    </a:p>
-                  </a:txBody>
-                  <a:tcPr marL="45720" marR="45720" marT="45720" marB="45720">
-                    <a:lnL w="6350" cap="flat" cmpd="sng" algn="ctr">
-                      <a:solidFill>
-                        <a:srgbClr val="D9D9DE"/>
-                      </a:solidFill>
-                      <a:prstDash val="solid"/>
-                      <a:round/>
-                      <a:headEnd type="none" w="med" len="med"/>
-                      <a:tailEnd type="none" w="med" len="med"/>
-                    </a:lnL>
-                    <a:lnR w="6350" cap="flat" cmpd="sng" algn="ctr">
-                      <a:solidFill>
-                        <a:srgbClr val="D9D9DE"/>
-                      </a:solidFill>
-                      <a:prstDash val="solid"/>
-                      <a:round/>
-                      <a:headEnd type="none" w="med" len="med"/>
-                      <a:tailEnd type="none" w="med" len="med"/>
-                    </a:lnR>
-                    <a:lnT w="6350" cap="flat" cmpd="sng" algn="ctr">
-                      <a:solidFill>
-                        <a:srgbClr val="D9D9DE"/>
-                      </a:solidFill>
-                      <a:prstDash val="solid"/>
-                      <a:round/>
-                      <a:headEnd type="none" w="med" len="med"/>
-                      <a:tailEnd type="none" w="med" len="med"/>
-                    </a:lnT>
-                    <a:lnB w="6350" cap="flat" cmpd="sng" algn="ctr">
-                      <a:solidFill>
-                        <a:srgbClr val="D9D9DE"/>
-                      </a:solidFill>
-                      <a:prstDash val="solid"/>
-                      <a:round/>
-                      <a:headEnd type="none" w="med" len="med"/>
-                      <a:tailEnd type="none" w="med" len="med"/>
-                    </a:lnB>
-                    <a:solidFill>
-                      <a:schemeClr val="bg1"/>
-                    </a:solidFill>
-                  </a:tcPr>
-                </a:tc>
-                <a:tc>
-                  <a:txBody>
-                    <a:bodyPr/>
-                    <a:lstStyle/>
-                    <a:p>
-                      <a:pPr indent="0" marL="0">
-                        <a:buNone/>
-                      </a:pPr>
-                      <a:r>
-                        <a:rPr lang="en-US" sz="1000" dirty="0">
-                          <a:solidFill>
-                            <a:schemeClr val="tx1"/>
-                          </a:solidFill>
-                        </a:rPr>
-                        <a:t>M05-001</a:t>
+                        <a:t>Portal shows the reach time and mileage 48215</a:t>
                       </a:r>
                       <a:endParaRPr lang="en-US" sz="1000" dirty="0"/>
                     </a:p>
@@ -15428,7 +13332,7 @@
                             <a:schemeClr val="tx1"/>
                           </a:solidFill>
                         </a:rPr>
-                        <a:t>Photo with camera, upload</a:t>
+                        <a:t>Take a photo with the camera and tap Done</a:t>
                       </a:r>
                       <a:endParaRPr lang="en-US" sz="1000" dirty="0"/>
                     </a:p>
@@ -15489,121 +13393,7 @@
                             <a:schemeClr val="tx1"/>
                           </a:solidFill>
                         </a:rPr>
-                        <a:t>Photo count 1</a:t>
-                      </a:r>
-                      <a:endParaRPr lang="en-US" sz="1000" dirty="0"/>
-                    </a:p>
-                  </a:txBody>
-                  <a:tcPr marL="45720" marR="45720" marT="45720" marB="45720">
-                    <a:lnL w="6350" cap="flat" cmpd="sng" algn="ctr">
-                      <a:solidFill>
-                        <a:srgbClr val="D9D9DE"/>
-                      </a:solidFill>
-                      <a:prstDash val="solid"/>
-                      <a:round/>
-                      <a:headEnd type="none" w="med" len="med"/>
-                      <a:tailEnd type="none" w="med" len="med"/>
-                    </a:lnL>
-                    <a:lnR w="6350" cap="flat" cmpd="sng" algn="ctr">
-                      <a:solidFill>
-                        <a:srgbClr val="D9D9DE"/>
-                      </a:solidFill>
-                      <a:prstDash val="solid"/>
-                      <a:round/>
-                      <a:headEnd type="none" w="med" len="med"/>
-                      <a:tailEnd type="none" w="med" len="med"/>
-                    </a:lnR>
-                    <a:lnT w="6350" cap="flat" cmpd="sng" algn="ctr">
-                      <a:solidFill>
-                        <a:srgbClr val="D9D9DE"/>
-                      </a:solidFill>
-                      <a:prstDash val="solid"/>
-                      <a:round/>
-                      <a:headEnd type="none" w="med" len="med"/>
-                      <a:tailEnd type="none" w="med" len="med"/>
-                    </a:lnT>
-                    <a:lnB w="6350" cap="flat" cmpd="sng" algn="ctr">
-                      <a:solidFill>
-                        <a:srgbClr val="D9D9DE"/>
-                      </a:solidFill>
-                      <a:prstDash val="solid"/>
-                      <a:round/>
-                      <a:headEnd type="none" w="med" len="med"/>
-                      <a:tailEnd type="none" w="med" len="med"/>
-                    </a:lnB>
-                    <a:solidFill>
-                      <a:schemeClr val="bg2"/>
-                    </a:solidFill>
-                  </a:tcPr>
-                </a:tc>
-                <a:tc>
-                  <a:txBody>
-                    <a:bodyPr/>
-                    <a:lstStyle/>
-                    <a:p>
-                      <a:pPr indent="0" marL="0">
-                        <a:buNone/>
-                      </a:pPr>
-                      <a:endParaRPr lang="en-US" sz="1000" dirty="0"/>
-                    </a:p>
-                  </a:txBody>
-                  <a:tcPr marL="45720" marR="45720" marT="45720" marB="45720">
-                    <a:lnL w="6350" cap="flat" cmpd="sng" algn="ctr">
-                      <a:solidFill>
-                        <a:srgbClr val="D9D9DE"/>
-                      </a:solidFill>
-                      <a:prstDash val="solid"/>
-                      <a:round/>
-                      <a:headEnd type="none" w="med" len="med"/>
-                      <a:tailEnd type="none" w="med" len="med"/>
-                    </a:lnL>
-                    <a:lnR w="6350" cap="flat" cmpd="sng" algn="ctr">
-                      <a:solidFill>
-                        <a:srgbClr val="D9D9DE"/>
-                      </a:solidFill>
-                      <a:prstDash val="solid"/>
-                      <a:round/>
-                      <a:headEnd type="none" w="med" len="med"/>
-                      <a:tailEnd type="none" w="med" len="med"/>
-                    </a:lnR>
-                    <a:lnT w="6350" cap="flat" cmpd="sng" algn="ctr">
-                      <a:solidFill>
-                        <a:srgbClr val="D9D9DE"/>
-                      </a:solidFill>
-                      <a:prstDash val="solid"/>
-                      <a:round/>
-                      <a:headEnd type="none" w="med" len="med"/>
-                      <a:tailEnd type="none" w="med" len="med"/>
-                    </a:lnT>
-                    <a:lnB w="6350" cap="flat" cmpd="sng" algn="ctr">
-                      <a:solidFill>
-                        <a:srgbClr val="D9D9DE"/>
-                      </a:solidFill>
-                      <a:prstDash val="solid"/>
-                      <a:round/>
-                      <a:headEnd type="none" w="med" len="med"/>
-                      <a:tailEnd type="none" w="med" len="med"/>
-                    </a:lnB>
-                    <a:solidFill>
-                      <a:schemeClr val="bg2"/>
-                    </a:solidFill>
-                  </a:tcPr>
-                </a:tc>
-                <a:tc>
-                  <a:txBody>
-                    <a:bodyPr/>
-                    <a:lstStyle/>
-                    <a:p>
-                      <a:pPr indent="0" marL="0">
-                        <a:buNone/>
-                      </a:pPr>
-                      <a:r>
-                        <a:rPr lang="en-US" sz="1000" dirty="0">
-                          <a:solidFill>
-                            <a:schemeClr val="tx1"/>
-                          </a:solidFill>
-                        </a:rPr>
-                        <a:t>M07-001</a:t>
+                        <a:t>Photo is listed in the app; portal photo count is 1</a:t>
                       </a:r>
                       <a:endParaRPr lang="en-US" sz="1000" dirty="0"/>
                     </a:p>
@@ -15788,7 +13578,7 @@
                             <a:schemeClr val="tx1"/>
                           </a:solidFill>
                         </a:rPr>
-                        <a:t>Finish job</a:t>
+                        <a:t>Tap Finish job and confirm</a:t>
                       </a:r>
                       <a:endParaRPr lang="en-US" sz="1000" dirty="0"/>
                     </a:p>
@@ -15849,121 +13639,7 @@
                             <a:schemeClr val="tx1"/>
                           </a:solidFill>
                         </a:rPr>
-                        <a:t>Completed screen</a:t>
-                      </a:r>
-                      <a:endParaRPr lang="en-US" sz="1000" dirty="0"/>
-                    </a:p>
-                  </a:txBody>
-                  <a:tcPr marL="45720" marR="45720" marT="45720" marB="45720">
-                    <a:lnL w="6350" cap="flat" cmpd="sng" algn="ctr">
-                      <a:solidFill>
-                        <a:srgbClr val="D9D9DE"/>
-                      </a:solidFill>
-                      <a:prstDash val="solid"/>
-                      <a:round/>
-                      <a:headEnd type="none" w="med" len="med"/>
-                      <a:tailEnd type="none" w="med" len="med"/>
-                    </a:lnL>
-                    <a:lnR w="6350" cap="flat" cmpd="sng" algn="ctr">
-                      <a:solidFill>
-                        <a:srgbClr val="D9D9DE"/>
-                      </a:solidFill>
-                      <a:prstDash val="solid"/>
-                      <a:round/>
-                      <a:headEnd type="none" w="med" len="med"/>
-                      <a:tailEnd type="none" w="med" len="med"/>
-                    </a:lnR>
-                    <a:lnT w="6350" cap="flat" cmpd="sng" algn="ctr">
-                      <a:solidFill>
-                        <a:srgbClr val="D9D9DE"/>
-                      </a:solidFill>
-                      <a:prstDash val="solid"/>
-                      <a:round/>
-                      <a:headEnd type="none" w="med" len="med"/>
-                      <a:tailEnd type="none" w="med" len="med"/>
-                    </a:lnT>
-                    <a:lnB w="6350" cap="flat" cmpd="sng" algn="ctr">
-                      <a:solidFill>
-                        <a:srgbClr val="D9D9DE"/>
-                      </a:solidFill>
-                      <a:prstDash val="solid"/>
-                      <a:round/>
-                      <a:headEnd type="none" w="med" len="med"/>
-                      <a:tailEnd type="none" w="med" len="med"/>
-                    </a:lnB>
-                    <a:solidFill>
-                      <a:schemeClr val="bg1"/>
-                    </a:solidFill>
-                  </a:tcPr>
-                </a:tc>
-                <a:tc>
-                  <a:txBody>
-                    <a:bodyPr/>
-                    <a:lstStyle/>
-                    <a:p>
-                      <a:pPr indent="0" marL="0">
-                        <a:buNone/>
-                      </a:pPr>
-                      <a:endParaRPr lang="en-US" sz="1000" dirty="0"/>
-                    </a:p>
-                  </a:txBody>
-                  <a:tcPr marL="45720" marR="45720" marT="45720" marB="45720">
-                    <a:lnL w="6350" cap="flat" cmpd="sng" algn="ctr">
-                      <a:solidFill>
-                        <a:srgbClr val="D9D9DE"/>
-                      </a:solidFill>
-                      <a:prstDash val="solid"/>
-                      <a:round/>
-                      <a:headEnd type="none" w="med" len="med"/>
-                      <a:tailEnd type="none" w="med" len="med"/>
-                    </a:lnL>
-                    <a:lnR w="6350" cap="flat" cmpd="sng" algn="ctr">
-                      <a:solidFill>
-                        <a:srgbClr val="D9D9DE"/>
-                      </a:solidFill>
-                      <a:prstDash val="solid"/>
-                      <a:round/>
-                      <a:headEnd type="none" w="med" len="med"/>
-                      <a:tailEnd type="none" w="med" len="med"/>
-                    </a:lnR>
-                    <a:lnT w="6350" cap="flat" cmpd="sng" algn="ctr">
-                      <a:solidFill>
-                        <a:srgbClr val="D9D9DE"/>
-                      </a:solidFill>
-                      <a:prstDash val="solid"/>
-                      <a:round/>
-                      <a:headEnd type="none" w="med" len="med"/>
-                      <a:tailEnd type="none" w="med" len="med"/>
-                    </a:lnT>
-                    <a:lnB w="6350" cap="flat" cmpd="sng" algn="ctr">
-                      <a:solidFill>
-                        <a:srgbClr val="D9D9DE"/>
-                      </a:solidFill>
-                      <a:prstDash val="solid"/>
-                      <a:round/>
-                      <a:headEnd type="none" w="med" len="med"/>
-                      <a:tailEnd type="none" w="med" len="med"/>
-                    </a:lnB>
-                    <a:solidFill>
-                      <a:schemeClr val="bg1"/>
-                    </a:solidFill>
-                  </a:tcPr>
-                </a:tc>
-                <a:tc>
-                  <a:txBody>
-                    <a:bodyPr/>
-                    <a:lstStyle/>
-                    <a:p>
-                      <a:pPr indent="0" marL="0">
-                        <a:buNone/>
-                      </a:pPr>
-                      <a:r>
-                        <a:rPr lang="en-US" sz="1000" dirty="0">
-                          <a:solidFill>
-                            <a:schemeClr val="tx1"/>
-                          </a:solidFill>
-                        </a:rPr>
-                        <a:t>M05-005, M05-007</a:t>
+                        <a:t>Completed screen is shown</a:t>
                       </a:r>
                       <a:endParaRPr lang="en-US" sz="1000" dirty="0"/>
                     </a:p>
@@ -16209,122 +13885,8 @@
                             <a:schemeClr val="tx1"/>
                           </a:solidFill>
                         </a:rPr>
-                        <a:t>CLOSED; timestamps in order, by truck, with GPS; KPI Pass</a:t>
+                        <a:t>Status CLOSED; request &lt; accept &lt; reach &lt; complete; ACCEPT, REACH and COMPLETE rows stamped by truck v3036 with GPS; KPI Pass</a:t>
                       </a:r>
-                      <a:endParaRPr lang="en-US" sz="1000" dirty="0"/>
-                    </a:p>
-                  </a:txBody>
-                  <a:tcPr marL="45720" marR="45720" marT="45720" marB="45720">
-                    <a:lnL w="6350" cap="flat" cmpd="sng" algn="ctr">
-                      <a:solidFill>
-                        <a:srgbClr val="D9D9DE"/>
-                      </a:solidFill>
-                      <a:prstDash val="solid"/>
-                      <a:round/>
-                      <a:headEnd type="none" w="med" len="med"/>
-                      <a:tailEnd type="none" w="med" len="med"/>
-                    </a:lnL>
-                    <a:lnR w="6350" cap="flat" cmpd="sng" algn="ctr">
-                      <a:solidFill>
-                        <a:srgbClr val="D9D9DE"/>
-                      </a:solidFill>
-                      <a:prstDash val="solid"/>
-                      <a:round/>
-                      <a:headEnd type="none" w="med" len="med"/>
-                      <a:tailEnd type="none" w="med" len="med"/>
-                    </a:lnR>
-                    <a:lnT w="6350" cap="flat" cmpd="sng" algn="ctr">
-                      <a:solidFill>
-                        <a:srgbClr val="D9D9DE"/>
-                      </a:solidFill>
-                      <a:prstDash val="solid"/>
-                      <a:round/>
-                      <a:headEnd type="none" w="med" len="med"/>
-                      <a:tailEnd type="none" w="med" len="med"/>
-                    </a:lnT>
-                    <a:lnB w="6350" cap="flat" cmpd="sng" algn="ctr">
-                      <a:solidFill>
-                        <a:srgbClr val="D9D9DE"/>
-                      </a:solidFill>
-                      <a:prstDash val="solid"/>
-                      <a:round/>
-                      <a:headEnd type="none" w="med" len="med"/>
-                      <a:tailEnd type="none" w="med" len="med"/>
-                    </a:lnB>
-                    <a:solidFill>
-                      <a:schemeClr val="bg2"/>
-                    </a:solidFill>
-                  </a:tcPr>
-                </a:tc>
-                <a:tc>
-                  <a:txBody>
-                    <a:bodyPr/>
-                    <a:lstStyle/>
-                    <a:p>
-                      <a:pPr indent="0" marL="0">
-                        <a:buNone/>
-                      </a:pPr>
-                      <a:r>
-                        <a:rPr lang="en-US" sz="1000" dirty="0">
-                          <a:solidFill>
-                            <a:schemeClr val="tx1"/>
-                          </a:solidFill>
-                        </a:rPr>
-                        <a:t>TC-05-023, 04-060, 05-020</a:t>
-                      </a:r>
-                      <a:endParaRPr lang="en-US" sz="1000" dirty="0"/>
-                    </a:p>
-                  </a:txBody>
-                  <a:tcPr marL="45720" marR="45720" marT="45720" marB="45720">
-                    <a:lnL w="6350" cap="flat" cmpd="sng" algn="ctr">
-                      <a:solidFill>
-                        <a:srgbClr val="D9D9DE"/>
-                      </a:solidFill>
-                      <a:prstDash val="solid"/>
-                      <a:round/>
-                      <a:headEnd type="none" w="med" len="med"/>
-                      <a:tailEnd type="none" w="med" len="med"/>
-                    </a:lnL>
-                    <a:lnR w="6350" cap="flat" cmpd="sng" algn="ctr">
-                      <a:solidFill>
-                        <a:srgbClr val="D9D9DE"/>
-                      </a:solidFill>
-                      <a:prstDash val="solid"/>
-                      <a:round/>
-                      <a:headEnd type="none" w="med" len="med"/>
-                      <a:tailEnd type="none" w="med" len="med"/>
-                    </a:lnR>
-                    <a:lnT w="6350" cap="flat" cmpd="sng" algn="ctr">
-                      <a:solidFill>
-                        <a:srgbClr val="D9D9DE"/>
-                      </a:solidFill>
-                      <a:prstDash val="solid"/>
-                      <a:round/>
-                      <a:headEnd type="none" w="med" len="med"/>
-                      <a:tailEnd type="none" w="med" len="med"/>
-                    </a:lnT>
-                    <a:lnB w="6350" cap="flat" cmpd="sng" algn="ctr">
-                      <a:solidFill>
-                        <a:srgbClr val="D9D9DE"/>
-                      </a:solidFill>
-                      <a:prstDash val="solid"/>
-                      <a:round/>
-                      <a:headEnd type="none" w="med" len="med"/>
-                      <a:tailEnd type="none" w="med" len="med"/>
-                    </a:lnB>
-                    <a:solidFill>
-                      <a:schemeClr val="bg2"/>
-                    </a:solidFill>
-                  </a:tcPr>
-                </a:tc>
-                <a:tc>
-                  <a:txBody>
-                    <a:bodyPr/>
-                    <a:lstStyle/>
-                    <a:p>
-                      <a:pPr indent="0" marL="0">
-                        <a:buNone/>
-                      </a:pPr>
                       <a:endParaRPr lang="en-US" sz="1000" dirty="0"/>
                     </a:p>
                   </a:txBody>
@@ -16383,7 +13945,7 @@
         </p:nvSpPr>
         <p:spPr>
           <a:xfrm>
-            <a:off x="548640" y="5897880"/>
+            <a:off x="548640" y="6035040"/>
             <a:ext cx="11094415" cy="274320"/>
           </a:xfrm>
           <a:prstGeom prst="rect">
@@ -16405,7 +13967,7 @@
                   <a:schemeClr val="accent4"/>
                 </a:solidFill>
               </a:rPr>
-              <a:t>Same table in the workbooks: web suite sheet 26 "E2E Journeys", app suite sheet 13 - filterable by case id.</a:t>
+              <a:t>Workbook sheet "23-E2E Journeys" - the same 11 steps, one row each. The test (TC-23-001.spec.ts) runs them in this order.</a:t>
             </a:r>
             <a:endParaRPr lang="en-US" sz="1100" dirty="0"/>
           </a:p>

</xml_diff>

<commit_message>
E2E tests follow the suite steps (11/8) with captions held 2.5 s; deck with 22 Oct results
</commit_message>
<xml_diff>
--- a/presentations/RoadSide_E2E_Journeys.pptx
+++ b/presentations/RoadSide_E2E_Journeys.pptx
@@ -17,9 +17,10 @@
     <p:sldId id="265" r:id="rId11"/>
     <p:sldId id="266" r:id="rId12"/>
     <p:sldId id="267" r:id="rId13"/>
+    <p:sldId id="268" r:id="rId14"/>
   </p:sldIdLst>
   <p:notesMasterIdLst>
-    <p:notesMasterId r:id="rId14"/>
+    <p:notesMasterId r:id="rId15"/>
   </p:notesMasterIdLst>
   <p:sldSz cx="12192000" cy="6858000"/>
   <p:notesSz cx="6858000" cy="12192000"/>
@@ -118,7 +119,7 @@
   <p:extLst>
     <p:ext uri="{521415D9-36F7-43E2-AB2F-B90AF26B5E84}">
       <p14:sectionLst xmlns:p14="http://schemas.microsoft.com/office/powerpoint/2010/main">
-        <p14:section name="Where we are" id="{3c5279c5-f5ae-2834-9dbc-2479c2361fbf}">
+        <p14:section name="Where we are" id="{56614008-cdf9-8055-13d0-349a1de7fa1e}">
           <p14:sldIdLst>
             <p14:sldId id="256"/>
             <p14:sldId id="257"/>
@@ -126,7 +127,7 @@
             <p14:sldId id="259"/>
           </p14:sldIdLst>
         </p14:section>
-        <p14:section name="The two journeys" id="{da909712-6e92-d557-dbf0-3df4c52c987d}">
+        <p14:section name="The two journeys" id="{ba03dc9f-0a51-2ea1-32bb-2b2e1c384d9a}">
           <p14:sldIdLst>
             <p14:sldId id="260"/>
             <p14:sldId id="261"/>
@@ -134,12 +135,13 @@
             <p14:sldId id="263"/>
             <p14:sldId id="264"/>
             <p14:sldId id="265"/>
+            <p14:sldId id="266"/>
           </p14:sldIdLst>
         </p14:section>
-        <p14:section name="Demo and next" id="{97f6995c-a9bd-1f5e-5b56-274b58c80fb5}">
+        <p14:section name="Demo and next" id="{d92010b6-ac93-b0fe-e1c9-7f6c379debc7}">
           <p14:sldIdLst>
-            <p14:sldId id="266"/>
             <p14:sldId id="267"/>
+            <p14:sldId id="268"/>
           </p14:sldIdLst>
         </p14:section>
       </p14:sectionLst>
@@ -722,7 +724,7 @@
           <a:p>
             <a:r>
               <a:rPr lang="en-US" dirty="0"/>
-              <a:t>Play the video here. Point out: dispatch on the left, job appears on the right; each driver tap, then the timestamp row on the portal.</a:t>
+              <a:t>Four moments from the 22 Oct run. Step 4 (not shown) checks the server feed the phone reads, so a failure points at server or phone.</a:t>
             </a:r>
             <a:endParaRPr lang="en-US" dirty="0"/>
           </a:p>
@@ -810,7 +812,7 @@
           <a:p>
             <a:r>
               <a:rPr lang="en-US" dirty="0"/>
-              <a:t>Each finding has its own test case in the suite, so it stays visible until it is fixed or accepted.</a:t>
+              <a:t>Play the video here. Point out: dispatch on the left, job appears on the right; each driver tap, then the timestamp row on the portal.</a:t>
             </a:r>
             <a:endParaRPr lang="en-US" dirty="0"/>
           </a:p>
@@ -834,6 +836,94 @@
             <a:fld id="{F7021451-1387-4CA6-816F-3879F97B5CBC}" type="slidenum">
               <a:rPr lang="en-US"/>
               <a:t>12</a:t>
+            </a:fld>
+            <a:endParaRPr lang="en-US"/>
+          </a:p>
+        </p:txBody>
+      </p:sp>
+    </p:spTree>
+    <p:extLst>
+      <p:ext uri="{BB962C8B-B14F-4D97-AF65-F5344CB8AC3E}">
+        <p14:creationId xmlns:p14="http://schemas.microsoft.com/office/powerpoint/2010/main" val="1024086991"/>
+      </p:ext>
+    </p:extLst>
+  </p:cSld>
+  <p:clrMapOvr>
+    <a:masterClrMapping/>
+  </p:clrMapOvr>
+</p:notes>
+</file>
+
+<file path=ppt/notesSlides/notesSlide13.xml><?xml version="1.0" encoding="utf-8"?>
+<p:notes xmlns:a="http://schemas.openxmlformats.org/drawingml/2006/main" xmlns:r="http://schemas.openxmlformats.org/officeDocument/2006/relationships" xmlns:p="http://schemas.openxmlformats.org/presentationml/2006/main">
+  <p:cSld>
+    <p:spTree>
+      <p:nvGrpSpPr>
+        <p:cNvPr id="1" name=""/>
+        <p:cNvGrpSpPr/>
+        <p:nvPr/>
+      </p:nvGrpSpPr>
+      <p:grpSpPr>
+        <a:xfrm>
+          <a:off x="0" y="0"/>
+          <a:ext cx="0" cy="0"/>
+          <a:chOff x="0" y="0"/>
+          <a:chExt cx="0" cy="0"/>
+        </a:xfrm>
+      </p:grpSpPr>
+      <p:sp>
+        <p:nvSpPr>
+          <p:cNvPr id="2" name="Slide Image Placeholder 1"/>
+          <p:cNvSpPr>
+            <a:spLocks noGrp="1" noRot="1" noChangeAspect="1"/>
+          </p:cNvSpPr>
+          <p:nvPr>
+            <p:ph type="sldImg"/>
+          </p:nvPr>
+        </p:nvSpPr>
+        <p:spPr/>
+      </p:sp>
+      <p:sp>
+        <p:nvSpPr>
+          <p:cNvPr id="3" name="Notes Placeholder 2"/>
+          <p:cNvSpPr>
+            <a:spLocks noGrp="1"/>
+          </p:cNvSpPr>
+          <p:nvPr>
+            <p:ph type="body" idx="1"/>
+          </p:nvPr>
+        </p:nvSpPr>
+        <p:spPr/>
+        <p:txBody>
+          <a:bodyPr/>
+          <a:lstStyle/>
+          <a:p>
+            <a:r>
+              <a:rPr lang="en-US" dirty="0"/>
+              <a:t>Each finding has its own test case in the suite, so it stays visible until it is fixed or accepted.</a:t>
+            </a:r>
+            <a:endParaRPr lang="en-US" dirty="0"/>
+          </a:p>
+        </p:txBody>
+      </p:sp>
+      <p:sp>
+        <p:nvSpPr>
+          <p:cNvPr id="4" name="Slide Number Placeholder 3"/>
+          <p:cNvSpPr>
+            <a:spLocks noGrp="1"/>
+          </p:cNvSpPr>
+          <p:nvPr>
+            <p:ph type="sldNum" sz="quarter" idx="10"/>
+          </p:nvPr>
+        </p:nvSpPr>
+        <p:spPr/>
+        <p:txBody>
+          <a:bodyPr/>
+          <a:lstStyle/>
+          <a:p>
+            <a:fld id="{F7021451-1387-4CA6-816F-3879F97B5CBC}" type="slidenum">
+              <a:rPr lang="en-US"/>
+              <a:t>13</a:t>
             </a:fld>
             <a:endParaRPr lang="en-US"/>
           </a:p>
@@ -1426,7 +1516,7 @@
           <a:p>
             <a:r>
               <a:rPr lang="en-US" dirty="0"/>
-              <a:t>Three frames from the recorded run. The full three-minute video plays in the demo.</a:t>
+              <a:t>Three frames from the 22 Oct run. The caption bar in the video names the step from the suite.</a:t>
             </a:r>
             <a:endParaRPr lang="en-US" dirty="0"/>
           </a:p>
@@ -4807,7 +4897,7 @@
                   <a:schemeClr val="tx1"/>
                 </a:solidFill>
               </a:rPr>
-              <a:t>Demo: watch the journeys</a:t>
+              <a:t>E2E-02 in the video: publish on the portal, see it on the phone</a:t>
             </a:r>
             <a:endParaRPr lang="en-US" sz="2600" dirty="0"/>
           </a:p>
@@ -4815,7 +4905,7 @@
       </p:sp>
       <p:pic>
         <p:nvPicPr>
-          <p:cNvPr id="3" name="t165.png" descr="C:\Projects\AspireDigital\ai-workshop\presentations\e2e-img\t165.png">    </p:cNvPr>
+          <p:cNvPr id="3" name="ann-create.png" descr="C:\Projects\AspireDigital\ai-workshop\presentations\e2e-img\ann-create.png">    </p:cNvPr>
           <p:cNvPicPr>
             <a:picLocks noChangeAspect="1"/>
           </p:cNvPicPr>
@@ -4829,8 +4919,8 @@
         </p:blipFill>
         <p:spPr>
           <a:xfrm>
-            <a:off x="548640" y="1371600"/>
-            <a:ext cx="6766560" cy="3612043"/>
+            <a:off x="548640" y="1325880"/>
+            <a:ext cx="3291840" cy="2057400"/>
           </a:xfrm>
           <a:prstGeom prst="rect">
             <a:avLst/>
@@ -4839,14 +4929,14 @@
       </p:pic>
       <p:sp>
         <p:nvSpPr>
-          <p:cNvPr id="4" name="frame t165.png"/>
+          <p:cNvPr id="4" name="frame ann-create.png"/>
           <p:cNvSpPr/>
           <p:nvPr/>
         </p:nvSpPr>
         <p:spPr>
           <a:xfrm>
-            <a:off x="548640" y="1371600"/>
-            <a:ext cx="6766560" cy="3612043"/>
+            <a:off x="548640" y="1325880"/>
+            <a:ext cx="3291840" cy="2057400"/>
           </a:xfrm>
           <a:prstGeom prst="rect">
             <a:avLst/>
@@ -4861,24 +4951,81 @@
       </p:sp>
       <p:sp>
         <p:nvSpPr>
-          <p:cNvPr id="5" name="card E2E-01 Job  (3 min)"/>
+          <p:cNvPr id="5" name="Text 2"/>
+          <p:cNvSpPr txBox="1"/>
+          <p:nvPr/>
+        </p:nvSpPr>
+        <p:spPr>
+          <a:xfrm>
+            <a:off x="3977640" y="1417320"/>
+            <a:ext cx="2011680" cy="1463040"/>
+          </a:xfrm>
+          <a:prstGeom prst="rect">
+            <a:avLst/>
+          </a:prstGeom>
+          <a:noFill/>
+          <a:ln/>
+        </p:spPr>
+        <p:txBody>
+          <a:bodyPr wrap="square" lIns="0" tIns="0" rIns="0" bIns="0" rtlCol="0" anchor="t"/>
+          <a:lstStyle/>
+          <a:p>
+            <a:pPr indent="0" marL="0">
+              <a:buNone/>
+            </a:pPr>
+            <a:r>
+              <a:rPr lang="en-US" sz="1200" dirty="0">
+                <a:solidFill>
+                  <a:schemeClr val="tx1"/>
+                </a:solidFill>
+              </a:rPr>
+              <a:t>Step 2: the create form an administrator fills (UAT screenshot)</a:t>
+            </a:r>
+            <a:endParaRPr lang="en-US" sz="1200" dirty="0"/>
+          </a:p>
+        </p:txBody>
+      </p:sp>
+      <p:pic>
+        <p:nvPicPr>
+          <p:cNvPr id="6" name="a5.png" descr="C:\Projects\AspireDigital\ai-workshop\presentations\e2e-img\a5.png">    </p:cNvPr>
+          <p:cNvPicPr>
+            <a:picLocks noChangeAspect="1"/>
+          </p:cNvPicPr>
+          <p:nvPr/>
+        </p:nvPicPr>
+        <p:blipFill>
+          <a:blip r:embed="rId2"/>
+          <a:stretch>
+            <a:fillRect/>
+          </a:stretch>
+        </p:blipFill>
+        <p:spPr>
+          <a:xfrm>
+            <a:off x="6126480" y="1325880"/>
+            <a:ext cx="3291840" cy="1757210"/>
+          </a:xfrm>
+          <a:prstGeom prst="rect">
+            <a:avLst/>
+          </a:prstGeom>
+        </p:spPr>
+      </p:pic>
+      <p:sp>
+        <p:nvSpPr>
+          <p:cNvPr id="7" name="frame a5.png"/>
           <p:cNvSpPr/>
           <p:nvPr/>
         </p:nvSpPr>
         <p:spPr>
           <a:xfrm>
-            <a:off x="7680960" y="1371600"/>
-            <a:ext cx="3962095" cy="2103120"/>
-          </a:xfrm>
-          <a:prstGeom prst="rect">
-            <a:avLst/>
-          </a:prstGeom>
-          <a:solidFill>
-            <a:schemeClr val="bg2"/>
-          </a:solidFill>
+            <a:off x="6126480" y="1325880"/>
+            <a:ext cx="3291840" cy="1757210"/>
+          </a:xfrm>
+          <a:prstGeom prst="rect">
+            <a:avLst/>
+          </a:prstGeom>
           <a:ln w="12700">
             <a:solidFill>
-              <a:schemeClr val="bg2"/>
+              <a:schemeClr val="accent5"/>
             </a:solidFill>
             <a:prstDash val="solid"/>
           </a:ln>
@@ -4886,24 +5033,81 @@
       </p:sp>
       <p:sp>
         <p:nvSpPr>
-          <p:cNvPr id="6" name="card edge E2E-01 Job  (3 min)"/>
+          <p:cNvPr id="8" name="Text 4"/>
+          <p:cNvSpPr txBox="1"/>
+          <p:nvPr/>
+        </p:nvSpPr>
+        <p:spPr>
+          <a:xfrm>
+            <a:off x="9555480" y="1417320"/>
+            <a:ext cx="2011680" cy="1463040"/>
+          </a:xfrm>
+          <a:prstGeom prst="rect">
+            <a:avLst/>
+          </a:prstGeom>
+          <a:noFill/>
+          <a:ln/>
+        </p:spPr>
+        <p:txBody>
+          <a:bodyPr wrap="square" lIns="0" tIns="0" rIns="0" bIns="0" rtlCol="0" anchor="t"/>
+          <a:lstStyle/>
+          <a:p>
+            <a:pPr indent="0" marL="0">
+              <a:buNone/>
+            </a:pPr>
+            <a:r>
+              <a:rPr lang="en-US" sz="1200" dirty="0">
+                <a:solidFill>
+                  <a:schemeClr val="tx1"/>
+                </a:solidFill>
+              </a:rPr>
+              <a:t>Step 5: News tab shows the High card (and the push notification)</a:t>
+            </a:r>
+            <a:endParaRPr lang="en-US" sz="1200" dirty="0"/>
+          </a:p>
+        </p:txBody>
+      </p:sp>
+      <p:pic>
+        <p:nvPicPr>
+          <p:cNvPr id="9" name="a6.png" descr="C:\Projects\AspireDigital\ai-workshop\presentations\e2e-img\a6.png">    </p:cNvPr>
+          <p:cNvPicPr>
+            <a:picLocks noChangeAspect="1"/>
+          </p:cNvPicPr>
+          <p:nvPr/>
+        </p:nvPicPr>
+        <p:blipFill>
+          <a:blip r:embed="rId3"/>
+          <a:stretch>
+            <a:fillRect/>
+          </a:stretch>
+        </p:blipFill>
+        <p:spPr>
+          <a:xfrm>
+            <a:off x="548640" y="3657600"/>
+            <a:ext cx="3291840" cy="1757210"/>
+          </a:xfrm>
+          <a:prstGeom prst="rect">
+            <a:avLst/>
+          </a:prstGeom>
+        </p:spPr>
+      </p:pic>
+      <p:sp>
+        <p:nvSpPr>
+          <p:cNvPr id="10" name="frame a6.png"/>
           <p:cNvSpPr/>
           <p:nvPr/>
         </p:nvSpPr>
         <p:spPr>
           <a:xfrm>
-            <a:off x="7680960" y="1371600"/>
-            <a:ext cx="64008" cy="2103120"/>
-          </a:xfrm>
-          <a:prstGeom prst="rect">
-            <a:avLst/>
-          </a:prstGeom>
-          <a:solidFill>
-            <a:schemeClr val="accent3"/>
-          </a:solidFill>
+            <a:off x="548640" y="3657600"/>
+            <a:ext cx="3291840" cy="1757210"/>
+          </a:xfrm>
+          <a:prstGeom prst="rect">
+            <a:avLst/>
+          </a:prstGeom>
           <a:ln w="12700">
             <a:solidFill>
-              <a:schemeClr val="accent3"/>
+              <a:schemeClr val="accent5"/>
             </a:solidFill>
             <a:prstDash val="solid"/>
           </a:ln>
@@ -4911,14 +5115,14 @@
       </p:sp>
       <p:sp>
         <p:nvSpPr>
-          <p:cNvPr id="7" name="Text 4"/>
+          <p:cNvPr id="11" name="Text 6"/>
           <p:cNvSpPr txBox="1"/>
           <p:nvPr/>
         </p:nvSpPr>
         <p:spPr>
           <a:xfrm>
-            <a:off x="7909560" y="1536192"/>
-            <a:ext cx="3596335" cy="365760"/>
+            <a:off x="3977640" y="3749040"/>
+            <a:ext cx="2011680" cy="1463040"/>
           </a:xfrm>
           <a:prstGeom prst="rect">
             <a:avLst/>
@@ -4934,93 +5138,58 @@
               <a:buNone/>
             </a:pPr>
             <a:r>
-              <a:rPr lang="en-US" sz="1400" b="1" dirty="0">
+              <a:rPr lang="en-US" sz="1200" dirty="0">
                 <a:solidFill>
                   <a:schemeClr val="tx1"/>
                 </a:solidFill>
               </a:rPr>
-              <a:t>E2E-01 Job  (3 min)</a:t>
-            </a:r>
-            <a:endParaRPr lang="en-US" sz="1400" dirty="0"/>
-          </a:p>
-        </p:txBody>
-      </p:sp>
-      <p:sp>
-        <p:nvSpPr>
-          <p:cNvPr id="8" name="Text 5"/>
-          <p:cNvSpPr txBox="1"/>
-          <p:nvPr/>
-        </p:nvSpPr>
-        <p:spPr>
-          <a:xfrm>
-            <a:off x="7909560" y="1938528"/>
-            <a:ext cx="3596335" cy="1417320"/>
-          </a:xfrm>
-          <a:prstGeom prst="rect">
-            <a:avLst/>
-          </a:prstGeom>
-          <a:noFill/>
-          <a:ln/>
-        </p:spPr>
-        <p:txBody>
-          <a:bodyPr wrap="square" lIns="0" tIns="0" rIns="0" bIns="0" rtlCol="0" anchor="t"/>
-          <a:lstStyle/>
-          <a:p>
-            <a:pPr indent="0" marL="0">
-              <a:lnSpc>
-                <a:spcPct val="115000"/>
-              </a:lnSpc>
-              <a:buNone/>
-            </a:pPr>
-            <a:r>
-              <a:rPr lang="en-US" sz="1200" dirty="0">
-                <a:solidFill>
-                  <a:schemeClr val="tx1"/>
-                </a:solidFill>
-              </a:rPr>
-              <a:t>TC-23-001-web-and-app_20Oct-real-location.mp4</a:t>
+              <a:t>Step 6: Home shows the high-priority banner</a:t>
             </a:r>
             <a:endParaRPr lang="en-US" sz="1200" dirty="0"/>
           </a:p>
-          <a:p>
-            <a:pPr indent="0" marL="0">
-              <a:lnSpc>
-                <a:spcPct val="115000"/>
-              </a:lnSpc>
-              <a:buNone/>
-            </a:pPr>
-            <a:r>
-              <a:rPr lang="en-US" sz="1200" dirty="0">
-                <a:solidFill>
-                  <a:schemeClr val="tx1"/>
-                </a:solidFill>
-              </a:rPr>
-              <a:t>Portal left, phone right. Step names appear as captions from the next run.</a:t>
-            </a:r>
-            <a:endParaRPr lang="en-US" sz="1200" dirty="0"/>
-          </a:p>
-        </p:txBody>
-      </p:sp>
-      <p:sp>
-        <p:nvSpPr>
-          <p:cNvPr id="9" name="card E2E-02 Announcement"/>
+        </p:txBody>
+      </p:sp>
+      <p:pic>
+        <p:nvPicPr>
+          <p:cNvPr id="12" name="a8.png" descr="C:\Projects\AspireDigital\ai-workshop\presentations\e2e-img\a8.png">    </p:cNvPr>
+          <p:cNvPicPr>
+            <a:picLocks noChangeAspect="1"/>
+          </p:cNvPicPr>
+          <p:nvPr/>
+        </p:nvPicPr>
+        <p:blipFill>
+          <a:blip r:embed="rId4"/>
+          <a:stretch>
+            <a:fillRect/>
+          </a:stretch>
+        </p:blipFill>
+        <p:spPr>
+          <a:xfrm>
+            <a:off x="6126480" y="3657600"/>
+            <a:ext cx="3291840" cy="1757210"/>
+          </a:xfrm>
+          <a:prstGeom prst="rect">
+            <a:avLst/>
+          </a:prstGeom>
+        </p:spPr>
+      </p:pic>
+      <p:sp>
+        <p:nvSpPr>
+          <p:cNvPr id="13" name="frame a8.png"/>
           <p:cNvSpPr/>
           <p:nvPr/>
         </p:nvSpPr>
         <p:spPr>
           <a:xfrm>
-            <a:off x="7680960" y="3657600"/>
-            <a:ext cx="3962095" cy="2194560"/>
-          </a:xfrm>
-          <a:prstGeom prst="rect">
-            <a:avLst/>
-          </a:prstGeom>
-          <a:solidFill>
-            <a:schemeClr val="bg2"/>
-          </a:solidFill>
+            <a:off x="6126480" y="3657600"/>
+            <a:ext cx="3291840" cy="1757210"/>
+          </a:xfrm>
+          <a:prstGeom prst="rect">
+            <a:avLst/>
+          </a:prstGeom>
           <a:ln w="12700">
             <a:solidFill>
-              <a:schemeClr val="bg2"/>
+              <a:schemeClr val="accent5"/>
             </a:solidFill>
             <a:prstDash val="solid"/>
           </a:ln>
@@ -5028,39 +5197,14 @@
       </p:sp>
       <p:sp>
         <p:nvSpPr>
-          <p:cNvPr id="10" name="card edge E2E-02 Announcement"/>
-          <p:cNvSpPr/>
-          <p:nvPr/>
-        </p:nvSpPr>
-        <p:spPr>
-          <a:xfrm>
-            <a:off x="7680960" y="3657600"/>
-            <a:ext cx="64008" cy="2194560"/>
-          </a:xfrm>
-          <a:prstGeom prst="rect">
-            <a:avLst/>
-          </a:prstGeom>
-          <a:solidFill>
-            <a:schemeClr val="accent2"/>
-          </a:solidFill>
-          <a:ln w="12700">
-            <a:solidFill>
-              <a:schemeClr val="accent2"/>
-            </a:solidFill>
-            <a:prstDash val="solid"/>
-          </a:ln>
-        </p:spPr>
-      </p:sp>
-      <p:sp>
-        <p:nvSpPr>
-          <p:cNvPr id="11" name="Text 8"/>
+          <p:cNvPr id="14" name="Text 8"/>
           <p:cNvSpPr txBox="1"/>
           <p:nvPr/>
         </p:nvSpPr>
         <p:spPr>
           <a:xfrm>
-            <a:off x="7909560" y="3822192"/>
-            <a:ext cx="3596335" cy="365760"/>
+            <a:off x="9555480" y="3749040"/>
+            <a:ext cx="2011680" cy="1463040"/>
           </a:xfrm>
           <a:prstGeom prst="rect">
             <a:avLst/>
@@ -5076,27 +5220,27 @@
               <a:buNone/>
             </a:pPr>
             <a:r>
-              <a:rPr lang="en-US" sz="1400" b="1" dirty="0">
+              <a:rPr lang="en-US" sz="1200" dirty="0">
                 <a:solidFill>
                   <a:schemeClr val="tx1"/>
                 </a:solidFill>
               </a:rPr>
-              <a:t>E2E-02 Announcement</a:t>
-            </a:r>
-            <a:endParaRPr lang="en-US" sz="1400" dirty="0"/>
-          </a:p>
-        </p:txBody>
-      </p:sp>
-      <p:sp>
-        <p:nvSpPr>
-          <p:cNvPr id="12" name="Text 9"/>
+              <a:t>Step 8: after "untick Active" the card is gone from News</a:t>
+            </a:r>
+            <a:endParaRPr lang="en-US" sz="1200" dirty="0"/>
+          </a:p>
+        </p:txBody>
+      </p:sp>
+      <p:sp>
+        <p:nvSpPr>
+          <p:cNvPr id="15" name="Text 9"/>
           <p:cNvSpPr txBox="1"/>
           <p:nvPr/>
         </p:nvSpPr>
         <p:spPr>
           <a:xfrm>
-            <a:off x="7909560" y="4224528"/>
-            <a:ext cx="3596335" cy="1508760"/>
+            <a:off x="548640" y="5989320"/>
+            <a:ext cx="11094415" cy="274320"/>
           </a:xfrm>
           <a:prstGeom prst="rect">
             <a:avLst/>
@@ -5109,54 +5253,15 @@
           <a:lstStyle/>
           <a:p>
             <a:pPr indent="0" marL="0">
-              <a:lnSpc>
-                <a:spcPct val="115000"/>
-              </a:lnSpc>
               <a:buNone/>
             </a:pPr>
             <a:r>
-              <a:rPr lang="en-US" sz="1200" dirty="0">
-                <a:solidFill>
-                  <a:schemeClr val="tx1"/>
-                </a:solidFill>
-              </a:rPr>
-              <a:t>Video from the first run (on the faster machine). Until then: the steps and the mapping on the previous two slides.</a:t>
-            </a:r>
-            <a:endParaRPr lang="en-US" sz="1200" dirty="0"/>
-          </a:p>
-        </p:txBody>
-      </p:sp>
-      <p:sp>
-        <p:nvSpPr>
-          <p:cNvPr id="13" name="Text 10"/>
-          <p:cNvSpPr txBox="1"/>
-          <p:nvPr/>
-        </p:nvSpPr>
-        <p:spPr>
-          <a:xfrm>
-            <a:off x="548640" y="5120803"/>
-            <a:ext cx="6766560" cy="548640"/>
-          </a:xfrm>
-          <a:prstGeom prst="rect">
-            <a:avLst/>
-          </a:prstGeom>
-          <a:noFill/>
-          <a:ln/>
-        </p:spPr>
-        <p:txBody>
-          <a:bodyPr wrap="square" lIns="0" tIns="0" rIns="0" bIns="0" rtlCol="0" anchor="t"/>
-          <a:lstStyle/>
-          <a:p>
-            <a:pPr indent="0" marL="0">
-              <a:buNone/>
-            </a:pPr>
-            <a:r>
-              <a:rPr lang="en-US" sz="1200" dirty="0">
-                <a:solidFill>
-                  <a:schemeClr val="accent4"/>
-                </a:solidFill>
-              </a:rPr>
-              <a:t>What to watch: the job number appearing on the phone after Dispatch, and the timestamps arriving on the portal after each tap.</a:t>
+              <a:rPr lang="en-US" sz="1200" b="1" dirty="0">
+                <a:solidFill>
+                  <a:schemeClr val="accent3"/>
+                </a:solidFill>
+              </a:rPr>
+              <a:t>Result 22 Oct 2026: PASSED in 1.6 min, all 8 steps. The announcement was switched off at the end and is no longer in the mobile feed.</a:t>
             </a:r>
             <a:endParaRPr lang="en-US" sz="1200" dirty="0"/>
           </a:p>
@@ -5264,22 +5369,68 @@
                   <a:schemeClr val="tx1"/>
                 </a:solidFill>
               </a:rPr>
-              <a:t>What the work found, and what we need next</a:t>
+              <a:t>Demo: watch the journeys</a:t>
             </a:r>
             <a:endParaRPr lang="en-US" sz="2600" dirty="0"/>
           </a:p>
         </p:txBody>
       </p:sp>
-      <p:sp>
-        <p:nvSpPr>
-          <p:cNvPr id="3" name="card Found while building the suites"/>
+      <p:pic>
+        <p:nvPicPr>
+          <p:cNvPr id="3" name="j11.png" descr="C:\Projects\AspireDigital\ai-workshop\presentations\e2e-img\j11.png">    </p:cNvPr>
+          <p:cNvPicPr>
+            <a:picLocks noChangeAspect="1"/>
+          </p:cNvPicPr>
+          <p:nvPr/>
+        </p:nvPicPr>
+        <p:blipFill>
+          <a:blip r:embed="rId1"/>
+          <a:stretch>
+            <a:fillRect/>
+          </a:stretch>
+        </p:blipFill>
+        <p:spPr>
+          <a:xfrm>
+            <a:off x="548640" y="1371600"/>
+            <a:ext cx="6766560" cy="3612043"/>
+          </a:xfrm>
+          <a:prstGeom prst="rect">
+            <a:avLst/>
+          </a:prstGeom>
+        </p:spPr>
+      </p:pic>
+      <p:sp>
+        <p:nvSpPr>
+          <p:cNvPr id="4" name="frame j11.png"/>
           <p:cNvSpPr/>
           <p:nvPr/>
         </p:nvSpPr>
         <p:spPr>
           <a:xfrm>
             <a:off x="548640" y="1371600"/>
-            <a:ext cx="5486400" cy="4480560"/>
+            <a:ext cx="6766560" cy="3612043"/>
+          </a:xfrm>
+          <a:prstGeom prst="rect">
+            <a:avLst/>
+          </a:prstGeom>
+          <a:ln w="12700">
+            <a:solidFill>
+              <a:schemeClr val="accent5"/>
+            </a:solidFill>
+            <a:prstDash val="solid"/>
+          </a:ln>
+        </p:spPr>
+      </p:sp>
+      <p:sp>
+        <p:nvSpPr>
+          <p:cNvPr id="5" name="card E2E-01 Job  (2 min 25 s)"/>
+          <p:cNvSpPr/>
+          <p:nvPr/>
+        </p:nvSpPr>
+        <p:spPr>
+          <a:xfrm>
+            <a:off x="7680960" y="1371600"/>
+            <a:ext cx="3962095" cy="2103120"/>
           </a:xfrm>
           <a:prstGeom prst="rect">
             <a:avLst/>
@@ -5297,14 +5448,156 @@
       </p:sp>
       <p:sp>
         <p:nvSpPr>
-          <p:cNvPr id="4" name="card edge Found while building the suites"/>
+          <p:cNvPr id="6" name="card edge E2E-01 Job  (2 min 25 s)"/>
           <p:cNvSpPr/>
           <p:nvPr/>
         </p:nvSpPr>
         <p:spPr>
           <a:xfrm>
-            <a:off x="548640" y="1371600"/>
-            <a:ext cx="64008" cy="4480560"/>
+            <a:off x="7680960" y="1371600"/>
+            <a:ext cx="64008" cy="2103120"/>
+          </a:xfrm>
+          <a:prstGeom prst="rect">
+            <a:avLst/>
+          </a:prstGeom>
+          <a:solidFill>
+            <a:schemeClr val="accent3"/>
+          </a:solidFill>
+          <a:ln w="12700">
+            <a:solidFill>
+              <a:schemeClr val="accent3"/>
+            </a:solidFill>
+            <a:prstDash val="solid"/>
+          </a:ln>
+        </p:spPr>
+      </p:sp>
+      <p:sp>
+        <p:nvSpPr>
+          <p:cNvPr id="7" name="Text 4"/>
+          <p:cNvSpPr txBox="1"/>
+          <p:nvPr/>
+        </p:nvSpPr>
+        <p:spPr>
+          <a:xfrm>
+            <a:off x="7909560" y="1536192"/>
+            <a:ext cx="3596335" cy="365760"/>
+          </a:xfrm>
+          <a:prstGeom prst="rect">
+            <a:avLst/>
+          </a:prstGeom>
+          <a:noFill/>
+          <a:ln/>
+        </p:spPr>
+        <p:txBody>
+          <a:bodyPr wrap="square" lIns="0" tIns="0" rIns="0" bIns="0" rtlCol="0" anchor="t"/>
+          <a:lstStyle/>
+          <a:p>
+            <a:pPr indent="0" marL="0">
+              <a:buNone/>
+            </a:pPr>
+            <a:r>
+              <a:rPr lang="en-US" sz="1400" b="1" dirty="0">
+                <a:solidFill>
+                  <a:schemeClr val="tx1"/>
+                </a:solidFill>
+              </a:rPr>
+              <a:t>E2E-01 Job  (2 min 25 s)</a:t>
+            </a:r>
+            <a:endParaRPr lang="en-US" sz="1400" dirty="0"/>
+          </a:p>
+        </p:txBody>
+      </p:sp>
+      <p:sp>
+        <p:nvSpPr>
+          <p:cNvPr id="8" name="Text 5"/>
+          <p:cNvSpPr txBox="1"/>
+          <p:nvPr/>
+        </p:nvSpPr>
+        <p:spPr>
+          <a:xfrm>
+            <a:off x="7909560" y="1938528"/>
+            <a:ext cx="3596335" cy="1417320"/>
+          </a:xfrm>
+          <a:prstGeom prst="rect">
+            <a:avLst/>
+          </a:prstGeom>
+          <a:noFill/>
+          <a:ln/>
+        </p:spPr>
+        <p:txBody>
+          <a:bodyPr wrap="square" lIns="0" tIns="0" rIns="0" bIns="0" rtlCol="0" anchor="t"/>
+          <a:lstStyle/>
+          <a:p>
+            <a:pPr indent="0" marL="0">
+              <a:lnSpc>
+                <a:spcPct val="115000"/>
+              </a:lnSpc>
+              <a:buNone/>
+            </a:pPr>
+            <a:r>
+              <a:rPr lang="en-US" sz="1200" dirty="0">
+                <a:solidFill>
+                  <a:schemeClr val="tx1"/>
+                </a:solidFill>
+              </a:rPr>
+              <a:t>TC-23-001-web-and-app.mp4 (22 Oct)</a:t>
+            </a:r>
+            <a:endParaRPr lang="en-US" sz="1200" dirty="0"/>
+          </a:p>
+          <a:p>
+            <a:pPr indent="0" marL="0">
+              <a:lnSpc>
+                <a:spcPct val="115000"/>
+              </a:lnSpc>
+              <a:buNone/>
+            </a:pPr>
+            <a:r>
+              <a:rPr lang="en-US" sz="1200" dirty="0">
+                <a:solidFill>
+                  <a:schemeClr val="tx1"/>
+                </a:solidFill>
+              </a:rPr>
+              <a:t>Portal left, phone right; a caption bar names each of the 11 steps.</a:t>
+            </a:r>
+            <a:endParaRPr lang="en-US" sz="1200" dirty="0"/>
+          </a:p>
+        </p:txBody>
+      </p:sp>
+      <p:sp>
+        <p:nvSpPr>
+          <p:cNvPr id="9" name="card E2E-02 Announcement  (55 s)"/>
+          <p:cNvSpPr/>
+          <p:nvPr/>
+        </p:nvSpPr>
+        <p:spPr>
+          <a:xfrm>
+            <a:off x="7680960" y="3657600"/>
+            <a:ext cx="3962095" cy="2194560"/>
+          </a:xfrm>
+          <a:prstGeom prst="rect">
+            <a:avLst/>
+          </a:prstGeom>
+          <a:solidFill>
+            <a:schemeClr val="bg2"/>
+          </a:solidFill>
+          <a:ln w="12700">
+            <a:solidFill>
+              <a:schemeClr val="bg2"/>
+            </a:solidFill>
+            <a:prstDash val="solid"/>
+          </a:ln>
+        </p:spPr>
+      </p:sp>
+      <p:sp>
+        <p:nvSpPr>
+          <p:cNvPr id="10" name="card edge E2E-02 Announcement  (55 s)"/>
+          <p:cNvSpPr/>
+          <p:nvPr/>
+        </p:nvSpPr>
+        <p:spPr>
+          <a:xfrm>
+            <a:off x="7680960" y="3657600"/>
+            <a:ext cx="64008" cy="2194560"/>
           </a:xfrm>
           <a:prstGeom prst="rect">
             <a:avLst/>
@@ -5322,14 +5615,14 @@
       </p:sp>
       <p:sp>
         <p:nvSpPr>
-          <p:cNvPr id="5" name="Text 3"/>
+          <p:cNvPr id="11" name="Text 8"/>
           <p:cNvSpPr txBox="1"/>
           <p:nvPr/>
         </p:nvSpPr>
         <p:spPr>
           <a:xfrm>
-            <a:off x="777240" y="1536192"/>
-            <a:ext cx="5120640" cy="365760"/>
+            <a:off x="7909560" y="3822192"/>
+            <a:ext cx="3596335" cy="365760"/>
           </a:xfrm>
           <a:prstGeom prst="rect">
             <a:avLst/>
@@ -5345,27 +5638,27 @@
               <a:buNone/>
             </a:pPr>
             <a:r>
-              <a:rPr lang="en-US" sz="1500" b="1" dirty="0">
+              <a:rPr lang="en-US" sz="1400" b="1" dirty="0">
                 <a:solidFill>
                   <a:schemeClr val="tx1"/>
                 </a:solidFill>
               </a:rPr>
-              <a:t>Found while building the suites</a:t>
-            </a:r>
-            <a:endParaRPr lang="en-US" sz="1500" dirty="0"/>
-          </a:p>
-        </p:txBody>
-      </p:sp>
-      <p:sp>
-        <p:nvSpPr>
-          <p:cNvPr id="6" name="Text 4"/>
+              <a:t>E2E-02 Announcement  (55 s)</a:t>
+            </a:r>
+            <a:endParaRPr lang="en-US" sz="1400" dirty="0"/>
+          </a:p>
+        </p:txBody>
+      </p:sp>
+      <p:sp>
+        <p:nvSpPr>
+          <p:cNvPr id="12" name="Text 9"/>
           <p:cNvSpPr txBox="1"/>
           <p:nvPr/>
         </p:nvSpPr>
         <p:spPr>
           <a:xfrm>
-            <a:off x="777240" y="1938528"/>
-            <a:ext cx="5120640" cy="3794760"/>
+            <a:off x="7909560" y="4224528"/>
+            <a:ext cx="3596335" cy="1508760"/>
           </a:xfrm>
           <a:prstGeom prst="rect">
             <a:avLst/>
@@ -5377,143 +5670,195 @@
           <a:bodyPr wrap="square" lIns="0" tIns="0" rIns="0" bIns="0" rtlCol="0" anchor="t"/>
           <a:lstStyle/>
           <a:p>
-            <a:pPr marL="342900" indent="-342900">
+            <a:pPr indent="0" marL="0">
               <a:lnSpc>
                 <a:spcPct val="115000"/>
               </a:lnSpc>
-              <a:buSzPct val="100000"/>
-              <a:buChar char="•"/>
-            </a:pPr>
-            <a:r>
-              <a:rPr lang="en-US" sz="1300" dirty="0">
+              <a:buNone/>
+            </a:pPr>
+            <a:r>
+              <a:rPr lang="en-US" sz="1200" dirty="0">
                 <a:solidFill>
                   <a:schemeClr val="tx1"/>
                 </a:solidFill>
               </a:rPr>
-              <a:t>Job save checks no mandatory fields; dispatch does not check service or location</a:t>
-            </a:r>
-            <a:endParaRPr lang="en-US" sz="1300" dirty="0"/>
-          </a:p>
-          <a:p>
-            <a:pPr marL="342900" indent="-342900">
+              <a:t>TC-23-003-web-and-app.mp4 (22 Oct)</a:t>
+            </a:r>
+            <a:endParaRPr lang="en-US" sz="1200" dirty="0"/>
+          </a:p>
+          <a:p>
+            <a:pPr indent="0" marL="0">
               <a:lnSpc>
                 <a:spcPct val="115000"/>
               </a:lnSpc>
-              <a:buSzPct val="100000"/>
-              <a:buChar char="•"/>
-            </a:pPr>
-            <a:r>
-              <a:rPr lang="en-US" sz="1300" dirty="0">
+              <a:buNone/>
+            </a:pPr>
+            <a:r>
+              <a:rPr lang="en-US" sz="1200" dirty="0">
                 <a:solidFill>
                   <a:schemeClr val="tx1"/>
                 </a:solidFill>
               </a:rPr>
-              <a:t>Double-click Save / Dispatch and two agents at once are not blocked</a:t>
-            </a:r>
-            <a:endParaRPr lang="en-US" sz="1300" dirty="0"/>
-          </a:p>
-          <a:p>
-            <a:pPr marL="342900" indent="-342900">
-              <a:lnSpc>
-                <a:spcPct val="115000"/>
-              </a:lnSpc>
-              <a:buSzPct val="100000"/>
-              <a:buChar char="•"/>
-            </a:pPr>
-            <a:r>
-              <a:rPr lang="en-US" sz="1300" dirty="0">
+              <a:t>Same layout, 8 captioned steps.</a:t>
+            </a:r>
+            <a:endParaRPr lang="en-US" sz="1200" dirty="0"/>
+          </a:p>
+        </p:txBody>
+      </p:sp>
+      <p:sp>
+        <p:nvSpPr>
+          <p:cNvPr id="13" name="Text 10"/>
+          <p:cNvSpPr txBox="1"/>
+          <p:nvPr/>
+        </p:nvSpPr>
+        <p:spPr>
+          <a:xfrm>
+            <a:off x="548640" y="5120803"/>
+            <a:ext cx="6766560" cy="548640"/>
+          </a:xfrm>
+          <a:prstGeom prst="rect">
+            <a:avLst/>
+          </a:prstGeom>
+          <a:noFill/>
+          <a:ln/>
+        </p:spPr>
+        <p:txBody>
+          <a:bodyPr wrap="square" lIns="0" tIns="0" rIns="0" bIns="0" rtlCol="0" anchor="t"/>
+          <a:lstStyle/>
+          <a:p>
+            <a:pPr indent="0" marL="0">
+              <a:buNone/>
+            </a:pPr>
+            <a:r>
+              <a:rPr lang="en-US" sz="1200" dirty="0">
+                <a:solidFill>
+                  <a:schemeClr val="accent4"/>
+                </a:solidFill>
+              </a:rPr>
+              <a:t>What to watch: the job number appearing on the phone after Dispatch, and the timestamps arriving on the portal after each tap.</a:t>
+            </a:r>
+            <a:endParaRPr lang="en-US" sz="1200" dirty="0"/>
+          </a:p>
+        </p:txBody>
+      </p:sp>
+      <p:sp>
+        <p:nvSpPr>
+          <p:cNvPr id="25" name="Slide Number Placeholder 0"/>
+          <p:cNvSpPr>
+            <a:spLocks noGrp="1"/>
+          </p:cNvSpPr>
+          <p:nvPr>
+            <p:ph type="sldNum" sz="quarter" idx="4294967295"/>
+          </p:nvPr>
+        </p:nvSpPr>
+        <p:spPr>
+          <a:xfrm>
+            <a:off x="11094415" y="6473952"/>
+            <a:ext cx="548640" cy="274320"/>
+          </a:xfrm>
+          <a:prstGeom prst="rect">
+            <a:avLst/>
+          </a:prstGeom>
+          <a:extLst>
+            <a:ext uri="{C572A759-6A51-4108-AA02-DFA0A04FC94B}">
+              <ma14:wrappingTextBoxFlag xmlns:ma14="http://schemas.microsoft.com/office/mac/drawingml/2011/main" val="0"/>
+            </a:ext>
+          </a:extLst>
+        </p:spPr>
+        <p:txBody>
+          <a:bodyPr/>
+          <a:lstStyle>
+            <a:lvl1pPr>
+              <a:defRPr sz="900">
+                <a:solidFill>
+                  <a:srgbClr val="71717A"/>
+                </a:solidFill>
+              </a:defRPr>
+            </a:lvl1pPr>
+          </a:lstStyle>
+          <a:p>
+            <a:pPr algn="r"/>
+            <a:fld id="{F7021451-1387-4CA6-816F-3879F97B5CBC}" type="slidenum">
+              <a:rPr b="0" lang="en-US"/>
+              <a:t>12</a:t>
+            </a:fld>
+            <a:endParaRPr lang="en-US"/>
+          </a:p>
+        </p:txBody>
+      </p:sp>
+    </p:spTree>
+  </p:cSld>
+  <p:clrMapOvr>
+    <a:masterClrMapping/>
+  </p:clrMapOvr>
+</p:sld>
+</file>
+
+<file path=ppt/slides/slide13.xml><?xml version="1.0" encoding="utf-8"?>
+<p:sld xmlns:a="http://schemas.openxmlformats.org/drawingml/2006/main" xmlns:r="http://schemas.openxmlformats.org/officeDocument/2006/relationships" xmlns:p="http://schemas.openxmlformats.org/presentationml/2006/main">
+  <p:cSld name="Slide 13">
+    <p:spTree>
+      <p:nvGrpSpPr>
+        <p:cNvPr id="1" name=""/>
+        <p:cNvGrpSpPr/>
+        <p:nvPr/>
+      </p:nvGrpSpPr>
+      <p:grpSpPr>
+        <a:xfrm>
+          <a:off x="0" y="0"/>
+          <a:ext cx="0" cy="0"/>
+          <a:chOff x="0" y="0"/>
+          <a:chExt cx="0" cy="0"/>
+        </a:xfrm>
+      </p:grpSpPr>
+      <p:sp>
+        <p:nvSpPr>
+          <p:cNvPr id="2" name="Text 0"/>
+          <p:cNvSpPr/>
+          <p:nvPr>
+            <p:ph idx="100" type="title" hasCustomPrompt="1"/>
+          </p:nvPr>
+        </p:nvSpPr>
+        <p:spPr>
+          <a:xfrm>
+            <a:off x="548640" y="320040"/>
+            <a:ext cx="11094415" cy="640080"/>
+          </a:xfrm>
+          <a:prstGeom prst="rect">
+            <a:avLst/>
+          </a:prstGeom>
+          <a:noFill/>
+          <a:ln/>
+        </p:spPr>
+        <p:txBody>
+          <a:bodyPr wrap="square" rtlCol="0" anchor="t"/>
+          <a:lstStyle/>
+          <a:p>
+            <a:pPr algn="l" indent="0" marL="0">
+              <a:buNone/>
+            </a:pPr>
+            <a:r>
+              <a:rPr lang="en-US" sz="2600" b="1" dirty="0">
                 <a:solidFill>
                   <a:schemeClr val="tx1"/>
                 </a:solidFill>
               </a:rPr>
-              <a:t>Load Provider lists busy trucks nationwide; stale GPS never excluded</a:t>
-            </a:r>
-            <a:endParaRPr lang="en-US" sz="1300" dirty="0"/>
-          </a:p>
-          <a:p>
-            <a:pPr marL="342900" indent="-342900">
-              <a:lnSpc>
-                <a:spcPct val="115000"/>
-              </a:lnSpc>
-              <a:buSzPct val="100000"/>
-              <a:buChar char="•"/>
-            </a:pPr>
-            <a:r>
-              <a:rPr lang="en-US" sz="1300" dirty="0">
-                <a:solidFill>
-                  <a:schemeClr val="tx1"/>
-                </a:solidFill>
-              </a:rPr>
-              <a:t>Benefit timeout + retry can strand a job (31 Aug incident)</a:t>
-            </a:r>
-            <a:endParaRPr lang="en-US" sz="1300" dirty="0"/>
-          </a:p>
-          <a:p>
-            <a:pPr marL="342900" indent="-342900">
-              <a:lnSpc>
-                <a:spcPct val="115000"/>
-              </a:lnSpc>
-              <a:buSzPct val="100000"/>
-              <a:buChar char="•"/>
-            </a:pPr>
-            <a:r>
-              <a:rPr lang="en-US" sz="1300" dirty="0">
-                <a:solidFill>
-                  <a:schemeClr val="tx1"/>
-                </a:solidFill>
-              </a:rPr>
-              <a:t>No role checks on job actions</a:t>
-            </a:r>
-            <a:endParaRPr lang="en-US" sz="1300" dirty="0"/>
-          </a:p>
-          <a:p>
-            <a:pPr marL="342900" indent="-342900">
-              <a:lnSpc>
-                <a:spcPct val="115000"/>
-              </a:lnSpc>
-              <a:buSzPct val="100000"/>
-              <a:buChar char="•"/>
-            </a:pPr>
-            <a:r>
-              <a:rPr lang="en-US" sz="1300" dirty="0">
-                <a:solidFill>
-                  <a:schemeClr val="tx1"/>
-                </a:solidFill>
-              </a:rPr>
-              <a:t>Announcements cannot be targeted; no read tracking</a:t>
-            </a:r>
-            <a:endParaRPr lang="en-US" sz="1300" dirty="0"/>
-          </a:p>
-          <a:p>
-            <a:pPr marL="342900" indent="-342900">
-              <a:lnSpc>
-                <a:spcPct val="115000"/>
-              </a:lnSpc>
-              <a:buSzPct val="100000"/>
-              <a:buChar char="•"/>
-            </a:pPr>
-            <a:r>
-              <a:rPr lang="en-US" sz="1300" dirty="0">
-                <a:solidFill>
-                  <a:schemeClr val="tx1"/>
-                </a:solidFill>
-              </a:rPr>
-              <a:t>App writes the login password to the device log (UAT build)</a:t>
-            </a:r>
-            <a:endParaRPr lang="en-US" sz="1300" dirty="0"/>
-          </a:p>
-        </p:txBody>
-      </p:sp>
-      <p:sp>
-        <p:nvSpPr>
-          <p:cNvPr id="7" name="card Next"/>
+              <a:t>What the work found, and what we need next</a:t>
+            </a:r>
+            <a:endParaRPr lang="en-US" sz="2600" dirty="0"/>
+          </a:p>
+        </p:txBody>
+      </p:sp>
+      <p:sp>
+        <p:nvSpPr>
+          <p:cNvPr id="3" name="card Found while building the suites"/>
           <p:cNvSpPr/>
           <p:nvPr/>
         </p:nvSpPr>
         <p:spPr>
           <a:xfrm>
-            <a:off x="6263640" y="1371600"/>
-            <a:ext cx="5379415" cy="4480560"/>
+            <a:off x="548640" y="1371600"/>
+            <a:ext cx="5486400" cy="4480560"/>
           </a:xfrm>
           <a:prstGeom prst="rect">
             <a:avLst/>
@@ -5531,6 +5876,240 @@
       </p:sp>
       <p:sp>
         <p:nvSpPr>
+          <p:cNvPr id="4" name="card edge Found while building the suites"/>
+          <p:cNvSpPr/>
+          <p:nvPr/>
+        </p:nvSpPr>
+        <p:spPr>
+          <a:xfrm>
+            <a:off x="548640" y="1371600"/>
+            <a:ext cx="64008" cy="4480560"/>
+          </a:xfrm>
+          <a:prstGeom prst="rect">
+            <a:avLst/>
+          </a:prstGeom>
+          <a:solidFill>
+            <a:schemeClr val="accent2"/>
+          </a:solidFill>
+          <a:ln w="12700">
+            <a:solidFill>
+              <a:schemeClr val="accent2"/>
+            </a:solidFill>
+            <a:prstDash val="solid"/>
+          </a:ln>
+        </p:spPr>
+      </p:sp>
+      <p:sp>
+        <p:nvSpPr>
+          <p:cNvPr id="5" name="Text 3"/>
+          <p:cNvSpPr txBox="1"/>
+          <p:nvPr/>
+        </p:nvSpPr>
+        <p:spPr>
+          <a:xfrm>
+            <a:off x="777240" y="1536192"/>
+            <a:ext cx="5120640" cy="365760"/>
+          </a:xfrm>
+          <a:prstGeom prst="rect">
+            <a:avLst/>
+          </a:prstGeom>
+          <a:noFill/>
+          <a:ln/>
+        </p:spPr>
+        <p:txBody>
+          <a:bodyPr wrap="square" lIns="0" tIns="0" rIns="0" bIns="0" rtlCol="0" anchor="t"/>
+          <a:lstStyle/>
+          <a:p>
+            <a:pPr indent="0" marL="0">
+              <a:buNone/>
+            </a:pPr>
+            <a:r>
+              <a:rPr lang="en-US" sz="1500" b="1" dirty="0">
+                <a:solidFill>
+                  <a:schemeClr val="tx1"/>
+                </a:solidFill>
+              </a:rPr>
+              <a:t>Found while building the suites</a:t>
+            </a:r>
+            <a:endParaRPr lang="en-US" sz="1500" dirty="0"/>
+          </a:p>
+        </p:txBody>
+      </p:sp>
+      <p:sp>
+        <p:nvSpPr>
+          <p:cNvPr id="6" name="Text 4"/>
+          <p:cNvSpPr txBox="1"/>
+          <p:nvPr/>
+        </p:nvSpPr>
+        <p:spPr>
+          <a:xfrm>
+            <a:off x="777240" y="1938528"/>
+            <a:ext cx="5120640" cy="3794760"/>
+          </a:xfrm>
+          <a:prstGeom prst="rect">
+            <a:avLst/>
+          </a:prstGeom>
+          <a:noFill/>
+          <a:ln/>
+        </p:spPr>
+        <p:txBody>
+          <a:bodyPr wrap="square" lIns="0" tIns="0" rIns="0" bIns="0" rtlCol="0" anchor="t"/>
+          <a:lstStyle/>
+          <a:p>
+            <a:pPr marL="342900" indent="-342900">
+              <a:lnSpc>
+                <a:spcPct val="115000"/>
+              </a:lnSpc>
+              <a:buSzPct val="100000"/>
+              <a:buChar char="•"/>
+            </a:pPr>
+            <a:r>
+              <a:rPr lang="en-US" sz="1300" dirty="0">
+                <a:solidFill>
+                  <a:schemeClr val="tx1"/>
+                </a:solidFill>
+              </a:rPr>
+              <a:t>Job save checks no mandatory fields; dispatch does not check service or location</a:t>
+            </a:r>
+            <a:endParaRPr lang="en-US" sz="1300" dirty="0"/>
+          </a:p>
+          <a:p>
+            <a:pPr marL="342900" indent="-342900">
+              <a:lnSpc>
+                <a:spcPct val="115000"/>
+              </a:lnSpc>
+              <a:buSzPct val="100000"/>
+              <a:buChar char="•"/>
+            </a:pPr>
+            <a:r>
+              <a:rPr lang="en-US" sz="1300" dirty="0">
+                <a:solidFill>
+                  <a:schemeClr val="tx1"/>
+                </a:solidFill>
+              </a:rPr>
+              <a:t>Double-click Save / Dispatch and two agents at once are not blocked</a:t>
+            </a:r>
+            <a:endParaRPr lang="en-US" sz="1300" dirty="0"/>
+          </a:p>
+          <a:p>
+            <a:pPr marL="342900" indent="-342900">
+              <a:lnSpc>
+                <a:spcPct val="115000"/>
+              </a:lnSpc>
+              <a:buSzPct val="100000"/>
+              <a:buChar char="•"/>
+            </a:pPr>
+            <a:r>
+              <a:rPr lang="en-US" sz="1300" dirty="0">
+                <a:solidFill>
+                  <a:schemeClr val="tx1"/>
+                </a:solidFill>
+              </a:rPr>
+              <a:t>Load Provider lists busy trucks nationwide; stale GPS never excluded</a:t>
+            </a:r>
+            <a:endParaRPr lang="en-US" sz="1300" dirty="0"/>
+          </a:p>
+          <a:p>
+            <a:pPr marL="342900" indent="-342900">
+              <a:lnSpc>
+                <a:spcPct val="115000"/>
+              </a:lnSpc>
+              <a:buSzPct val="100000"/>
+              <a:buChar char="•"/>
+            </a:pPr>
+            <a:r>
+              <a:rPr lang="en-US" sz="1300" dirty="0">
+                <a:solidFill>
+                  <a:schemeClr val="tx1"/>
+                </a:solidFill>
+              </a:rPr>
+              <a:t>Benefit timeout + retry can strand a job (31 Aug incident)</a:t>
+            </a:r>
+            <a:endParaRPr lang="en-US" sz="1300" dirty="0"/>
+          </a:p>
+          <a:p>
+            <a:pPr marL="342900" indent="-342900">
+              <a:lnSpc>
+                <a:spcPct val="115000"/>
+              </a:lnSpc>
+              <a:buSzPct val="100000"/>
+              <a:buChar char="•"/>
+            </a:pPr>
+            <a:r>
+              <a:rPr lang="en-US" sz="1300" dirty="0">
+                <a:solidFill>
+                  <a:schemeClr val="tx1"/>
+                </a:solidFill>
+              </a:rPr>
+              <a:t>No role checks on job actions</a:t>
+            </a:r>
+            <a:endParaRPr lang="en-US" sz="1300" dirty="0"/>
+          </a:p>
+          <a:p>
+            <a:pPr marL="342900" indent="-342900">
+              <a:lnSpc>
+                <a:spcPct val="115000"/>
+              </a:lnSpc>
+              <a:buSzPct val="100000"/>
+              <a:buChar char="•"/>
+            </a:pPr>
+            <a:r>
+              <a:rPr lang="en-US" sz="1300" dirty="0">
+                <a:solidFill>
+                  <a:schemeClr val="tx1"/>
+                </a:solidFill>
+              </a:rPr>
+              <a:t>Announcements cannot be targeted; no read tracking</a:t>
+            </a:r>
+            <a:endParaRPr lang="en-US" sz="1300" dirty="0"/>
+          </a:p>
+          <a:p>
+            <a:pPr marL="342900" indent="-342900">
+              <a:lnSpc>
+                <a:spcPct val="115000"/>
+              </a:lnSpc>
+              <a:buSzPct val="100000"/>
+              <a:buChar char="•"/>
+            </a:pPr>
+            <a:r>
+              <a:rPr lang="en-US" sz="1300" dirty="0">
+                <a:solidFill>
+                  <a:schemeClr val="tx1"/>
+                </a:solidFill>
+              </a:rPr>
+              <a:t>App writes the login password to the device log (UAT build)</a:t>
+            </a:r>
+            <a:endParaRPr lang="en-US" sz="1300" dirty="0"/>
+          </a:p>
+        </p:txBody>
+      </p:sp>
+      <p:sp>
+        <p:nvSpPr>
+          <p:cNvPr id="7" name="card Next"/>
+          <p:cNvSpPr/>
+          <p:nvPr/>
+        </p:nvSpPr>
+        <p:spPr>
+          <a:xfrm>
+            <a:off x="6263640" y="1371600"/>
+            <a:ext cx="5379415" cy="4480560"/>
+          </a:xfrm>
+          <a:prstGeom prst="rect">
+            <a:avLst/>
+          </a:prstGeom>
+          <a:solidFill>
+            <a:schemeClr val="bg2"/>
+          </a:solidFill>
+          <a:ln w="12700">
+            <a:solidFill>
+              <a:schemeClr val="bg2"/>
+            </a:solidFill>
+            <a:prstDash val="solid"/>
+          </a:ln>
+        </p:spPr>
+      </p:sp>
+      <p:sp>
+        <p:nvSpPr>
           <p:cNvPr id="8" name="card edge Next"/>
           <p:cNvSpPr/>
           <p:nvPr/>
@@ -5642,7 +6221,7 @@
                   <a:schemeClr val="tx1"/>
                 </a:solidFill>
               </a:rPr>
-              <a:t>Run E2E-02 and record both journeys with step captions</a:t>
+              <a:t>Run both journeys before each release; keep the report and video as release evidence</a:t>
             </a:r>
             <a:endParaRPr lang="en-US" sz="1300" dirty="0"/>
           </a:p>
@@ -5723,7 +6302,7 @@
             <a:pPr algn="r"/>
             <a:fld id="{F7021451-1387-4CA6-816F-3879F97B5CBC}" type="slidenum">
               <a:rPr b="0" lang="en-US"/>
-              <a:t>12</a:t>
+              <a:t>13</a:t>
             </a:fld>
             <a:endParaRPr lang="en-US"/>
           </a:p>
@@ -9229,7 +9808,7 @@
                   <a:schemeClr val="accent3"/>
                 </a:solidFill>
               </a:rPr>
-              <a:t>PASSED 20 Oct 2026  ·  ~4.5 min  ·  11 steps</a:t>
+              <a:t>PASSED 22 Oct 2026  ·  3.7 min  ·  11 steps  ·  job 26JB049155</a:t>
             </a:r>
             <a:endParaRPr lang="en-US" sz="1300" dirty="0"/>
           </a:p>
@@ -9275,11 +9854,11 @@
             <a:avLst/>
           </a:prstGeom>
           <a:solidFill>
-            <a:schemeClr val="accent2"/>
+            <a:schemeClr val="accent3"/>
           </a:solidFill>
           <a:ln w="12700">
             <a:solidFill>
-              <a:schemeClr val="accent2"/>
+              <a:schemeClr val="accent3"/>
             </a:solidFill>
             <a:prstDash val="solid"/>
           </a:ln>
@@ -9420,10 +9999,10 @@
             <a:r>
               <a:rPr lang="en-US" sz="1300" b="1" dirty="0">
                 <a:solidFill>
-                  <a:schemeClr val="accent2"/>
-                </a:solidFill>
-              </a:rPr>
-              <a:t>Built 22 Oct 2026  ·  first run next  ·  8 steps</a:t>
+                  <a:schemeClr val="accent3"/>
+                </a:solidFill>
+              </a:rPr>
+              <a:t>PASSED 22 Oct 2026  ·  1.6 min  ·  8 steps  ·  switched off at the end</a:t>
             </a:r>
             <a:endParaRPr lang="en-US" sz="1300" dirty="0"/>
           </a:p>
@@ -9813,7 +10392,7 @@
                   <a:schemeClr val="tx1"/>
                 </a:solidFill>
               </a:rPr>
-              <a:t>Driver signed in, Ready on</a:t>
+              <a:t>Driver signs in, truck v3036, Ready on</a:t>
             </a:r>
             <a:endParaRPr lang="en-US" sz="950" dirty="0"/>
           </a:p>
@@ -9912,7 +10491,7 @@
                   <a:schemeClr val="tx1"/>
                 </a:solidFill>
               </a:rPr>
-              <a:t>Agent creates job (Thai address)</a:t>
+              <a:t>Agent creates the job (Thai address)</a:t>
             </a:r>
             <a:endParaRPr lang="en-US" sz="950" dirty="0"/>
           </a:p>
@@ -10011,7 +10590,7 @@
                   <a:schemeClr val="tx1"/>
                 </a:solidFill>
               </a:rPr>
-              <a:t>Sets incident pin</a:t>
+              <a:t>Agent sets the incident pin</a:t>
             </a:r>
             <a:endParaRPr lang="en-US" sz="950" dirty="0"/>
           </a:p>
@@ -10110,7 +10689,7 @@
                   <a:schemeClr val="tx1"/>
                 </a:solidFill>
               </a:rPr>
-              <a:t>Assigns truck, Dispatch</a:t>
+              <a:t>Agent assigns truck v3036 and dispatches</a:t>
             </a:r>
             <a:endParaRPr lang="en-US" sz="950" dirty="0"/>
           </a:p>
@@ -10209,7 +10788,7 @@
                   <a:schemeClr val="tx1"/>
                 </a:solidFill>
               </a:rPr>
-              <a:t>Job appears, 9.7 km</a:t>
+              <a:t>Job card appears on the phone</a:t>
             </a:r>
             <a:endParaRPr lang="en-US" sz="950" dirty="0"/>
           </a:p>
@@ -10308,7 +10887,7 @@
                   <a:schemeClr val="tx1"/>
                 </a:solidFill>
               </a:rPr>
-              <a:t>Take Job</a:t>
+              <a:t>Driver taps Take Job</a:t>
             </a:r>
             <a:endParaRPr lang="en-US" sz="950" dirty="0"/>
           </a:p>
@@ -10407,7 +10986,7 @@
                   <a:schemeClr val="tx1"/>
                 </a:solidFill>
               </a:rPr>
-              <a:t>Drives ~5 km by road</a:t>
+              <a:t>Truck drives ~5 km by road</a:t>
             </a:r>
             <a:endParaRPr lang="en-US" sz="950" dirty="0"/>
           </a:p>
@@ -10506,7 +11085,7 @@
                   <a:schemeClr val="tx1"/>
                 </a:solidFill>
               </a:rPr>
-              <a:t>Arrive + mileage 48215</a:t>
+              <a:t>Arrived, odometer 48215</a:t>
             </a:r>
             <a:endParaRPr lang="en-US" sz="950" dirty="0"/>
           </a:p>
@@ -10605,7 +11184,7 @@
                   <a:schemeClr val="tx1"/>
                 </a:solidFill>
               </a:rPr>
-              <a:t>Photo, upload</a:t>
+              <a:t>Photo taken and uploaded</a:t>
             </a:r>
             <a:endParaRPr lang="en-US" sz="950" dirty="0"/>
           </a:p>
@@ -10704,7 +11283,7 @@
                   <a:schemeClr val="tx1"/>
                 </a:solidFill>
               </a:rPr>
-              <a:t>Finish job</a:t>
+              <a:t>Driver finishes the job</a:t>
             </a:r>
             <a:endParaRPr lang="en-US" sz="950" dirty="0"/>
           </a:p>
@@ -10803,7 +11382,7 @@
                   <a:schemeClr val="tx1"/>
                 </a:solidFill>
               </a:rPr>
-              <a:t>CLOSED, timestamps by truck</a:t>
+              <a:t>Portal shows CLOSED with the driver's timestamps</a:t>
             </a:r>
             <a:endParaRPr lang="en-US" sz="950" dirty="0"/>
           </a:p>
@@ -14083,7 +14662,7 @@
       </p:sp>
       <p:pic>
         <p:nvPicPr>
-          <p:cNvPr id="3" name="t30.png" descr="C:\Projects\AspireDigital\ai-workshop\presentations\e2e-img\t30.png">    </p:cNvPr>
+          <p:cNvPr id="3" name="j5.png" descr="C:\Projects\AspireDigital\ai-workshop\presentations\e2e-img\j5.png">    </p:cNvPr>
           <p:cNvPicPr>
             <a:picLocks noChangeAspect="1"/>
           </p:cNvPicPr>
@@ -14107,7 +14686,7 @@
       </p:pic>
       <p:sp>
         <p:nvSpPr>
-          <p:cNvPr id="4" name="frame t30.png"/>
+          <p:cNvPr id="4" name="frame j5.png"/>
           <p:cNvSpPr/>
           <p:nvPr/>
         </p:nvSpPr>
@@ -14157,7 +14736,7 @@
                   <a:schemeClr val="tx1"/>
                 </a:solidFill>
               </a:rPr>
-              <a:t>Step 5: dispatched on the portal, the job is on the phone 9.70 km away</a:t>
+              <a:t>Step 5: dispatched on the portal; the job card is on the phone, 9.60 km away</a:t>
             </a:r>
             <a:endParaRPr lang="en-US" sz="1200" dirty="0"/>
           </a:p>
@@ -14165,7 +14744,7 @@
       </p:sp>
       <p:pic>
         <p:nvPicPr>
-          <p:cNvPr id="6" name="t105.png" descr="C:\Projects\AspireDigital\ai-workshop\presentations\e2e-img\t105.png">    </p:cNvPr>
+          <p:cNvPr id="6" name="j8.png" descr="C:\Projects\AspireDigital\ai-workshop\presentations\e2e-img\j8.png">    </p:cNvPr>
           <p:cNvPicPr>
             <a:picLocks noChangeAspect="1"/>
           </p:cNvPicPr>
@@ -14189,7 +14768,7 @@
       </p:pic>
       <p:sp>
         <p:nvSpPr>
-          <p:cNvPr id="7" name="frame t105.png"/>
+          <p:cNvPr id="7" name="frame j8.png"/>
           <p:cNvSpPr/>
           <p:nvPr/>
         </p:nvSpPr>
@@ -14247,7 +14826,7 @@
       </p:sp>
       <p:pic>
         <p:nvPicPr>
-          <p:cNvPr id="9" name="t165.png" descr="C:\Projects\AspireDigital\ai-workshop\presentations\e2e-img\t165.png">    </p:cNvPr>
+          <p:cNvPr id="9" name="j11.png" descr="C:\Projects\AspireDigital\ai-workshop\presentations\e2e-img\j11.png">    </p:cNvPr>
           <p:cNvPicPr>
             <a:picLocks noChangeAspect="1"/>
           </p:cNvPicPr>
@@ -14271,7 +14850,7 @@
       </p:pic>
       <p:sp>
         <p:nvSpPr>
-          <p:cNvPr id="10" name="frame t165.png"/>
+          <p:cNvPr id="10" name="frame j11.png"/>
           <p:cNvSpPr/>
           <p:nvPr/>
         </p:nvSpPr>
@@ -14321,7 +14900,7 @@
                   <a:schemeClr val="tx1"/>
                 </a:solidFill>
               </a:rPr>
-              <a:t>Step 11: portal shows ACCEPT / REACH / COMPLETE by truck v3036, KPI Pass</a:t>
+              <a:t>Step 11: portal shows ACCEPT / REACH / COMPLETE by truck v3036, KPI Pass; phone shows the route</a:t>
             </a:r>
             <a:endParaRPr lang="en-US" sz="1200" dirty="0"/>
           </a:p>
@@ -14329,7 +14908,7 @@
       </p:sp>
       <p:sp>
         <p:nvSpPr>
-          <p:cNvPr id="12" name="card Result 20 Oct 2026: PASSED, job 26JB049153"/>
+          <p:cNvPr id="12" name="card Result 22 Oct 2026: PASSED in 3.7 min, job 26JB049155"/>
           <p:cNvSpPr/>
           <p:nvPr/>
         </p:nvSpPr>
@@ -14354,7 +14933,7 @@
       </p:sp>
       <p:sp>
         <p:nvSpPr>
-          <p:cNvPr id="13" name="card edge Result 20 Oct 2026: PASSED, job 26JB049153"/>
+          <p:cNvPr id="13" name="card edge Result 22 Oct 2026: PASSED in 3.7 min, job 26JB049155"/>
           <p:cNvSpPr/>
           <p:nvPr/>
         </p:nvSpPr>
@@ -14407,7 +14986,7 @@
                   <a:schemeClr val="tx1"/>
                 </a:solidFill>
               </a:rPr>
-              <a:t>Result 20 Oct 2026: PASSED, job 26JB049153</a:t>
+              <a:t>Result 22 Oct 2026: PASSED in 3.7 min, job 26JB049155</a:t>
             </a:r>
             <a:endParaRPr lang="en-US" sz="1400" dirty="0"/>
           </a:p>
@@ -14446,7 +15025,7 @@
                   <a:schemeClr val="tx1"/>
                 </a:solidFill>
               </a:rPr>
-              <a:t>Job card 9.70 km, portal road distance 7 km, mileage 48215, 1 photo, status CLOSED, KPI Pass on accept / reach / complete. Evidence: side-by-side video, Playwright report and trace.</a:t>
+              <a:t>All 11 steps passed. Job card 9.60 km, portal road distance 9.6 km, mileage 48215, 1 photo, status CLOSED, KPI Pass on accept / reach / complete. Evidence: captioned side-by-side video, Playwright report and trace. Also passed on 20 Oct (job 26JB049153).</a:t>
             </a:r>
             <a:endParaRPr lang="en-US" sz="1250" dirty="0"/>
           </a:p>
@@ -14935,7 +15514,7 @@
                   <a:schemeClr val="tx1"/>
                 </a:solidFill>
               </a:rPr>
-              <a:t>Admin creates High announcement</a:t>
+              <a:t>Admin creates a High announcement and publishes</a:t>
             </a:r>
             <a:endParaRPr lang="en-US" sz="950" dirty="0"/>
           </a:p>
@@ -15034,7 +15613,7 @@
                   <a:schemeClr val="tx1"/>
                 </a:solidFill>
               </a:rPr>
-              <a:t>List: Approved, Active</a:t>
+              <a:t>List shows Approved, Active, High</a:t>
             </a:r>
             <a:endParaRPr lang="en-US" sz="950" dirty="0"/>
           </a:p>
@@ -15331,7 +15910,7 @@
                   <a:schemeClr val="tx1"/>
                 </a:solidFill>
               </a:rPr>
-              <a:t>Home: high-priority banner</a:t>
+              <a:t>Home shows the high-priority banner</a:t>
             </a:r>
             <a:endParaRPr lang="en-US" sz="950" dirty="0"/>
           </a:p>
@@ -15529,7 +16108,7 @@
                   <a:schemeClr val="tx1"/>
                 </a:solidFill>
               </a:rPr>
-              <a:t>Gone from News</a:t>
+              <a:t>Gone from the News tab</a:t>
             </a:r>
             <a:endParaRPr lang="en-US" sz="950" dirty="0"/>
           </a:p>

</xml_diff>